<commit_message>
Revised ppt + Windows 7 llm report
</commit_message>
<xml_diff>
--- a/TriageGuard Progress Evaluation.pptx
+++ b/TriageGuard Progress Evaluation.pptx
@@ -4,9 +4,6 @@
   <p:sldMasterIdLst>
     <p:sldMasterId id="2147483648" r:id="rId1"/>
   </p:sldMasterIdLst>
-  <p:notesMasterIdLst>
-    <p:notesMasterId r:id="rId12"/>
-  </p:notesMasterIdLst>
   <p:sldIdLst>
     <p:sldId id="256" r:id="rId2"/>
     <p:sldId id="257" r:id="rId3"/>
@@ -19,6 +16,9 @@
     <p:sldId id="264" r:id="rId10"/>
     <p:sldId id="265" r:id="rId11"/>
   </p:sldIdLst>
+  <p:notesMasterIdLst>
+    <p:notesMasterId r:id="rId12"/>
+  </p:notesMasterIdLst>
   <p:sldSz cx="12192000" cy="6858000"/>
   <p:notesSz cx="6858000" cy="12192000"/>
   <p:defaultTextStyle>
@@ -113,11 +113,6 @@
       </a:defRPr>
     </a:lvl9pPr>
   </p:defaultTextStyle>
-  <p:extLst>
-    <p:ext uri="{EFAFB233-063F-42B5-8137-9DF3F51BA10A}">
-      <p15:sldGuideLst xmlns:p15="http://schemas.microsoft.com/office/powerpoint/2012/main"/>
-    </p:ext>
-  </p:extLst>
 </p:presentation>
 </file>
 
@@ -143,10 +138,234 @@
           <a:chExt cx="0" cy="0"/>
         </a:xfrm>
       </p:grpSpPr>
+      <p:sp>
+        <p:nvSpPr>
+          <p:cNvPr id="2" name="Header Placeholder 1"/>
+          <p:cNvSpPr>
+            <a:spLocks noGrp="1"/>
+          </p:cNvSpPr>
+          <p:nvPr>
+            <p:ph type="hdr" sz="quarter"/>
+          </p:nvPr>
+        </p:nvSpPr>
+        <p:spPr>
+          <a:xfrm>
+            <a:off x="0" y="0"/>
+            <a:ext cx="2971800" cy="458788"/>
+          </a:xfrm>
+          <a:prstGeom prst="rect">
+            <a:avLst/>
+          </a:prstGeom>
+        </p:spPr>
+        <p:txBody>
+          <a:bodyPr vert="horz" lIns="91440" tIns="45720" rIns="91440" bIns="45720" rtlCol="0"/>
+          <a:lstStyle>
+            <a:lvl1pPr algn="l">
+              <a:defRPr sz="1200"/>
+            </a:lvl1pPr>
+          </a:lstStyle>
+          <a:p>
+            <a:endParaRPr lang="en-US"/>
+          </a:p>
+        </p:txBody>
+      </p:sp>
+      <p:sp>
+        <p:nvSpPr>
+          <p:cNvPr id="3" name="Date Placeholder 2"/>
+          <p:cNvSpPr>
+            <a:spLocks noGrp="1"/>
+          </p:cNvSpPr>
+          <p:nvPr>
+            <p:ph type="dt" idx="1"/>
+          </p:nvPr>
+        </p:nvSpPr>
+        <p:spPr>
+          <a:xfrm>
+            <a:off x="3884613" y="0"/>
+            <a:ext cx="2971800" cy="458788"/>
+          </a:xfrm>
+          <a:prstGeom prst="rect">
+            <a:avLst/>
+          </a:prstGeom>
+        </p:spPr>
+        <p:txBody>
+          <a:bodyPr vert="horz" lIns="91440" tIns="45720" rIns="91440" bIns="45720" rtlCol="0"/>
+          <a:lstStyle>
+            <a:lvl1pPr algn="r">
+              <a:defRPr sz="1200"/>
+            </a:lvl1pPr>
+          </a:lstStyle>
+          <a:p>
+            <a:fld id="{5282F153-3F37-0F45-9E97-73ACFA13230C}" type="datetimeFigureOut">
+              <a:rPr lang="en-US"/>
+              <a:t>7/23/19</a:t>
+            </a:fld>
+            <a:endParaRPr lang="en-US"/>
+          </a:p>
+        </p:txBody>
+      </p:sp>
+      <p:sp>
+        <p:nvSpPr>
+          <p:cNvPr id="4" name="Slide Image Placeholder 3"/>
+          <p:cNvSpPr>
+            <a:spLocks noGrp="1" noRot="1" noChangeAspect="1"/>
+          </p:cNvSpPr>
+          <p:nvPr>
+            <p:ph type="sldImg" idx="2"/>
+          </p:nvPr>
+        </p:nvSpPr>
+        <p:spPr>
+          <a:xfrm>
+            <a:off x="685800" y="1143000"/>
+            <a:ext cx="5486400" cy="3086100"/>
+          </a:xfrm>
+          <a:prstGeom prst="rect">
+            <a:avLst/>
+          </a:prstGeom>
+          <a:noFill/>
+          <a:ln w="12700">
+            <a:solidFill>
+              <a:prstClr val="black"/>
+            </a:solidFill>
+          </a:ln>
+        </p:spPr>
+        <p:txBody>
+          <a:bodyPr vert="horz" lIns="91440" tIns="45720" rIns="91440" bIns="45720" rtlCol="0" anchor="ctr"/>
+          <a:lstStyle/>
+          <a:p>
+            <a:endParaRPr lang="en-US"/>
+          </a:p>
+        </p:txBody>
+      </p:sp>
+      <p:sp>
+        <p:nvSpPr>
+          <p:cNvPr id="5" name="Notes Placeholder 4"/>
+          <p:cNvSpPr>
+            <a:spLocks noGrp="1"/>
+          </p:cNvSpPr>
+          <p:nvPr>
+            <p:ph type="body" sz="quarter" idx="3"/>
+          </p:nvPr>
+        </p:nvSpPr>
+        <p:spPr>
+          <a:xfrm>
+            <a:off x="685800" y="4400550"/>
+            <a:ext cx="5486400" cy="3600450"/>
+          </a:xfrm>
+          <a:prstGeom prst="rect">
+            <a:avLst/>
+          </a:prstGeom>
+        </p:spPr>
+        <p:txBody>
+          <a:bodyPr vert="horz" lIns="91440" tIns="45720" rIns="91440" bIns="45720" rtlCol="0"/>
+          <a:lstStyle/>
+          <a:p>
+            <a:pPr lvl="0"/>
+            <a:r>
+              <a:rPr lang="en-US"/>
+              <a:t>Click to edit Master text styles</a:t>
+            </a:r>
+          </a:p>
+          <a:p>
+            <a:pPr lvl="1"/>
+            <a:r>
+              <a:rPr lang="en-US"/>
+              <a:t>Second level</a:t>
+            </a:r>
+          </a:p>
+          <a:p>
+            <a:pPr lvl="2"/>
+            <a:r>
+              <a:rPr lang="en-US"/>
+              <a:t>Third level</a:t>
+            </a:r>
+          </a:p>
+          <a:p>
+            <a:pPr lvl="3"/>
+            <a:r>
+              <a:rPr lang="en-US"/>
+              <a:t>Fourth level</a:t>
+            </a:r>
+          </a:p>
+          <a:p>
+            <a:pPr lvl="4"/>
+            <a:r>
+              <a:rPr lang="en-US"/>
+              <a:t>Fifth level</a:t>
+            </a:r>
+          </a:p>
+        </p:txBody>
+      </p:sp>
+      <p:sp>
+        <p:nvSpPr>
+          <p:cNvPr id="6" name="Footer Placeholder 5"/>
+          <p:cNvSpPr>
+            <a:spLocks noGrp="1"/>
+          </p:cNvSpPr>
+          <p:nvPr>
+            <p:ph type="ftr" sz="quarter" idx="4"/>
+          </p:nvPr>
+        </p:nvSpPr>
+        <p:spPr>
+          <a:xfrm>
+            <a:off x="0" y="8685213"/>
+            <a:ext cx="2971800" cy="458787"/>
+          </a:xfrm>
+          <a:prstGeom prst="rect">
+            <a:avLst/>
+          </a:prstGeom>
+        </p:spPr>
+        <p:txBody>
+          <a:bodyPr vert="horz" lIns="91440" tIns="45720" rIns="91440" bIns="45720" rtlCol="0" anchor="b"/>
+          <a:lstStyle>
+            <a:lvl1pPr algn="l">
+              <a:defRPr sz="1200"/>
+            </a:lvl1pPr>
+          </a:lstStyle>
+          <a:p>
+            <a:endParaRPr lang="en-US"/>
+          </a:p>
+        </p:txBody>
+      </p:sp>
+      <p:sp>
+        <p:nvSpPr>
+          <p:cNvPr id="7" name="Slide Number Placeholder 6"/>
+          <p:cNvSpPr>
+            <a:spLocks noGrp="1"/>
+          </p:cNvSpPr>
+          <p:nvPr>
+            <p:ph type="sldNum" sz="quarter" idx="5"/>
+          </p:nvPr>
+        </p:nvSpPr>
+        <p:spPr>
+          <a:xfrm>
+            <a:off x="3884613" y="8685213"/>
+            <a:ext cx="2971800" cy="458787"/>
+          </a:xfrm>
+          <a:prstGeom prst="rect">
+            <a:avLst/>
+          </a:prstGeom>
+        </p:spPr>
+        <p:txBody>
+          <a:bodyPr vert="horz" lIns="91440" tIns="45720" rIns="91440" bIns="45720" rtlCol="0" anchor="b"/>
+          <a:lstStyle>
+            <a:lvl1pPr algn="r">
+              <a:defRPr sz="1200"/>
+            </a:lvl1pPr>
+          </a:lstStyle>
+          <a:p>
+            <a:fld id="{CE5E9CC1-C706-0F49-92D6-E571CC5EEA8F}" type="slidenum">
+              <a:rPr lang="en-US"/>
+              <a:t>‹#›</a:t>
+            </a:fld>
+            <a:endParaRPr lang="en-US"/>
+          </a:p>
+        </p:txBody>
+      </p:sp>
     </p:spTree>
     <p:extLst>
       <p:ext uri="{BB962C8B-B14F-4D97-AF65-F5344CB8AC3E}">
-        <p14:creationId xmlns:p14="http://schemas.microsoft.com/office/powerpoint/2010/main" val="4214962511"/>
+        <p14:creationId xmlns:p14="http://schemas.microsoft.com/office/powerpoint/2010/main" val="1024086991"/>
       </p:ext>
     </p:extLst>
   </p:cSld>
@@ -294,6 +513,7 @@
               <a:rPr lang="en-US" dirty="0"/>
               <a:t>Intro: TriageGuard takes a memory dump and an optional pcap, finds the cryptography in it, and writes an evidence-cited report. The lab leans towards cryptography, so crypto analysis is the core. Today: what is built, a real Windows 11 dump run, and the red-team results for the LLM report.</a:t>
             </a:r>
+            <a:endParaRPr lang="en-US" dirty="0"/>
           </a:p>
         </p:txBody>
       </p:sp>
@@ -379,8 +599,9 @@
           <a:p>
             <a:r>
               <a:rPr lang="en-US" dirty="0"/>
-              <a:t>Close with what is left: mostly write-ups, plus two improvements to make the red-team results stronger. Questions.</a:t>
-            </a:r>
+              <a:t>What is left: a ground-truth test of the crypto module with keys we control, a few more public dumps for variety, a stronger red team, and the write-ups.</a:t>
+            </a:r>
+            <a:endParaRPr lang="en-US" dirty="0"/>
           </a:p>
         </p:txBody>
       </p:sp>
@@ -468,6 +689,7 @@
               <a:rPr lang="en-US" dirty="0"/>
               <a:t>Walk the six stages left to right. Stress the last one: the LLM only receives structured findings, never raw dump bytes, and has to cite finding ids. That is what the defences later check.</a:t>
             </a:r>
+            <a:endParaRPr lang="en-US" dirty="0"/>
           </a:p>
         </p:txBody>
       </p:sp>
@@ -555,6 +777,7 @@
               <a:rPr lang="en-US" dirty="0"/>
               <a:t>This is the done list. Everything on the project brief except the write-ups is built and measured. The remaining items are on the last slide.</a:t>
             </a:r>
+            <a:endParaRPr lang="en-US" dirty="0"/>
           </a:p>
         </p:txBody>
       </p:sp>
@@ -642,6 +865,7 @@
               <a:rPr lang="en-US" dirty="0"/>
               <a:t>Cipher scope is wider than the basic AES, DES, RSA: ChaCha20/Salsa20, AES-GCM and ECC are included because modern ransomware often uses ChaCha with elliptic-curve key exchange. Each result says whether it rests on implementation constants (the cipher is really implemented) or only on API strings. Checked against real OpenSSL, libsodium and libgcrypt.</a:t>
             </a:r>
+            <a:endParaRPr lang="en-US" dirty="0"/>
           </a:p>
         </p:txBody>
       </p:sp>
@@ -729,6 +953,7 @@
               <a:rPr lang="en-US" dirty="0"/>
               <a:t>Three public images, three Windows versions, 32 and 64 bit. Windows 11: RSA-512 key and Notepad opening encryption_log.txt. Windows 10 (DFIR Madness Stolen Szechuan Sauce) is the most visual: a PE header injected into the print spooler and PowerShell with injected regions, and its real 188 MB pcap parsed (546 TLS handshakes, all strong suites). Windows 7 showed that identical code in many processes is a system-wide component, so those hits are medium, not high. Also say: Windows Defender blocked reading some extracted regions on the infected Windows 10 image, which the pipeline now records as a finding. Public data only, nothing executed.</a:t>
             </a:r>
+            <a:endParaRPr lang="en-US" dirty="0"/>
           </a:p>
         </p:txBody>
       </p:sp>
@@ -816,6 +1041,7 @@
               <a:rPr lang="en-US" dirty="0"/>
               <a:t>Each row is a real failure we hit on the real image that the synthetic sample never showed. The synthetic data was too clean: it has no cert store, no corrupt key fragments, no Defender JIT memory.</a:t>
             </a:r>
+            <a:endParaRPr lang="en-US" dirty="0"/>
           </a:p>
         </p:txBody>
       </p:sp>
@@ -903,6 +1129,7 @@
               <a:rPr lang="en-US" dirty="0"/>
               <a:t>The attacker controls fields the pipeline passes on to the LLM, for example the issuer claim in a JWT. The payloads are planted in a synthetic image, so ground truth is known. Each scenario runs three times without defences and three times with them.</a:t>
             </a:r>
+            <a:endParaRPr lang="en-US" dirty="0"/>
           </a:p>
         </p:txBody>
       </p:sp>
@@ -990,6 +1217,7 @@
               <a:rPr lang="en-US" dirty="0"/>
               <a:t>Attack success rate is the share of reports that did what the attacker wanted. 4 of 36 without defences, 1 of 36 with them, and none of the successful reports reached a reader without a validation warning. Citation coverage goes from 28 to 78 percent. The one defended success was an attack that failed undefended, which shows how noisy 6 trials are. All 78 reports and the CSV are saved in the repo. If asked: an earlier version of our checker only recognised square-bracket citations and the model sometimes writes fullwidth brackets, which inflated one attack; we fixed it and re-scored.</a:t>
             </a:r>
+            <a:endParaRPr lang="en-US" dirty="0"/>
           </a:p>
         </p:txBody>
       </p:sp>
@@ -1077,6 +1305,7 @@
               <a:rPr lang="en-US" dirty="0"/>
               <a:t>Be upfront about these. A cited claim can still be wrong, so the cross-check against the rule-based result matters. If asked about the checker: an earlier version only recognised square-bracket citations and the model sometimes writes fullwidth brackets; we fixed that and re-scored all 78 reports.</a:t>
             </a:r>
+            <a:endParaRPr lang="en-US" dirty="0"/>
           </a:p>
         </p:txBody>
       </p:sp>
@@ -1154,7 +1383,6 @@
         <a:solidFill>
           <a:srgbClr val="070A12"/>
         </a:solidFill>
-        <a:effectLst/>
       </p:bgPr>
     </p:bg>
     <p:spTree>
@@ -1174,9 +1402,7 @@
       <p:sp>
         <p:nvSpPr>
           <p:cNvPr id="2" name="Title Placeholder 1"/>
-          <p:cNvSpPr>
-            <a:spLocks noGrp="1"/>
-          </p:cNvSpPr>
+          <p:cNvSpPr/>
           <p:nvPr>
             <p:ph type="title"/>
           </p:nvPr>
@@ -1195,7 +1421,7 @@
         <p:txBody>
           <a:bodyPr wrap="square" lIns="0" tIns="0" rIns="0" bIns="0" rtlCol="0" anchor="t"/>
           <a:lstStyle>
-            <a:lvl1pPr marL="0" indent="0" algn="l">
+            <a:lvl1pPr algn="l" indent="0" marL="0">
               <a:lnSpc>
                 <a:spcPct val="115000"/>
               </a:lnSpc>
@@ -1211,7 +1437,7 @@
             </a:lvl1pPr>
           </a:lstStyle>
           <a:p>
-            <a:pPr marL="0" indent="0" algn="l">
+            <a:pPr algn="l" indent="0" marL="0">
               <a:lnSpc>
                 <a:spcPct val="115000"/>
               </a:lnSpc>
@@ -1224,11 +1450,9 @@
       <p:sp>
         <p:nvSpPr>
           <p:cNvPr id="3" name="Text Placeholder 2"/>
-          <p:cNvSpPr>
-            <a:spLocks noGrp="1"/>
-          </p:cNvSpPr>
+          <p:cNvSpPr/>
           <p:nvPr>
-            <p:ph type="body" idx="101"/>
+            <p:ph idx="101" type="body"/>
           </p:nvPr>
         </p:nvSpPr>
         <p:spPr>
@@ -1245,7 +1469,7 @@
         <p:txBody>
           <a:bodyPr wrap="square" lIns="0" tIns="0" rIns="0" bIns="0" rtlCol="0" anchor="t"/>
           <a:lstStyle>
-            <a:lvl1pPr marL="0" indent="0" algn="l">
+            <a:lvl1pPr algn="l" indent="0" marL="0">
               <a:lnSpc>
                 <a:spcPct val="140000"/>
               </a:lnSpc>
@@ -1261,7 +1485,7 @@
             </a:lvl1pPr>
           </a:lstStyle>
           <a:p>
-            <a:pPr marL="0" indent="0" algn="l">
+            <a:pPr algn="l" indent="0" marL="0">
               <a:lnSpc>
                 <a:spcPct val="140000"/>
               </a:lnSpc>
@@ -1287,7 +1511,6 @@
         <a:solidFill>
           <a:srgbClr val="070A12"/>
         </a:solidFill>
-        <a:effectLst/>
       </p:bgPr>
     </p:bg>
     <p:spTree>
@@ -1307,9 +1530,7 @@
       <p:sp>
         <p:nvSpPr>
           <p:cNvPr id="2" name="Title Placeholder 1"/>
-          <p:cNvSpPr>
-            <a:spLocks noGrp="1"/>
-          </p:cNvSpPr>
+          <p:cNvSpPr/>
           <p:nvPr>
             <p:ph type="title"/>
           </p:nvPr>
@@ -1328,7 +1549,7 @@
         <p:txBody>
           <a:bodyPr wrap="square" lIns="0" tIns="0" rIns="0" bIns="0" rtlCol="0" anchor="t"/>
           <a:lstStyle>
-            <a:lvl1pPr marL="0" indent="0" algn="l">
+            <a:lvl1pPr algn="l" indent="0" marL="0">
               <a:lnSpc>
                 <a:spcPct val="115000"/>
               </a:lnSpc>
@@ -1344,7 +1565,7 @@
             </a:lvl1pPr>
           </a:lstStyle>
           <a:p>
-            <a:pPr marL="0" indent="0" algn="l">
+            <a:pPr algn="l" indent="0" marL="0">
               <a:lnSpc>
                 <a:spcPct val="115000"/>
               </a:lnSpc>
@@ -1357,11 +1578,9 @@
       <p:sp>
         <p:nvSpPr>
           <p:cNvPr id="3" name="Text Placeholder 2"/>
-          <p:cNvSpPr>
-            <a:spLocks noGrp="1"/>
-          </p:cNvSpPr>
+          <p:cNvSpPr/>
           <p:nvPr>
-            <p:ph type="body" idx="101"/>
+            <p:ph idx="101" type="body"/>
           </p:nvPr>
         </p:nvSpPr>
         <p:spPr>
@@ -1378,7 +1597,7 @@
         <p:txBody>
           <a:bodyPr wrap="square" lIns="0" tIns="0" rIns="0" bIns="0" rtlCol="0" anchor="t"/>
           <a:lstStyle>
-            <a:lvl1pPr marL="0" indent="0" algn="l">
+            <a:lvl1pPr algn="l" indent="0" marL="0">
               <a:lnSpc>
                 <a:spcPct val="140000"/>
               </a:lnSpc>
@@ -1394,7 +1613,7 @@
             </a:lvl1pPr>
           </a:lstStyle>
           <a:p>
-            <a:pPr marL="0" indent="0" algn="l">
+            <a:pPr algn="l" indent="0" marL="0">
               <a:lnSpc>
                 <a:spcPct val="140000"/>
               </a:lnSpc>
@@ -1673,7 +1892,6 @@
         <a:solidFill>
           <a:srgbClr val="070A12"/>
         </a:solidFill>
-        <a:effectLst/>
       </p:bgPr>
     </p:bg>
     <p:spTree>
@@ -1720,13 +1938,6 @@
           </a:gradFill>
           <a:ln/>
         </p:spPr>
-        <p:txBody>
-          <a:bodyPr/>
-          <a:lstStyle/>
-          <a:p>
-            <a:endParaRPr lang="en-US"/>
-          </a:p>
-        </p:txBody>
       </p:sp>
       <p:sp>
         <p:nvSpPr>
@@ -1768,13 +1979,6 @@
           </a:gradFill>
           <a:ln/>
         </p:spPr>
-        <p:txBody>
-          <a:bodyPr/>
-          <a:lstStyle/>
-          <a:p>
-            <a:endParaRPr lang="en-US"/>
-          </a:p>
-        </p:txBody>
       </p:sp>
       <p:sp>
         <p:nvSpPr>
@@ -1816,13 +2020,6 @@
           </a:gradFill>
           <a:ln/>
         </p:spPr>
-        <p:txBody>
-          <a:bodyPr/>
-          <a:lstStyle/>
-          <a:p>
-            <a:endParaRPr lang="en-US"/>
-          </a:p>
-        </p:txBody>
       </p:sp>
       <p:sp>
         <p:nvSpPr>
@@ -1847,14 +2044,14 @@
           </a:bodyPr>
           <a:lstStyle/>
           <a:p>
-            <a:pPr marL="0" indent="0" algn="l">
+            <a:pPr algn="l" indent="0" marL="0">
               <a:lnSpc>
                 <a:spcPts val="2100"/>
               </a:lnSpc>
               <a:buNone/>
             </a:pPr>
             <a:r>
-              <a:rPr lang="en-US" sz="1500" b="1" kern="0" spc="300" dirty="0">
+              <a:rPr lang="en-US" sz="1500" b="1" spc="300" kern="0" dirty="0">
                 <a:solidFill>
                   <a:srgbClr val="5CCFC0"/>
                 </a:solidFill>
@@ -1871,9 +2068,7 @@
       <p:sp>
         <p:nvSpPr>
           <p:cNvPr id="6" name="Text 4"/>
-          <p:cNvSpPr>
-            <a:spLocks noGrp="1"/>
-          </p:cNvSpPr>
+          <p:cNvSpPr/>
           <p:nvPr>
             <p:ph type="title"/>
           </p:nvPr>
@@ -1895,7 +2090,7 @@
           </a:bodyPr>
           <a:lstStyle/>
           <a:p>
-            <a:pPr marL="0" indent="0" algn="l">
+            <a:pPr algn="l" indent="0" marL="0">
               <a:lnSpc>
                 <a:spcPts val="9975"/>
               </a:lnSpc>
@@ -1947,7 +2142,7 @@
           </a:bodyPr>
           <a:lstStyle/>
           <a:p>
-            <a:pPr marL="0" indent="0" algn="l">
+            <a:pPr algn="l" indent="0" marL="0">
               <a:lnSpc>
                 <a:spcPts val="3250"/>
               </a:lnSpc>
@@ -1997,13 +2192,6 @@
           </a:gradFill>
           <a:ln/>
         </p:spPr>
-        <p:txBody>
-          <a:bodyPr/>
-          <a:lstStyle/>
-          <a:p>
-            <a:endParaRPr lang="en-US"/>
-          </a:p>
-        </p:txBody>
       </p:sp>
       <p:sp>
         <p:nvSpPr>
@@ -2028,7 +2216,7 @@
           </a:bodyPr>
           <a:lstStyle/>
           <a:p>
-            <a:pPr marL="0" indent="0" algn="l">
+            <a:pPr algn="l" indent="0" marL="0">
               <a:lnSpc>
                 <a:spcPts val="2400"/>
               </a:lnSpc>
@@ -2048,7 +2236,7 @@
             <a:endParaRPr lang="en-US" sz="1600" dirty="0"/>
           </a:p>
           <a:p>
-            <a:pPr marL="0" indent="0" algn="l">
+            <a:pPr algn="l" indent="0" marL="0">
               <a:lnSpc>
                 <a:spcPts val="2400"/>
               </a:lnSpc>
@@ -2085,7 +2273,6 @@
         <a:solidFill>
           <a:srgbClr val="070A12"/>
         </a:solidFill>
-        <a:effectLst/>
       </p:bgPr>
     </p:bg>
     <p:spTree>
@@ -2132,13 +2319,6 @@
           </a:gradFill>
           <a:ln/>
         </p:spPr>
-        <p:txBody>
-          <a:bodyPr/>
-          <a:lstStyle/>
-          <a:p>
-            <a:endParaRPr lang="en-US"/>
-          </a:p>
-        </p:txBody>
       </p:sp>
       <p:sp>
         <p:nvSpPr>
@@ -2163,14 +2343,14 @@
           </a:bodyPr>
           <a:lstStyle/>
           <a:p>
-            <a:pPr marL="0" indent="0" algn="l">
+            <a:pPr algn="l" indent="0" marL="0">
               <a:lnSpc>
                 <a:spcPts val="1960"/>
               </a:lnSpc>
               <a:buNone/>
             </a:pPr>
             <a:r>
-              <a:rPr lang="en-US" sz="1400" b="1" kern="0" spc="250" dirty="0">
+              <a:rPr lang="en-US" sz="1400" b="1" spc="250" kern="0" dirty="0">
                 <a:solidFill>
                   <a:srgbClr val="5CCFC0"/>
                 </a:solidFill>
@@ -2187,9 +2367,7 @@
       <p:sp>
         <p:nvSpPr>
           <p:cNvPr id="4" name="Text 2"/>
-          <p:cNvSpPr>
-            <a:spLocks noGrp="1"/>
-          </p:cNvSpPr>
+          <p:cNvSpPr/>
           <p:nvPr>
             <p:ph type="title"/>
           </p:nvPr>
@@ -2211,7 +2389,7 @@
           </a:bodyPr>
           <a:lstStyle/>
           <a:p>
-            <a:pPr marL="0" indent="0" algn="l">
+            <a:pPr algn="l" indent="0" marL="0">
               <a:lnSpc>
                 <a:spcPts val="4180"/>
               </a:lnSpc>
@@ -2241,11 +2419,11 @@
         <p:spPr>
           <a:xfrm>
             <a:off x="815975" y="1951354"/>
-            <a:ext cx="5187950" cy="1037590"/>
+            <a:ext cx="3397250" cy="1517650"/>
           </a:xfrm>
           <a:prstGeom prst="roundRect">
             <a:avLst>
-              <a:gd name="adj" fmla="val 11934"/>
+              <a:gd name="adj" fmla="val 8159"/>
             </a:avLst>
           </a:prstGeom>
           <a:solidFill>
@@ -2262,13 +2440,6 @@
             <a:prstDash val="solid"/>
           </a:ln>
         </p:spPr>
-        <p:txBody>
-          <a:bodyPr/>
-          <a:lstStyle/>
-          <a:p>
-            <a:endParaRPr lang="en-US"/>
-          </a:p>
-        </p:txBody>
       </p:sp>
       <p:sp>
         <p:nvSpPr>
@@ -2279,7 +2450,7 @@
         <p:spPr>
           <a:xfrm>
             <a:off x="1021080" y="2156464"/>
-            <a:ext cx="4921072" cy="327660"/>
+            <a:ext cx="3076651" cy="309880"/>
           </a:xfrm>
           <a:prstGeom prst="rect">
             <a:avLst/>
@@ -2293,14 +2464,14 @@
           </a:bodyPr>
           <a:lstStyle/>
           <a:p>
-            <a:pPr marL="0" indent="0" algn="l">
+            <a:pPr algn="l" indent="0" marL="0">
               <a:lnSpc>
-                <a:spcPts val="2380"/>
+                <a:spcPts val="2240"/>
               </a:lnSpc>
               <a:buNone/>
             </a:pPr>
             <a:r>
-              <a:rPr lang="en-US" sz="1700" b="1" dirty="0">
+              <a:rPr lang="en-US" sz="1600" b="1" dirty="0">
                 <a:solidFill>
                   <a:srgbClr val="5CCFC0"/>
                 </a:solidFill>
@@ -2308,9 +2479,9 @@
                 <a:ea typeface="DM Sans" pitchFamily="34" charset="-122"/>
                 <a:cs typeface="DM Sans" pitchFamily="34" charset="-120"/>
               </a:rPr>
-              <a:t>Final report</a:t>
-            </a:r>
-            <a:endParaRPr lang="en-US" sz="1700" dirty="0"/>
+              <a:t>Ground-truth crypto test</a:t>
+            </a:r>
+            <a:endParaRPr lang="en-US" sz="1600" dirty="0"/>
           </a:p>
         </p:txBody>
       </p:sp>
@@ -2322,8 +2493,8 @@
         </p:nvSpPr>
         <p:spPr>
           <a:xfrm>
-            <a:off x="1021080" y="2534921"/>
-            <a:ext cx="4921072" cy="274320"/>
+            <a:off x="1021080" y="2517142"/>
+            <a:ext cx="3076651" cy="772160"/>
           </a:xfrm>
           <a:prstGeom prst="rect">
             <a:avLst/>
@@ -2337,7 +2508,7 @@
           </a:bodyPr>
           <a:lstStyle/>
           <a:p>
-            <a:pPr marL="0" indent="0" algn="l">
+            <a:pPr algn="l" indent="0" marL="0">
               <a:lnSpc>
                 <a:spcPts val="1960"/>
               </a:lnSpc>
@@ -2352,7 +2523,7 @@
                 <a:ea typeface="DM Sans" pitchFamily="34" charset="-122"/>
                 <a:cs typeface="DM Sans" pitchFamily="34" charset="-120"/>
               </a:rPr>
-              <a:t>Method, results and limits written up</a:t>
+              <a:t>Our own VM and known keys: measure what we find and the false alarms</a:t>
             </a:r>
             <a:endParaRPr lang="en-US" sz="1400" dirty="0"/>
           </a:p>
@@ -2366,12 +2537,12 @@
         </p:nvSpPr>
         <p:spPr>
           <a:xfrm>
-            <a:off x="6188075" y="1951354"/>
-            <a:ext cx="5187950" cy="1037590"/>
+            <a:off x="4397375" y="1951354"/>
+            <a:ext cx="3397250" cy="1517650"/>
           </a:xfrm>
           <a:prstGeom prst="roundRect">
             <a:avLst>
-              <a:gd name="adj" fmla="val 11934"/>
+              <a:gd name="adj" fmla="val 8159"/>
             </a:avLst>
           </a:prstGeom>
           <a:solidFill>
@@ -2388,13 +2559,6 @@
             <a:prstDash val="solid"/>
           </a:ln>
         </p:spPr>
-        <p:txBody>
-          <a:bodyPr/>
-          <a:lstStyle/>
-          <a:p>
-            <a:endParaRPr lang="en-US"/>
-          </a:p>
-        </p:txBody>
       </p:sp>
       <p:sp>
         <p:nvSpPr>
@@ -2404,8 +2568,8 @@
         </p:nvSpPr>
         <p:spPr>
           <a:xfrm>
-            <a:off x="6393180" y="2156464"/>
-            <a:ext cx="4921072" cy="327660"/>
+            <a:off x="4602480" y="2156464"/>
+            <a:ext cx="3076651" cy="309880"/>
           </a:xfrm>
           <a:prstGeom prst="rect">
             <a:avLst/>
@@ -2419,14 +2583,14 @@
           </a:bodyPr>
           <a:lstStyle/>
           <a:p>
-            <a:pPr marL="0" indent="0" algn="l">
+            <a:pPr algn="l" indent="0" marL="0">
               <a:lnSpc>
-                <a:spcPts val="2380"/>
+                <a:spcPts val="2240"/>
               </a:lnSpc>
               <a:buNone/>
             </a:pPr>
             <a:r>
-              <a:rPr lang="en-US" sz="1700" b="1" dirty="0">
+              <a:rPr lang="en-US" sz="1600" b="1" dirty="0">
                 <a:solidFill>
                   <a:srgbClr val="8FA8F0"/>
                 </a:solidFill>
@@ -2434,9 +2598,9 @@
                 <a:ea typeface="DM Sans" pitchFamily="34" charset="-122"/>
                 <a:cs typeface="DM Sans" pitchFamily="34" charset="-120"/>
               </a:rPr>
-              <a:t>Post-quantum paragraph</a:t>
-            </a:r>
-            <a:endParaRPr lang="en-US" sz="1700" dirty="0"/>
+              <a:t>More public dumps</a:t>
+            </a:r>
+            <a:endParaRPr lang="en-US" sz="1600" dirty="0"/>
           </a:p>
         </p:txBody>
       </p:sp>
@@ -2448,8 +2612,8 @@
         </p:nvSpPr>
         <p:spPr>
           <a:xfrm>
-            <a:off x="6393180" y="2534921"/>
-            <a:ext cx="4921072" cy="274320"/>
+            <a:off x="4602480" y="2517142"/>
+            <a:ext cx="3076651" cy="523240"/>
           </a:xfrm>
           <a:prstGeom prst="rect">
             <a:avLst/>
@@ -2463,7 +2627,7 @@
           </a:bodyPr>
           <a:lstStyle/>
           <a:p>
-            <a:pPr marL="0" indent="0" algn="l">
+            <a:pPr algn="l" indent="0" marL="0">
               <a:lnSpc>
                 <a:spcPts val="1960"/>
               </a:lnSpc>
@@ -2478,7 +2642,7 @@
                 <a:ea typeface="DM Sans" pitchFamily="34" charset="-122"/>
                 <a:cs typeface="DM Sans" pitchFamily="34" charset="-120"/>
               </a:rPr>
-              <a:t>ML-KEM and ML-DSA, discussion only</a:t>
+              <a:t>Ransomware-style Windows 10 or 11, and a Windows Server image</a:t>
             </a:r>
             <a:endParaRPr lang="en-US" sz="1400" dirty="0"/>
           </a:p>
@@ -2492,12 +2656,12 @@
         </p:nvSpPr>
         <p:spPr>
           <a:xfrm>
-            <a:off x="815975" y="3173096"/>
-            <a:ext cx="5187950" cy="1037590"/>
+            <a:off x="7978775" y="1951354"/>
+            <a:ext cx="3397250" cy="1517650"/>
           </a:xfrm>
           <a:prstGeom prst="roundRect">
             <a:avLst>
-              <a:gd name="adj" fmla="val 11934"/>
+              <a:gd name="adj" fmla="val 8159"/>
             </a:avLst>
           </a:prstGeom>
           <a:solidFill>
@@ -2514,13 +2678,6 @@
             <a:prstDash val="solid"/>
           </a:ln>
         </p:spPr>
-        <p:txBody>
-          <a:bodyPr/>
-          <a:lstStyle/>
-          <a:p>
-            <a:endParaRPr lang="en-US"/>
-          </a:p>
-        </p:txBody>
       </p:sp>
       <p:sp>
         <p:nvSpPr>
@@ -2530,8 +2687,8 @@
         </p:nvSpPr>
         <p:spPr>
           <a:xfrm>
-            <a:off x="1021080" y="3378200"/>
-            <a:ext cx="4921072" cy="327660"/>
+            <a:off x="8183880" y="2156464"/>
+            <a:ext cx="3076651" cy="309880"/>
           </a:xfrm>
           <a:prstGeom prst="rect">
             <a:avLst/>
@@ -2545,14 +2702,14 @@
           </a:bodyPr>
           <a:lstStyle/>
           <a:p>
-            <a:pPr marL="0" indent="0" algn="l">
+            <a:pPr algn="l" indent="0" marL="0">
               <a:lnSpc>
-                <a:spcPts val="2380"/>
+                <a:spcPts val="2240"/>
               </a:lnSpc>
               <a:buNone/>
             </a:pPr>
             <a:r>
-              <a:rPr lang="en-US" sz="1700" b="1" dirty="0">
+              <a:rPr lang="en-US" sz="1600" b="1" dirty="0">
                 <a:solidFill>
                   <a:srgbClr val="D9B650"/>
                 </a:solidFill>
@@ -2560,9 +2717,9 @@
                 <a:ea typeface="DM Sans" pitchFamily="34" charset="-122"/>
                 <a:cs typeface="DM Sans" pitchFamily="34" charset="-120"/>
               </a:rPr>
-              <a:t>Harder attacks</a:t>
-            </a:r>
-            <a:endParaRPr lang="en-US" sz="1700" dirty="0"/>
+              <a:t>Stronger red team</a:t>
+            </a:r>
+            <a:endParaRPr lang="en-US" sz="1600" dirty="0"/>
           </a:p>
         </p:txBody>
       </p:sp>
@@ -2574,8 +2731,8 @@
         </p:nvSpPr>
         <p:spPr>
           <a:xfrm>
-            <a:off x="1021080" y="3756664"/>
-            <a:ext cx="4921072" cy="274320"/>
+            <a:off x="8183880" y="2517142"/>
+            <a:ext cx="3076651" cy="523240"/>
           </a:xfrm>
           <a:prstGeom prst="rect">
             <a:avLst/>
@@ -2589,7 +2746,7 @@
           </a:bodyPr>
           <a:lstStyle/>
           <a:p>
-            <a:pPr marL="0" indent="0" algn="l">
+            <a:pPr algn="l" indent="0" marL="0">
               <a:lnSpc>
                 <a:spcPts val="1960"/>
               </a:lnSpc>
@@ -2604,7 +2761,7 @@
                 <a:ea typeface="DM Sans" pitchFamily="34" charset="-122"/>
                 <a:cs typeface="DM Sans" pitchFamily="34" charset="-120"/>
               </a:rPr>
-              <a:t>Several fields at once, no trigger words</a:t>
+              <a:t>Harder attacks, more trials, a second LLM</a:t>
             </a:r>
             <a:endParaRPr lang="en-US" sz="1400" dirty="0"/>
           </a:p>
@@ -2618,12 +2775,12 @@
         </p:nvSpPr>
         <p:spPr>
           <a:xfrm>
-            <a:off x="6188075" y="3173096"/>
-            <a:ext cx="5187950" cy="1037590"/>
+            <a:off x="815975" y="3653154"/>
+            <a:ext cx="3397250" cy="1268730"/>
           </a:xfrm>
           <a:prstGeom prst="roundRect">
             <a:avLst>
-              <a:gd name="adj" fmla="val 11934"/>
+              <a:gd name="adj" fmla="val 9760"/>
             </a:avLst>
           </a:prstGeom>
           <a:solidFill>
@@ -2640,13 +2797,6 @@
             <a:prstDash val="solid"/>
           </a:ln>
         </p:spPr>
-        <p:txBody>
-          <a:bodyPr/>
-          <a:lstStyle/>
-          <a:p>
-            <a:endParaRPr lang="en-US"/>
-          </a:p>
-        </p:txBody>
       </p:sp>
       <p:sp>
         <p:nvSpPr>
@@ -2656,8 +2806,8 @@
         </p:nvSpPr>
         <p:spPr>
           <a:xfrm>
-            <a:off x="6393180" y="3378200"/>
-            <a:ext cx="4921072" cy="327660"/>
+            <a:off x="1021080" y="3858264"/>
+            <a:ext cx="3076651" cy="309880"/>
           </a:xfrm>
           <a:prstGeom prst="rect">
             <a:avLst/>
@@ -2671,24 +2821,24 @@
           </a:bodyPr>
           <a:lstStyle/>
           <a:p>
-            <a:pPr marL="0" indent="0" algn="l">
+            <a:pPr algn="l" indent="0" marL="0">
               <a:lnSpc>
-                <a:spcPts val="2380"/>
+                <a:spcPts val="2240"/>
               </a:lnSpc>
               <a:buNone/>
             </a:pPr>
             <a:r>
-              <a:rPr lang="en-US" sz="1700" b="1" dirty="0">
+              <a:rPr lang="en-US" sz="1600" b="1" dirty="0">
                 <a:solidFill>
-                  <a:srgbClr val="8FA8F0"/>
+                  <a:srgbClr val="5CCFC0"/>
                 </a:solidFill>
                 <a:latin typeface="DM Sans" pitchFamily="34" charset="0"/>
                 <a:ea typeface="DM Sans" pitchFamily="34" charset="-122"/>
                 <a:cs typeface="DM Sans" pitchFamily="34" charset="-120"/>
               </a:rPr>
-              <a:t>Stronger numbers</a:t>
-            </a:r>
-            <a:endParaRPr lang="en-US" sz="1700" dirty="0"/>
+              <a:t>Final report</a:t>
+            </a:r>
+            <a:endParaRPr lang="en-US" sz="1600" dirty="0"/>
           </a:p>
         </p:txBody>
       </p:sp>
@@ -2700,8 +2850,8 @@
         </p:nvSpPr>
         <p:spPr>
           <a:xfrm>
-            <a:off x="6393180" y="3756664"/>
-            <a:ext cx="4921072" cy="274320"/>
+            <a:off x="1021080" y="4218942"/>
+            <a:ext cx="3076651" cy="523240"/>
           </a:xfrm>
           <a:prstGeom prst="rect">
             <a:avLst/>
@@ -2715,7 +2865,7 @@
           </a:bodyPr>
           <a:lstStyle/>
           <a:p>
-            <a:pPr marL="0" indent="0" algn="l">
+            <a:pPr algn="l" indent="0" marL="0">
               <a:lnSpc>
                 <a:spcPts val="1960"/>
               </a:lnSpc>
@@ -2730,7 +2880,7 @@
                 <a:ea typeface="DM Sans" pitchFamily="34" charset="-122"/>
                 <a:cs typeface="DM Sans" pitchFamily="34" charset="-120"/>
               </a:rPr>
-              <a:t>More trials per attack and a second LLM</a:t>
+              <a:t>Method, results and limits written up</a:t>
             </a:r>
             <a:endParaRPr lang="en-US" sz="1400" dirty="0"/>
           </a:p>
@@ -2744,7 +2894,126 @@
         </p:nvSpPr>
         <p:spPr>
           <a:xfrm>
-            <a:off x="812800" y="4467864"/>
+            <a:off x="4397375" y="3653154"/>
+            <a:ext cx="6978650" cy="1268730"/>
+          </a:xfrm>
+          <a:prstGeom prst="roundRect">
+            <a:avLst>
+              <a:gd name="adj" fmla="val 9760"/>
+            </a:avLst>
+          </a:prstGeom>
+          <a:solidFill>
+            <a:srgbClr val="FFFFFF">
+              <a:alpha val="5000"/>
+            </a:srgbClr>
+          </a:solidFill>
+          <a:ln w="6350">
+            <a:solidFill>
+              <a:srgbClr val="FFFFFF">
+                <a:alpha val="9000"/>
+              </a:srgbClr>
+            </a:solidFill>
+            <a:prstDash val="solid"/>
+          </a:ln>
+        </p:spPr>
+      </p:sp>
+      <p:sp>
+        <p:nvSpPr>
+          <p:cNvPr id="18" name="Text 16"/>
+          <p:cNvSpPr/>
+          <p:nvPr/>
+        </p:nvSpPr>
+        <p:spPr>
+          <a:xfrm>
+            <a:off x="4602480" y="3858264"/>
+            <a:ext cx="6765493" cy="309880"/>
+          </a:xfrm>
+          <a:prstGeom prst="rect">
+            <a:avLst/>
+          </a:prstGeom>
+          <a:noFill/>
+          <a:ln/>
+        </p:spPr>
+        <p:txBody>
+          <a:bodyPr wrap="square" lIns="0" tIns="0" rIns="0" bIns="0" rtlCol="0" anchor="t">
+            <a:normAutofit/>
+          </a:bodyPr>
+          <a:lstStyle/>
+          <a:p>
+            <a:pPr algn="l" indent="0" marL="0">
+              <a:lnSpc>
+                <a:spcPts val="2240"/>
+              </a:lnSpc>
+              <a:buNone/>
+            </a:pPr>
+            <a:r>
+              <a:rPr lang="en-US" sz="1600" b="1" dirty="0">
+                <a:solidFill>
+                  <a:srgbClr val="8FA8F0"/>
+                </a:solidFill>
+                <a:latin typeface="DM Sans" pitchFamily="34" charset="0"/>
+                <a:ea typeface="DM Sans" pitchFamily="34" charset="-122"/>
+                <a:cs typeface="DM Sans" pitchFamily="34" charset="-120"/>
+              </a:rPr>
+              <a:t>Post-quantum paragraph</a:t>
+            </a:r>
+            <a:endParaRPr lang="en-US" sz="1600" dirty="0"/>
+          </a:p>
+        </p:txBody>
+      </p:sp>
+      <p:sp>
+        <p:nvSpPr>
+          <p:cNvPr id="19" name="Text 17"/>
+          <p:cNvSpPr/>
+          <p:nvPr/>
+        </p:nvSpPr>
+        <p:spPr>
+          <a:xfrm>
+            <a:off x="4602480" y="4218942"/>
+            <a:ext cx="6765493" cy="274320"/>
+          </a:xfrm>
+          <a:prstGeom prst="rect">
+            <a:avLst/>
+          </a:prstGeom>
+          <a:noFill/>
+          <a:ln/>
+        </p:spPr>
+        <p:txBody>
+          <a:bodyPr wrap="square" lIns="0" tIns="0" rIns="0" bIns="0" rtlCol="0" anchor="t">
+            <a:normAutofit/>
+          </a:bodyPr>
+          <a:lstStyle/>
+          <a:p>
+            <a:pPr algn="l" indent="0" marL="0">
+              <a:lnSpc>
+                <a:spcPts val="1960"/>
+              </a:lnSpc>
+              <a:buNone/>
+            </a:pPr>
+            <a:r>
+              <a:rPr lang="en-US" sz="1400" dirty="0">
+                <a:solidFill>
+                  <a:srgbClr val="B4BDD6"/>
+                </a:solidFill>
+                <a:latin typeface="DM Sans" pitchFamily="34" charset="0"/>
+                <a:ea typeface="DM Sans" pitchFamily="34" charset="-122"/>
+                <a:cs typeface="DM Sans" pitchFamily="34" charset="-120"/>
+              </a:rPr>
+              <a:t>ML-KEM and ML-DSA, a discussion paragraph only</a:t>
+            </a:r>
+            <a:endParaRPr lang="en-US" sz="1400" dirty="0"/>
+          </a:p>
+        </p:txBody>
+      </p:sp>
+      <p:sp>
+        <p:nvSpPr>
+          <p:cNvPr id="20" name="Shape 18"/>
+          <p:cNvSpPr/>
+          <p:nvPr/>
+        </p:nvSpPr>
+        <p:spPr>
+          <a:xfrm>
+            <a:off x="812800" y="5179064"/>
             <a:ext cx="1651000" cy="50800"/>
           </a:xfrm>
           <a:prstGeom prst="roundRect">
@@ -2765,13 +3034,6 @@
           </a:gradFill>
           <a:ln/>
         </p:spPr>
-        <p:txBody>
-          <a:bodyPr/>
-          <a:lstStyle/>
-          <a:p>
-            <a:endParaRPr lang="en-US"/>
-          </a:p>
-        </p:txBody>
       </p:sp>
     </p:spTree>
   </p:cSld>
@@ -2789,7 +3051,6 @@
         <a:solidFill>
           <a:srgbClr val="070A12"/>
         </a:solidFill>
-        <a:effectLst/>
       </p:bgPr>
     </p:bg>
     <p:spTree>
@@ -2836,13 +3097,6 @@
           </a:gradFill>
           <a:ln/>
         </p:spPr>
-        <p:txBody>
-          <a:bodyPr/>
-          <a:lstStyle/>
-          <a:p>
-            <a:endParaRPr lang="en-US"/>
-          </a:p>
-        </p:txBody>
       </p:sp>
       <p:sp>
         <p:nvSpPr>
@@ -2867,14 +3121,14 @@
           </a:bodyPr>
           <a:lstStyle/>
           <a:p>
-            <a:pPr marL="0" indent="0" algn="l">
+            <a:pPr algn="l" indent="0" marL="0">
               <a:lnSpc>
                 <a:spcPts val="1960"/>
               </a:lnSpc>
               <a:buNone/>
             </a:pPr>
             <a:r>
-              <a:rPr lang="en-US" sz="1400" b="1" kern="0" spc="250" dirty="0">
+              <a:rPr lang="en-US" sz="1400" b="1" spc="250" kern="0" dirty="0">
                 <a:solidFill>
                   <a:srgbClr val="5CCFC0"/>
                 </a:solidFill>
@@ -2891,9 +3145,7 @@
       <p:sp>
         <p:nvSpPr>
           <p:cNvPr id="4" name="Text 2"/>
-          <p:cNvSpPr>
-            <a:spLocks noGrp="1"/>
-          </p:cNvSpPr>
+          <p:cNvSpPr/>
           <p:nvPr>
             <p:ph type="title"/>
           </p:nvPr>
@@ -2915,7 +3167,7 @@
           </a:bodyPr>
           <a:lstStyle/>
           <a:p>
-            <a:pPr marL="0" indent="0" algn="l">
+            <a:pPr algn="l" indent="0" marL="0">
               <a:lnSpc>
                 <a:spcPts val="4180"/>
               </a:lnSpc>
@@ -2966,13 +3218,6 @@
             <a:prstDash val="solid"/>
           </a:ln>
         </p:spPr>
-        <p:txBody>
-          <a:bodyPr/>
-          <a:lstStyle/>
-          <a:p>
-            <a:endParaRPr lang="en-US"/>
-          </a:p>
-        </p:txBody>
       </p:sp>
       <p:sp>
         <p:nvSpPr>
@@ -2997,7 +3242,7 @@
           </a:bodyPr>
           <a:lstStyle/>
           <a:p>
-            <a:pPr marL="0" indent="0" algn="l">
+            <a:pPr algn="l" indent="0" marL="0">
               <a:lnSpc>
                 <a:spcPts val="2100"/>
               </a:lnSpc>
@@ -3041,7 +3286,7 @@
           </a:bodyPr>
           <a:lstStyle/>
           <a:p>
-            <a:pPr marL="0" indent="0" algn="l">
+            <a:pPr algn="l" indent="0" marL="0">
               <a:lnSpc>
                 <a:spcPts val="2025"/>
               </a:lnSpc>
@@ -3092,13 +3337,6 @@
             <a:prstDash val="solid"/>
           </a:ln>
         </p:spPr>
-        <p:txBody>
-          <a:bodyPr/>
-          <a:lstStyle/>
-          <a:p>
-            <a:endParaRPr lang="en-US"/>
-          </a:p>
-        </p:txBody>
       </p:sp>
       <p:sp>
         <p:nvSpPr>
@@ -3123,7 +3361,7 @@
           </a:bodyPr>
           <a:lstStyle/>
           <a:p>
-            <a:pPr marL="0" indent="0" algn="l">
+            <a:pPr algn="l" indent="0" marL="0">
               <a:lnSpc>
                 <a:spcPts val="2100"/>
               </a:lnSpc>
@@ -3167,7 +3405,7 @@
           </a:bodyPr>
           <a:lstStyle/>
           <a:p>
-            <a:pPr marL="0" indent="0" algn="l">
+            <a:pPr algn="l" indent="0" marL="0">
               <a:lnSpc>
                 <a:spcPts val="2025"/>
               </a:lnSpc>
@@ -3218,13 +3456,6 @@
             <a:prstDash val="solid"/>
           </a:ln>
         </p:spPr>
-        <p:txBody>
-          <a:bodyPr/>
-          <a:lstStyle/>
-          <a:p>
-            <a:endParaRPr lang="en-US"/>
-          </a:p>
-        </p:txBody>
       </p:sp>
       <p:sp>
         <p:nvSpPr>
@@ -3249,7 +3480,7 @@
           </a:bodyPr>
           <a:lstStyle/>
           <a:p>
-            <a:pPr marL="0" indent="0" algn="l">
+            <a:pPr algn="l" indent="0" marL="0">
               <a:lnSpc>
                 <a:spcPts val="2100"/>
               </a:lnSpc>
@@ -3293,7 +3524,7 @@
           </a:bodyPr>
           <a:lstStyle/>
           <a:p>
-            <a:pPr marL="0" indent="0" algn="l">
+            <a:pPr algn="l" indent="0" marL="0">
               <a:lnSpc>
                 <a:spcPts val="2025"/>
               </a:lnSpc>
@@ -3344,13 +3575,6 @@
             <a:prstDash val="solid"/>
           </a:ln>
         </p:spPr>
-        <p:txBody>
-          <a:bodyPr/>
-          <a:lstStyle/>
-          <a:p>
-            <a:endParaRPr lang="en-US"/>
-          </a:p>
-        </p:txBody>
       </p:sp>
       <p:sp>
         <p:nvSpPr>
@@ -3375,7 +3599,7 @@
           </a:bodyPr>
           <a:lstStyle/>
           <a:p>
-            <a:pPr marL="0" indent="0" algn="l">
+            <a:pPr algn="l" indent="0" marL="0">
               <a:lnSpc>
                 <a:spcPts val="2100"/>
               </a:lnSpc>
@@ -3419,7 +3643,7 @@
           </a:bodyPr>
           <a:lstStyle/>
           <a:p>
-            <a:pPr marL="0" indent="0" algn="l">
+            <a:pPr algn="l" indent="0" marL="0">
               <a:lnSpc>
                 <a:spcPts val="2025"/>
               </a:lnSpc>
@@ -3470,13 +3694,6 @@
             <a:prstDash val="solid"/>
           </a:ln>
         </p:spPr>
-        <p:txBody>
-          <a:bodyPr/>
-          <a:lstStyle/>
-          <a:p>
-            <a:endParaRPr lang="en-US"/>
-          </a:p>
-        </p:txBody>
       </p:sp>
       <p:sp>
         <p:nvSpPr>
@@ -3501,7 +3718,7 @@
           </a:bodyPr>
           <a:lstStyle/>
           <a:p>
-            <a:pPr marL="0" indent="0" algn="l">
+            <a:pPr algn="l" indent="0" marL="0">
               <a:lnSpc>
                 <a:spcPts val="2100"/>
               </a:lnSpc>
@@ -3545,7 +3762,7 @@
           </a:bodyPr>
           <a:lstStyle/>
           <a:p>
-            <a:pPr marL="0" indent="0" algn="l">
+            <a:pPr algn="l" indent="0" marL="0">
               <a:lnSpc>
                 <a:spcPts val="2025"/>
               </a:lnSpc>
@@ -3596,13 +3813,6 @@
             <a:prstDash val="solid"/>
           </a:ln>
         </p:spPr>
-        <p:txBody>
-          <a:bodyPr/>
-          <a:lstStyle/>
-          <a:p>
-            <a:endParaRPr lang="en-US"/>
-          </a:p>
-        </p:txBody>
       </p:sp>
       <p:sp>
         <p:nvSpPr>
@@ -3627,7 +3837,7 @@
           </a:bodyPr>
           <a:lstStyle/>
           <a:p>
-            <a:pPr marL="0" indent="0" algn="l">
+            <a:pPr algn="l" indent="0" marL="0">
               <a:lnSpc>
                 <a:spcPts val="2100"/>
               </a:lnSpc>
@@ -3671,7 +3881,7 @@
           </a:bodyPr>
           <a:lstStyle/>
           <a:p>
-            <a:pPr marL="0" indent="0" algn="l">
+            <a:pPr algn="l" indent="0" marL="0">
               <a:lnSpc>
                 <a:spcPts val="2025"/>
               </a:lnSpc>
@@ -3715,7 +3925,7 @@
           </a:bodyPr>
           <a:lstStyle/>
           <a:p>
-            <a:pPr marL="0" indent="0" algn="l">
+            <a:pPr algn="l" indent="0" marL="0">
               <a:lnSpc>
                 <a:spcPts val="1680"/>
               </a:lnSpc>
@@ -3752,7 +3962,6 @@
         <a:solidFill>
           <a:srgbClr val="070A12"/>
         </a:solidFill>
-        <a:effectLst/>
       </p:bgPr>
     </p:bg>
     <p:spTree>
@@ -3799,13 +4008,6 @@
           </a:gradFill>
           <a:ln/>
         </p:spPr>
-        <p:txBody>
-          <a:bodyPr/>
-          <a:lstStyle/>
-          <a:p>
-            <a:endParaRPr lang="en-US"/>
-          </a:p>
-        </p:txBody>
       </p:sp>
       <p:sp>
         <p:nvSpPr>
@@ -3830,14 +4032,14 @@
           </a:bodyPr>
           <a:lstStyle/>
           <a:p>
-            <a:pPr marL="0" indent="0" algn="l">
+            <a:pPr algn="l" indent="0" marL="0">
               <a:lnSpc>
                 <a:spcPts val="1960"/>
               </a:lnSpc>
               <a:buNone/>
             </a:pPr>
             <a:r>
-              <a:rPr lang="en-US" sz="1400" b="1" kern="0" spc="250" dirty="0">
+              <a:rPr lang="en-US" sz="1400" b="1" spc="250" kern="0" dirty="0">
                 <a:solidFill>
                   <a:srgbClr val="5CCFC0"/>
                 </a:solidFill>
@@ -3854,9 +4056,7 @@
       <p:sp>
         <p:nvSpPr>
           <p:cNvPr id="4" name="Text 2"/>
-          <p:cNvSpPr>
-            <a:spLocks noGrp="1"/>
-          </p:cNvSpPr>
+          <p:cNvSpPr/>
           <p:nvPr>
             <p:ph type="title"/>
           </p:nvPr>
@@ -3878,7 +4078,7 @@
           </a:bodyPr>
           <a:lstStyle/>
           <a:p>
-            <a:pPr marL="0" indent="0" algn="l">
+            <a:pPr algn="l" indent="0" marL="0">
               <a:lnSpc>
                 <a:spcPts val="4180"/>
               </a:lnSpc>
@@ -3929,25 +4129,18 @@
             <a:prstDash val="solid"/>
           </a:ln>
         </p:spPr>
-        <p:txBody>
-          <a:bodyPr/>
-          <a:lstStyle/>
-          <a:p>
-            <a:endParaRPr lang="en-US"/>
-          </a:p>
-        </p:txBody>
       </p:sp>
       <p:pic>
         <p:nvPicPr>
-          <p:cNvPr id="6" name="Image 0" descr="CheckCircle"/>
+          <p:cNvPr id="6" name="Image 0" descr="CheckCircle">    </p:cNvPr>
           <p:cNvPicPr>
             <a:picLocks noChangeAspect="1"/>
           </p:cNvPicPr>
           <p:nvPr/>
         </p:nvPicPr>
         <p:blipFill>
-          <a:blip r:embed="rId3"/>
-          <a:srcRect/>
+          <a:blip r:embed="rId1"/>
+          <a:srcRect l="0" r="0" t="0" b="0"/>
           <a:stretch/>
         </p:blipFill>
         <p:spPr>
@@ -3983,7 +4176,7 @@
           </a:bodyPr>
           <a:lstStyle/>
           <a:p>
-            <a:pPr marL="0" indent="0" algn="l">
+            <a:pPr algn="l" indent="0" marL="0">
               <a:lnSpc>
                 <a:spcPts val="1958"/>
               </a:lnSpc>
@@ -4034,25 +4227,18 @@
             <a:prstDash val="solid"/>
           </a:ln>
         </p:spPr>
-        <p:txBody>
-          <a:bodyPr/>
-          <a:lstStyle/>
-          <a:p>
-            <a:endParaRPr lang="en-US"/>
-          </a:p>
-        </p:txBody>
       </p:sp>
       <p:pic>
         <p:nvPicPr>
-          <p:cNvPr id="9" name="Image 1" descr="CheckCircle"/>
+          <p:cNvPr id="9" name="Image 1" descr="CheckCircle">    </p:cNvPr>
           <p:cNvPicPr>
             <a:picLocks noChangeAspect="1"/>
           </p:cNvPicPr>
           <p:nvPr/>
         </p:nvPicPr>
         <p:blipFill>
-          <a:blip r:embed="rId3"/>
-          <a:srcRect/>
+          <a:blip r:embed="rId2"/>
+          <a:srcRect l="0" r="0" t="0" b="0"/>
           <a:stretch/>
         </p:blipFill>
         <p:spPr>
@@ -4088,7 +4274,7 @@
           </a:bodyPr>
           <a:lstStyle/>
           <a:p>
-            <a:pPr marL="0" indent="0" algn="l">
+            <a:pPr algn="l" indent="0" marL="0">
               <a:lnSpc>
                 <a:spcPts val="1958"/>
               </a:lnSpc>
@@ -4117,8 +4303,8 @@
         </p:nvSpPr>
         <p:spPr>
           <a:xfrm>
-            <a:off x="815975" y="3444876"/>
-            <a:ext cx="5187950" cy="613410"/>
+            <a:off x="815975" y="3444875"/>
+            <a:ext cx="5187950" cy="831215"/>
           </a:xfrm>
           <a:prstGeom prst="roundRect">
             <a:avLst>
@@ -4139,17 +4325,10 @@
             <a:prstDash val="solid"/>
           </a:ln>
         </p:spPr>
-        <p:txBody>
-          <a:bodyPr/>
-          <a:lstStyle/>
-          <a:p>
-            <a:endParaRPr lang="en-US"/>
-          </a:p>
-        </p:txBody>
       </p:sp>
       <p:pic>
         <p:nvPicPr>
-          <p:cNvPr id="12" name="Image 2" descr="CheckCircle"/>
+          <p:cNvPr id="12" name="Image 2" descr="CheckCircle">    </p:cNvPr>
           <p:cNvPicPr>
             <a:picLocks noChangeAspect="1"/>
           </p:cNvPicPr>
@@ -4157,7 +4336,7 @@
         </p:nvPicPr>
         <p:blipFill>
           <a:blip r:embed="rId3"/>
-          <a:srcRect/>
+          <a:srcRect l="0" r="0" t="0" b="0"/>
           <a:stretch/>
         </p:blipFill>
         <p:spPr>
@@ -4179,7 +4358,7 @@
         <p:spPr>
           <a:xfrm>
             <a:off x="1414780" y="3611880"/>
-            <a:ext cx="4528642" cy="446405"/>
+            <a:ext cx="4528642" cy="522605"/>
           </a:xfrm>
           <a:prstGeom prst="rect">
             <a:avLst/>
@@ -4189,11 +4368,11 @@
         </p:spPr>
         <p:txBody>
           <a:bodyPr wrap="square" lIns="0" tIns="0" rIns="0" bIns="0" rtlCol="0" anchor="t">
-            <a:normAutofit fontScale="92500"/>
+            <a:normAutofit/>
           </a:bodyPr>
           <a:lstStyle/>
           <a:p>
-            <a:pPr marL="0" indent="0" algn="l">
+            <a:pPr algn="l" indent="0" marL="0">
               <a:lnSpc>
                 <a:spcPts val="1958"/>
               </a:lnSpc>
@@ -4222,8 +4401,8 @@
         </p:nvSpPr>
         <p:spPr>
           <a:xfrm>
-            <a:off x="815975" y="4225289"/>
-            <a:ext cx="5187950" cy="579757"/>
+            <a:off x="815975" y="4409441"/>
+            <a:ext cx="5187950" cy="613410"/>
           </a:xfrm>
           <a:prstGeom prst="roundRect">
             <a:avLst>
@@ -4244,30 +4423,23 @@
             <a:prstDash val="solid"/>
           </a:ln>
         </p:spPr>
-        <p:txBody>
-          <a:bodyPr/>
-          <a:lstStyle/>
-          <a:p>
-            <a:endParaRPr lang="en-US"/>
-          </a:p>
-        </p:txBody>
       </p:sp>
       <p:pic>
         <p:nvPicPr>
-          <p:cNvPr id="15" name="Image 3" descr="CheckCircle"/>
+          <p:cNvPr id="15" name="Image 3" descr="CheckCircle">    </p:cNvPr>
           <p:cNvPicPr>
             <a:picLocks noChangeAspect="1"/>
           </p:cNvPicPr>
           <p:nvPr/>
         </p:nvPicPr>
         <p:blipFill>
-          <a:blip r:embed="rId3"/>
-          <a:srcRect/>
+          <a:blip r:embed="rId4"/>
+          <a:srcRect l="0" r="0" t="0" b="0"/>
           <a:stretch/>
         </p:blipFill>
         <p:spPr>
           <a:xfrm>
-            <a:off x="1008380" y="4386083"/>
+            <a:off x="1008380" y="4576445"/>
             <a:ext cx="279400" cy="279400"/>
           </a:xfrm>
           <a:prstGeom prst="rect">
@@ -4283,8 +4455,8 @@
         </p:nvSpPr>
         <p:spPr>
           <a:xfrm>
-            <a:off x="1414780" y="4374038"/>
-            <a:ext cx="4528642" cy="491809"/>
+            <a:off x="1414780" y="4591844"/>
+            <a:ext cx="4528642" cy="274003"/>
           </a:xfrm>
           <a:prstGeom prst="rect">
             <a:avLst/>
@@ -4298,7 +4470,7 @@
           </a:bodyPr>
           <a:lstStyle/>
           <a:p>
-            <a:pPr marL="0" indent="0" algn="l">
+            <a:pPr algn="l" indent="0" marL="0">
               <a:lnSpc>
                 <a:spcPts val="1958"/>
               </a:lnSpc>
@@ -4349,25 +4521,18 @@
             <a:prstDash val="solid"/>
           </a:ln>
         </p:spPr>
-        <p:txBody>
-          <a:bodyPr/>
-          <a:lstStyle/>
-          <a:p>
-            <a:endParaRPr lang="en-US"/>
-          </a:p>
-        </p:txBody>
       </p:sp>
       <p:pic>
         <p:nvPicPr>
-          <p:cNvPr id="18" name="Image 4" descr="CheckCircle"/>
+          <p:cNvPr id="18" name="Image 4" descr="CheckCircle">    </p:cNvPr>
           <p:cNvPicPr>
             <a:picLocks noChangeAspect="1"/>
           </p:cNvPicPr>
           <p:nvPr/>
         </p:nvPicPr>
         <p:blipFill>
-          <a:blip r:embed="rId3"/>
-          <a:srcRect/>
+          <a:blip r:embed="rId5"/>
+          <a:srcRect l="0" r="0" t="0" b="0"/>
           <a:stretch/>
         </p:blipFill>
         <p:spPr>
@@ -4403,7 +4568,7 @@
           </a:bodyPr>
           <a:lstStyle/>
           <a:p>
-            <a:pPr marL="0" indent="0" algn="l">
+            <a:pPr algn="l" indent="0" marL="0">
               <a:lnSpc>
                 <a:spcPts val="1958"/>
               </a:lnSpc>
@@ -4454,25 +4619,18 @@
             <a:prstDash val="solid"/>
           </a:ln>
         </p:spPr>
-        <p:txBody>
-          <a:bodyPr/>
-          <a:lstStyle/>
-          <a:p>
-            <a:endParaRPr lang="en-US"/>
-          </a:p>
-        </p:txBody>
       </p:sp>
       <p:pic>
         <p:nvPicPr>
-          <p:cNvPr id="21" name="Image 5" descr="CheckCircle"/>
+          <p:cNvPr id="21" name="Image 5" descr="CheckCircle">    </p:cNvPr>
           <p:cNvPicPr>
             <a:picLocks noChangeAspect="1"/>
           </p:cNvPicPr>
           <p:nvPr/>
         </p:nvPicPr>
         <p:blipFill>
-          <a:blip r:embed="rId3"/>
-          <a:srcRect/>
+          <a:blip r:embed="rId6"/>
+          <a:srcRect l="0" r="0" t="0" b="0"/>
           <a:stretch/>
         </p:blipFill>
         <p:spPr>
@@ -4508,7 +4666,7 @@
           </a:bodyPr>
           <a:lstStyle/>
           <a:p>
-            <a:pPr marL="0" indent="0" algn="l">
+            <a:pPr algn="l" indent="0" marL="0">
               <a:lnSpc>
                 <a:spcPts val="1958"/>
               </a:lnSpc>
@@ -4559,25 +4717,18 @@
             <a:prstDash val="solid"/>
           </a:ln>
         </p:spPr>
-        <p:txBody>
-          <a:bodyPr/>
-          <a:lstStyle/>
-          <a:p>
-            <a:endParaRPr lang="en-US"/>
-          </a:p>
-        </p:txBody>
       </p:sp>
       <p:pic>
         <p:nvPicPr>
-          <p:cNvPr id="24" name="Image 6" descr="CheckCircle"/>
+          <p:cNvPr id="24" name="Image 6" descr="CheckCircle">    </p:cNvPr>
           <p:cNvPicPr>
             <a:picLocks noChangeAspect="1"/>
           </p:cNvPicPr>
           <p:nvPr/>
         </p:nvPicPr>
         <p:blipFill>
-          <a:blip r:embed="rId3"/>
-          <a:srcRect/>
+          <a:blip r:embed="rId7"/>
+          <a:srcRect l="0" r="0" t="0" b="0"/>
           <a:stretch/>
         </p:blipFill>
         <p:spPr>
@@ -4613,7 +4764,7 @@
           </a:bodyPr>
           <a:lstStyle/>
           <a:p>
-            <a:pPr marL="0" indent="0" algn="l">
+            <a:pPr algn="l" indent="0" marL="0">
               <a:lnSpc>
                 <a:spcPts val="1958"/>
               </a:lnSpc>
@@ -4664,25 +4815,18 @@
             <a:prstDash val="solid"/>
           </a:ln>
         </p:spPr>
-        <p:txBody>
-          <a:bodyPr/>
-          <a:lstStyle/>
-          <a:p>
-            <a:endParaRPr lang="en-US"/>
-          </a:p>
-        </p:txBody>
       </p:sp>
       <p:pic>
         <p:nvPicPr>
-          <p:cNvPr id="27" name="Image 7" descr="CheckCircle"/>
+          <p:cNvPr id="27" name="Image 7" descr="CheckCircle">    </p:cNvPr>
           <p:cNvPicPr>
             <a:picLocks noChangeAspect="1"/>
           </p:cNvPicPr>
           <p:nvPr/>
         </p:nvPicPr>
         <p:blipFill>
-          <a:blip r:embed="rId3"/>
-          <a:srcRect/>
+          <a:blip r:embed="rId8"/>
+          <a:srcRect l="0" r="0" t="0" b="0"/>
           <a:stretch/>
         </p:blipFill>
         <p:spPr>
@@ -4718,7 +4862,7 @@
           </a:bodyPr>
           <a:lstStyle/>
           <a:p>
-            <a:pPr marL="0" indent="0" algn="l">
+            <a:pPr algn="l" indent="0" marL="0">
               <a:lnSpc>
                 <a:spcPts val="1958"/>
               </a:lnSpc>
@@ -4762,7 +4906,7 @@
           </a:bodyPr>
           <a:lstStyle/>
           <a:p>
-            <a:pPr marL="0" indent="0" algn="l">
+            <a:pPr algn="l" indent="0" marL="0">
               <a:lnSpc>
                 <a:spcPts val="1680"/>
               </a:lnSpc>
@@ -4799,7 +4943,6 @@
         <a:solidFill>
           <a:srgbClr val="070A12"/>
         </a:solidFill>
-        <a:effectLst/>
       </p:bgPr>
     </p:bg>
     <p:spTree>
@@ -4846,13 +4989,6 @@
           </a:gradFill>
           <a:ln/>
         </p:spPr>
-        <p:txBody>
-          <a:bodyPr/>
-          <a:lstStyle/>
-          <a:p>
-            <a:endParaRPr lang="en-US"/>
-          </a:p>
-        </p:txBody>
       </p:sp>
       <p:sp>
         <p:nvSpPr>
@@ -4877,14 +5013,14 @@
           </a:bodyPr>
           <a:lstStyle/>
           <a:p>
-            <a:pPr marL="0" indent="0" algn="l">
+            <a:pPr algn="l" indent="0" marL="0">
               <a:lnSpc>
                 <a:spcPts val="1960"/>
               </a:lnSpc>
               <a:buNone/>
             </a:pPr>
             <a:r>
-              <a:rPr lang="en-US" sz="1400" b="1" kern="0" spc="250" dirty="0">
+              <a:rPr lang="en-US" sz="1400" b="1" spc="250" kern="0" dirty="0">
                 <a:solidFill>
                   <a:srgbClr val="8FA8F0"/>
                 </a:solidFill>
@@ -4901,9 +5037,7 @@
       <p:sp>
         <p:nvSpPr>
           <p:cNvPr id="4" name="Text 2"/>
-          <p:cNvSpPr>
-            <a:spLocks noGrp="1"/>
-          </p:cNvSpPr>
+          <p:cNvSpPr/>
           <p:nvPr>
             <p:ph type="title"/>
           </p:nvPr>
@@ -4925,7 +5059,7 @@
           </a:bodyPr>
           <a:lstStyle/>
           <a:p>
-            <a:pPr marL="0" indent="0" algn="l">
+            <a:pPr algn="l" indent="0" marL="0">
               <a:lnSpc>
                 <a:spcPts val="4180"/>
               </a:lnSpc>
@@ -4976,13 +5110,6 @@
             <a:prstDash val="solid"/>
           </a:ln>
         </p:spPr>
-        <p:txBody>
-          <a:bodyPr/>
-          <a:lstStyle/>
-          <a:p>
-            <a:endParaRPr lang="en-US"/>
-          </a:p>
-        </p:txBody>
       </p:sp>
       <p:graphicFrame>
         <p:nvGraphicFramePr>
@@ -5000,27 +5127,15 @@
         </p:nvGraphicFramePr>
         <p:xfrm>
           <a:off x="1043940" y="2153921"/>
-          <a:ext cx="5662137" cy="3068320"/>
+          <a:ext cx="5662136" cy="3068320"/>
         </p:xfrm>
         <a:graphic>
           <a:graphicData uri="http://schemas.openxmlformats.org/drawingml/2006/table">
             <a:tbl>
               <a:tblPr/>
               <a:tblGrid>
-                <a:gridCol w="2151612">
-                  <a:extLst>
-                    <a:ext uri="{9D8B030D-6E8A-4147-A177-3AD203B41FA5}">
-                      <a16:colId xmlns:a16="http://schemas.microsoft.com/office/drawing/2014/main" val="20000"/>
-                    </a:ext>
-                  </a:extLst>
-                </a:gridCol>
-                <a:gridCol w="3510525">
-                  <a:extLst>
-                    <a:ext uri="{9D8B030D-6E8A-4147-A177-3AD203B41FA5}">
-                      <a16:colId xmlns:a16="http://schemas.microsoft.com/office/drawing/2014/main" val="20001"/>
-                    </a:ext>
-                  </a:extLst>
-                </a:gridCol>
+                <a:gridCol w="2151612"/>
+                <a:gridCol w="3510525"/>
               </a:tblGrid>
               <a:tr h="383540">
                 <a:tc>
@@ -5028,7 +5143,7 @@
                     <a:bodyPr/>
                     <a:lstStyle/>
                     <a:p>
-                      <a:pPr marL="0" indent="0">
+                      <a:pPr indent="0" marL="0">
                         <a:lnSpc>
                           <a:spcPts val="1960"/>
                         </a:lnSpc>
@@ -5052,7 +5167,7 @@
                       </a:endParaRPr>
                     </a:p>
                   </a:txBody>
-                  <a:tcPr marL="62230" marR="62230" marT="62230" marB="62230">
+                  <a:tcPr marL="62230" marR="62230" marT="62230" marB="62230" anchor="t">
                     <a:lnL w="12700" cap="flat" cmpd="sng" algn="ctr">
                       <a:solidFill>
                         <a:srgbClr val="46484D"/>
@@ -5099,7 +5214,7 @@
                     <a:bodyPr/>
                     <a:lstStyle/>
                     <a:p>
-                      <a:pPr marL="0" indent="0">
+                      <a:pPr indent="0" marL="0">
                         <a:lnSpc>
                           <a:spcPts val="1960"/>
                         </a:lnSpc>
@@ -5123,7 +5238,7 @@
                       </a:endParaRPr>
                     </a:p>
                   </a:txBody>
-                  <a:tcPr marL="62230" marR="62230" marT="62230" marB="62230">
+                  <a:tcPr marL="62230" marR="62230" marT="62230" marB="62230" anchor="t">
                     <a:lnL w="12700" cap="flat" cmpd="sng" algn="ctr">
                       <a:solidFill>
                         <a:srgbClr val="54565B"/>
@@ -5165,11 +5280,6 @@
                     </a:solidFill>
                   </a:tcPr>
                 </a:tc>
-                <a:extLst>
-                  <a:ext uri="{0D108BD9-81ED-4DB2-BD59-A6C34878D82A}">
-                    <a16:rowId xmlns:a16="http://schemas.microsoft.com/office/drawing/2014/main" val="10000"/>
-                  </a:ext>
-                </a:extLst>
               </a:tr>
               <a:tr h="383540">
                 <a:tc>
@@ -5177,7 +5287,7 @@
                     <a:bodyPr/>
                     <a:lstStyle/>
                     <a:p>
-                      <a:pPr marL="0" indent="0">
+                      <a:pPr indent="0" marL="0">
                         <a:lnSpc>
                           <a:spcPts val="1960"/>
                         </a:lnSpc>
@@ -5201,7 +5311,7 @@
                       </a:endParaRPr>
                     </a:p>
                   </a:txBody>
-                  <a:tcPr marL="62230" marR="62230" marT="62230" marB="62230">
+                  <a:tcPr marL="62230" marR="62230" marT="62230" marB="62230" anchor="t">
                     <a:lnL w="12700" cap="flat" cmpd="sng" algn="ctr">
                       <a:solidFill>
                         <a:srgbClr val="46484D"/>
@@ -5245,7 +5355,7 @@
                     <a:bodyPr/>
                     <a:lstStyle/>
                     <a:p>
-                      <a:pPr marL="0" indent="0">
+                      <a:pPr indent="0" marL="0">
                         <a:lnSpc>
                           <a:spcPts val="1960"/>
                         </a:lnSpc>
@@ -5269,7 +5379,7 @@
                       </a:endParaRPr>
                     </a:p>
                   </a:txBody>
-                  <a:tcPr marL="62230" marR="62230" marT="62230" marB="62230">
+                  <a:tcPr marL="62230" marR="62230" marT="62230" marB="62230" anchor="t">
                     <a:lnL w="12700" cap="flat" cmpd="sng" algn="ctr">
                       <a:solidFill>
                         <a:srgbClr val="46484D"/>
@@ -5308,11 +5418,6 @@
                     </a:lnB>
                   </a:tcPr>
                 </a:tc>
-                <a:extLst>
-                  <a:ext uri="{0D108BD9-81ED-4DB2-BD59-A6C34878D82A}">
-                    <a16:rowId xmlns:a16="http://schemas.microsoft.com/office/drawing/2014/main" val="10001"/>
-                  </a:ext>
-                </a:extLst>
               </a:tr>
               <a:tr h="383540">
                 <a:tc>
@@ -5320,7 +5425,7 @@
                     <a:bodyPr/>
                     <a:lstStyle/>
                     <a:p>
-                      <a:pPr marL="0" indent="0">
+                      <a:pPr indent="0" marL="0">
                         <a:lnSpc>
                           <a:spcPts val="1960"/>
                         </a:lnSpc>
@@ -5344,7 +5449,7 @@
                       </a:endParaRPr>
                     </a:p>
                   </a:txBody>
-                  <a:tcPr marL="62230" marR="62230" marT="62230" marB="62230">
+                  <a:tcPr marL="62230" marR="62230" marT="62230" marB="62230" anchor="t">
                     <a:lnL w="12700" cap="flat" cmpd="sng" algn="ctr">
                       <a:solidFill>
                         <a:srgbClr val="46484D"/>
@@ -5388,7 +5493,7 @@
                     <a:bodyPr/>
                     <a:lstStyle/>
                     <a:p>
-                      <a:pPr marL="0" indent="0">
+                      <a:pPr indent="0" marL="0">
                         <a:lnSpc>
                           <a:spcPts val="1960"/>
                         </a:lnSpc>
@@ -5412,7 +5517,7 @@
                       </a:endParaRPr>
                     </a:p>
                   </a:txBody>
-                  <a:tcPr marL="62230" marR="62230" marT="62230" marB="62230">
+                  <a:tcPr marL="62230" marR="62230" marT="62230" marB="62230" anchor="t">
                     <a:lnL w="12700" cap="flat" cmpd="sng" algn="ctr">
                       <a:solidFill>
                         <a:srgbClr val="46484D"/>
@@ -5451,11 +5556,6 @@
                     </a:lnB>
                   </a:tcPr>
                 </a:tc>
-                <a:extLst>
-                  <a:ext uri="{0D108BD9-81ED-4DB2-BD59-A6C34878D82A}">
-                    <a16:rowId xmlns:a16="http://schemas.microsoft.com/office/drawing/2014/main" val="10002"/>
-                  </a:ext>
-                </a:extLst>
               </a:tr>
               <a:tr h="383540">
                 <a:tc>
@@ -5463,7 +5563,7 @@
                     <a:bodyPr/>
                     <a:lstStyle/>
                     <a:p>
-                      <a:pPr marL="0" indent="0">
+                      <a:pPr indent="0" marL="0">
                         <a:lnSpc>
                           <a:spcPts val="1960"/>
                         </a:lnSpc>
@@ -5487,7 +5587,7 @@
                       </a:endParaRPr>
                     </a:p>
                   </a:txBody>
-                  <a:tcPr marL="62230" marR="62230" marT="62230" marB="62230">
+                  <a:tcPr marL="62230" marR="62230" marT="62230" marB="62230" anchor="t">
                     <a:lnL w="12700" cap="flat" cmpd="sng" algn="ctr">
                       <a:solidFill>
                         <a:srgbClr val="46484D"/>
@@ -5531,7 +5631,7 @@
                     <a:bodyPr/>
                     <a:lstStyle/>
                     <a:p>
-                      <a:pPr marL="0" indent="0">
+                      <a:pPr indent="0" marL="0">
                         <a:lnSpc>
                           <a:spcPts val="1960"/>
                         </a:lnSpc>
@@ -5555,7 +5655,7 @@
                       </a:endParaRPr>
                     </a:p>
                   </a:txBody>
-                  <a:tcPr marL="62230" marR="62230" marT="62230" marB="62230">
+                  <a:tcPr marL="62230" marR="62230" marT="62230" marB="62230" anchor="t">
                     <a:lnL w="12700" cap="flat" cmpd="sng" algn="ctr">
                       <a:solidFill>
                         <a:srgbClr val="46484D"/>
@@ -5594,11 +5694,6 @@
                     </a:lnB>
                   </a:tcPr>
                 </a:tc>
-                <a:extLst>
-                  <a:ext uri="{0D108BD9-81ED-4DB2-BD59-A6C34878D82A}">
-                    <a16:rowId xmlns:a16="http://schemas.microsoft.com/office/drawing/2014/main" val="10003"/>
-                  </a:ext>
-                </a:extLst>
               </a:tr>
               <a:tr h="383540">
                 <a:tc>
@@ -5606,7 +5701,7 @@
                     <a:bodyPr/>
                     <a:lstStyle/>
                     <a:p>
-                      <a:pPr marL="0" indent="0">
+                      <a:pPr indent="0" marL="0">
                         <a:lnSpc>
                           <a:spcPts val="1960"/>
                         </a:lnSpc>
@@ -5630,7 +5725,7 @@
                       </a:endParaRPr>
                     </a:p>
                   </a:txBody>
-                  <a:tcPr marL="62230" marR="62230" marT="62230" marB="62230">
+                  <a:tcPr marL="62230" marR="62230" marT="62230" marB="62230" anchor="t">
                     <a:lnL w="12700" cap="flat" cmpd="sng" algn="ctr">
                       <a:solidFill>
                         <a:srgbClr val="46484D"/>
@@ -5674,7 +5769,7 @@
                     <a:bodyPr/>
                     <a:lstStyle/>
                     <a:p>
-                      <a:pPr marL="0" indent="0">
+                      <a:pPr indent="0" marL="0">
                         <a:lnSpc>
                           <a:spcPts val="1960"/>
                         </a:lnSpc>
@@ -5698,7 +5793,7 @@
                       </a:endParaRPr>
                     </a:p>
                   </a:txBody>
-                  <a:tcPr marL="62230" marR="62230" marT="62230" marB="62230">
+                  <a:tcPr marL="62230" marR="62230" marT="62230" marB="62230" anchor="t">
                     <a:lnL w="12700" cap="flat" cmpd="sng" algn="ctr">
                       <a:solidFill>
                         <a:srgbClr val="46484D"/>
@@ -5737,11 +5832,6 @@
                     </a:lnB>
                   </a:tcPr>
                 </a:tc>
-                <a:extLst>
-                  <a:ext uri="{0D108BD9-81ED-4DB2-BD59-A6C34878D82A}">
-                    <a16:rowId xmlns:a16="http://schemas.microsoft.com/office/drawing/2014/main" val="10004"/>
-                  </a:ext>
-                </a:extLst>
               </a:tr>
               <a:tr h="383540">
                 <a:tc>
@@ -5749,7 +5839,7 @@
                     <a:bodyPr/>
                     <a:lstStyle/>
                     <a:p>
-                      <a:pPr marL="0" indent="0">
+                      <a:pPr indent="0" marL="0">
                         <a:lnSpc>
                           <a:spcPts val="1960"/>
                         </a:lnSpc>
@@ -5773,7 +5863,7 @@
                       </a:endParaRPr>
                     </a:p>
                   </a:txBody>
-                  <a:tcPr marL="62230" marR="62230" marT="62230" marB="62230">
+                  <a:tcPr marL="62230" marR="62230" marT="62230" marB="62230" anchor="t">
                     <a:lnL w="12700" cap="flat" cmpd="sng" algn="ctr">
                       <a:solidFill>
                         <a:srgbClr val="46484D"/>
@@ -5817,7 +5907,7 @@
                     <a:bodyPr/>
                     <a:lstStyle/>
                     <a:p>
-                      <a:pPr marL="0" indent="0">
+                      <a:pPr indent="0" marL="0">
                         <a:lnSpc>
                           <a:spcPts val="1960"/>
                         </a:lnSpc>
@@ -5841,7 +5931,7 @@
                       </a:endParaRPr>
                     </a:p>
                   </a:txBody>
-                  <a:tcPr marL="62230" marR="62230" marT="62230" marB="62230">
+                  <a:tcPr marL="62230" marR="62230" marT="62230" marB="62230" anchor="t">
                     <a:lnL w="12700" cap="flat" cmpd="sng" algn="ctr">
                       <a:solidFill>
                         <a:srgbClr val="46484D"/>
@@ -5880,11 +5970,6 @@
                     </a:lnB>
                   </a:tcPr>
                 </a:tc>
-                <a:extLst>
-                  <a:ext uri="{0D108BD9-81ED-4DB2-BD59-A6C34878D82A}">
-                    <a16:rowId xmlns:a16="http://schemas.microsoft.com/office/drawing/2014/main" val="10005"/>
-                  </a:ext>
-                </a:extLst>
               </a:tr>
               <a:tr h="383540">
                 <a:tc>
@@ -5892,7 +5977,7 @@
                     <a:bodyPr/>
                     <a:lstStyle/>
                     <a:p>
-                      <a:pPr marL="0" indent="0">
+                      <a:pPr indent="0" marL="0">
                         <a:lnSpc>
                           <a:spcPts val="1960"/>
                         </a:lnSpc>
@@ -5916,7 +6001,7 @@
                       </a:endParaRPr>
                     </a:p>
                   </a:txBody>
-                  <a:tcPr marL="62230" marR="62230" marT="62230" marB="62230">
+                  <a:tcPr marL="62230" marR="62230" marT="62230" marB="62230" anchor="t">
                     <a:lnL w="12700" cap="flat" cmpd="sng" algn="ctr">
                       <a:solidFill>
                         <a:srgbClr val="46484D"/>
@@ -5960,7 +6045,7 @@
                     <a:bodyPr/>
                     <a:lstStyle/>
                     <a:p>
-                      <a:pPr marL="0" indent="0">
+                      <a:pPr indent="0" marL="0">
                         <a:lnSpc>
                           <a:spcPts val="1960"/>
                         </a:lnSpc>
@@ -5984,7 +6069,7 @@
                       </a:endParaRPr>
                     </a:p>
                   </a:txBody>
-                  <a:tcPr marL="62230" marR="62230" marT="62230" marB="62230">
+                  <a:tcPr marL="62230" marR="62230" marT="62230" marB="62230" anchor="t">
                     <a:lnL w="12700" cap="flat" cmpd="sng" algn="ctr">
                       <a:solidFill>
                         <a:srgbClr val="46484D"/>
@@ -6023,11 +6108,6 @@
                     </a:lnB>
                   </a:tcPr>
                 </a:tc>
-                <a:extLst>
-                  <a:ext uri="{0D108BD9-81ED-4DB2-BD59-A6C34878D82A}">
-                    <a16:rowId xmlns:a16="http://schemas.microsoft.com/office/drawing/2014/main" val="10006"/>
-                  </a:ext>
-                </a:extLst>
               </a:tr>
               <a:tr h="383540">
                 <a:tc>
@@ -6035,7 +6115,7 @@
                     <a:bodyPr/>
                     <a:lstStyle/>
                     <a:p>
-                      <a:pPr marL="0" indent="0">
+                      <a:pPr indent="0" marL="0">
                         <a:lnSpc>
                           <a:spcPts val="1960"/>
                         </a:lnSpc>
@@ -6059,7 +6139,7 @@
                       </a:endParaRPr>
                     </a:p>
                   </a:txBody>
-                  <a:tcPr marL="62230" marR="62230" marT="62230" marB="62230">
+                  <a:tcPr marL="62230" marR="62230" marT="62230" marB="62230" anchor="t">
                     <a:lnL w="12700" cap="flat" cmpd="sng" algn="ctr">
                       <a:solidFill>
                         <a:srgbClr val="46484D"/>
@@ -6103,7 +6183,7 @@
                     <a:bodyPr/>
                     <a:lstStyle/>
                     <a:p>
-                      <a:pPr marL="0" indent="0">
+                      <a:pPr indent="0" marL="0">
                         <a:lnSpc>
                           <a:spcPts val="1960"/>
                         </a:lnSpc>
@@ -6127,7 +6207,7 @@
                       </a:endParaRPr>
                     </a:p>
                   </a:txBody>
-                  <a:tcPr marL="62230" marR="62230" marT="62230" marB="62230">
+                  <a:tcPr marL="62230" marR="62230" marT="62230" marB="62230" anchor="t">
                     <a:lnL w="12700" cap="flat" cmpd="sng" algn="ctr">
                       <a:solidFill>
                         <a:srgbClr val="46484D"/>
@@ -6166,11 +6246,6 @@
                     </a:lnB>
                   </a:tcPr>
                 </a:tc>
-                <a:extLst>
-                  <a:ext uri="{0D108BD9-81ED-4DB2-BD59-A6C34878D82A}">
-                    <a16:rowId xmlns:a16="http://schemas.microsoft.com/office/drawing/2014/main" val="10007"/>
-                  </a:ext>
-                </a:extLst>
               </a:tr>
             </a:tbl>
           </a:graphicData>
@@ -6216,13 +6291,6 @@
             <a:prstDash val="solid"/>
           </a:ln>
         </p:spPr>
-        <p:txBody>
-          <a:bodyPr/>
-          <a:lstStyle/>
-          <a:p>
-            <a:endParaRPr lang="en-US"/>
-          </a:p>
-        </p:txBody>
       </p:sp>
       <p:sp>
         <p:nvSpPr>
@@ -6247,7 +6315,7 @@
           </a:bodyPr>
           <a:lstStyle/>
           <a:p>
-            <a:pPr marL="0" indent="0" algn="l">
+            <a:pPr algn="l" indent="0" marL="0">
               <a:lnSpc>
                 <a:spcPts val="2400"/>
               </a:lnSpc>
@@ -6291,7 +6359,7 @@
           </a:bodyPr>
           <a:lstStyle/>
           <a:p>
-            <a:pPr marL="169418" indent="-169418" algn="l">
+            <a:pPr algn="l" marL="169418" indent="-169418">
               <a:lnSpc>
                 <a:spcPts val="2170"/>
               </a:lnSpc>
@@ -6312,7 +6380,7 @@
             <a:endParaRPr lang="en-US" sz="1400" dirty="0"/>
           </a:p>
           <a:p>
-            <a:pPr marL="169418" indent="-169418" algn="l">
+            <a:pPr algn="l" marL="169418" indent="-169418">
               <a:lnSpc>
                 <a:spcPts val="2170"/>
               </a:lnSpc>
@@ -6333,7 +6401,7 @@
             <a:endParaRPr lang="en-US" sz="1400" dirty="0"/>
           </a:p>
           <a:p>
-            <a:pPr marL="169418" indent="-169418" algn="l">
+            <a:pPr algn="l" marL="169418" indent="-169418">
               <a:lnSpc>
                 <a:spcPts val="2170"/>
               </a:lnSpc>
@@ -6354,7 +6422,7 @@
             <a:endParaRPr lang="en-US" sz="1400" dirty="0"/>
           </a:p>
           <a:p>
-            <a:pPr marL="169418" indent="-169418" algn="l">
+            <a:pPr algn="l" marL="169418" indent="-169418">
               <a:lnSpc>
                 <a:spcPts val="2170"/>
               </a:lnSpc>
@@ -6375,7 +6443,7 @@
             <a:endParaRPr lang="en-US" sz="1400" dirty="0"/>
           </a:p>
           <a:p>
-            <a:pPr marL="169418" indent="-169418" algn="l">
+            <a:pPr algn="l" marL="169418" indent="-169418">
               <a:lnSpc>
                 <a:spcPts val="2170"/>
               </a:lnSpc>
@@ -6420,7 +6488,7 @@
           </a:bodyPr>
           <a:lstStyle/>
           <a:p>
-            <a:pPr marL="0" indent="0" algn="l">
+            <a:pPr algn="l" indent="0" marL="0">
               <a:lnSpc>
                 <a:spcPts val="1960"/>
               </a:lnSpc>
@@ -6464,7 +6532,7 @@
           </a:bodyPr>
           <a:lstStyle/>
           <a:p>
-            <a:pPr marL="0" indent="0" algn="l">
+            <a:pPr algn="l" indent="0" marL="0">
               <a:lnSpc>
                 <a:spcPts val="1680"/>
               </a:lnSpc>
@@ -6501,7 +6569,6 @@
         <a:solidFill>
           <a:srgbClr val="0B1220"/>
         </a:solidFill>
-        <a:effectLst/>
       </p:bgPr>
     </p:bg>
     <p:spTree>
@@ -6548,13 +6615,6 @@
           </a:gradFill>
           <a:ln/>
         </p:spPr>
-        <p:txBody>
-          <a:bodyPr/>
-          <a:lstStyle/>
-          <a:p>
-            <a:endParaRPr lang="en-US"/>
-          </a:p>
-        </p:txBody>
       </p:sp>
       <p:sp>
         <p:nvSpPr>
@@ -6579,14 +6639,14 @@
           </a:bodyPr>
           <a:lstStyle/>
           <a:p>
-            <a:pPr marL="0" indent="0" algn="l">
+            <a:pPr algn="l" indent="0" marL="0">
               <a:lnSpc>
                 <a:spcPts val="1960"/>
               </a:lnSpc>
               <a:buNone/>
             </a:pPr>
             <a:r>
-              <a:rPr lang="en-US" sz="1400" b="1" kern="0" spc="250" dirty="0">
+              <a:rPr lang="en-US" sz="1400" b="1" spc="250" kern="0" dirty="0">
                 <a:solidFill>
                   <a:srgbClr val="5CCFC0"/>
                 </a:solidFill>
@@ -6603,9 +6663,7 @@
       <p:sp>
         <p:nvSpPr>
           <p:cNvPr id="4" name="Text 2"/>
-          <p:cNvSpPr>
-            <a:spLocks noGrp="1"/>
-          </p:cNvSpPr>
+          <p:cNvSpPr/>
           <p:nvPr>
             <p:ph type="title"/>
           </p:nvPr>
@@ -6627,7 +6685,7 @@
           </a:bodyPr>
           <a:lstStyle/>
           <a:p>
-            <a:pPr marL="0" indent="0" algn="l">
+            <a:pPr algn="l" indent="0" marL="0">
               <a:lnSpc>
                 <a:spcPts val="4180"/>
               </a:lnSpc>
@@ -6678,13 +6736,6 @@
             <a:prstDash val="solid"/>
           </a:ln>
         </p:spPr>
-        <p:txBody>
-          <a:bodyPr/>
-          <a:lstStyle/>
-          <a:p>
-            <a:endParaRPr lang="en-US"/>
-          </a:p>
-        </p:txBody>
       </p:sp>
       <p:sp>
         <p:nvSpPr>
@@ -6709,7 +6760,7 @@
           </a:bodyPr>
           <a:lstStyle/>
           <a:p>
-            <a:pPr marL="0" indent="0" algn="l">
+            <a:pPr algn="l" indent="0" marL="0">
               <a:lnSpc>
                 <a:spcPts val="2520"/>
               </a:lnSpc>
@@ -6753,7 +6804,7 @@
           </a:bodyPr>
           <a:lstStyle/>
           <a:p>
-            <a:pPr marL="0" indent="0" algn="l">
+            <a:pPr algn="l" indent="0" marL="0">
               <a:lnSpc>
                 <a:spcPts val="1620"/>
               </a:lnSpc>
@@ -6797,7 +6848,7 @@
           </a:bodyPr>
           <a:lstStyle/>
           <a:p>
-            <a:pPr marL="0" indent="0" algn="l">
+            <a:pPr algn="l" indent="0" marL="0">
               <a:lnSpc>
                 <a:spcPts val="3990"/>
               </a:lnSpc>
@@ -6841,7 +6892,7 @@
           </a:bodyPr>
           <a:lstStyle/>
           <a:p>
-            <a:pPr marL="0" indent="0" algn="l">
+            <a:pPr algn="l" indent="0" marL="0">
               <a:lnSpc>
                 <a:spcPts val="1680"/>
               </a:lnSpc>
@@ -6885,7 +6936,7 @@
           </a:bodyPr>
           <a:lstStyle/>
           <a:p>
-            <a:pPr marL="0" indent="0" algn="l">
+            <a:pPr algn="l" indent="0" marL="0">
               <a:lnSpc>
                 <a:spcPts val="3990"/>
               </a:lnSpc>
@@ -6929,7 +6980,7 @@
           </a:bodyPr>
           <a:lstStyle/>
           <a:p>
-            <a:pPr marL="0" indent="0" algn="l">
+            <a:pPr algn="l" indent="0" marL="0">
               <a:lnSpc>
                 <a:spcPts val="1680"/>
               </a:lnSpc>
@@ -6973,7 +7024,7 @@
           </a:bodyPr>
           <a:lstStyle/>
           <a:p>
-            <a:pPr marL="0" indent="0" algn="l">
+            <a:pPr algn="l" indent="0" marL="0">
               <a:lnSpc>
                 <a:spcPts val="1820"/>
               </a:lnSpc>
@@ -7024,13 +7075,6 @@
             <a:prstDash val="solid"/>
           </a:ln>
         </p:spPr>
-        <p:txBody>
-          <a:bodyPr/>
-          <a:lstStyle/>
-          <a:p>
-            <a:endParaRPr lang="en-US"/>
-          </a:p>
-        </p:txBody>
       </p:sp>
       <p:sp>
         <p:nvSpPr>
@@ -7055,7 +7099,7 @@
           </a:bodyPr>
           <a:lstStyle/>
           <a:p>
-            <a:pPr marL="0" indent="0" algn="l">
+            <a:pPr algn="l" indent="0" marL="0">
               <a:lnSpc>
                 <a:spcPts val="2520"/>
               </a:lnSpc>
@@ -7099,7 +7143,7 @@
           </a:bodyPr>
           <a:lstStyle/>
           <a:p>
-            <a:pPr marL="0" indent="0" algn="l">
+            <a:pPr algn="l" indent="0" marL="0">
               <a:lnSpc>
                 <a:spcPts val="1620"/>
               </a:lnSpc>
@@ -7143,7 +7187,7 @@
           </a:bodyPr>
           <a:lstStyle/>
           <a:p>
-            <a:pPr marL="0" indent="0" algn="l">
+            <a:pPr algn="l" indent="0" marL="0">
               <a:lnSpc>
                 <a:spcPts val="3990"/>
               </a:lnSpc>
@@ -7187,7 +7231,7 @@
           </a:bodyPr>
           <a:lstStyle/>
           <a:p>
-            <a:pPr marL="0" indent="0" algn="l">
+            <a:pPr algn="l" indent="0" marL="0">
               <a:lnSpc>
                 <a:spcPts val="1680"/>
               </a:lnSpc>
@@ -7231,7 +7275,7 @@
           </a:bodyPr>
           <a:lstStyle/>
           <a:p>
-            <a:pPr marL="0" indent="0" algn="l">
+            <a:pPr algn="l" indent="0" marL="0">
               <a:lnSpc>
                 <a:spcPts val="3990"/>
               </a:lnSpc>
@@ -7275,7 +7319,7 @@
           </a:bodyPr>
           <a:lstStyle/>
           <a:p>
-            <a:pPr marL="0" indent="0" algn="l">
+            <a:pPr algn="l" indent="0" marL="0">
               <a:lnSpc>
                 <a:spcPts val="1680"/>
               </a:lnSpc>
@@ -7319,7 +7363,7 @@
           </a:bodyPr>
           <a:lstStyle/>
           <a:p>
-            <a:pPr marL="0" indent="0" algn="l">
+            <a:pPr algn="l" indent="0" marL="0">
               <a:lnSpc>
                 <a:spcPts val="1820"/>
               </a:lnSpc>
@@ -7370,13 +7414,6 @@
             <a:prstDash val="solid"/>
           </a:ln>
         </p:spPr>
-        <p:txBody>
-          <a:bodyPr/>
-          <a:lstStyle/>
-          <a:p>
-            <a:endParaRPr lang="en-US"/>
-          </a:p>
-        </p:txBody>
       </p:sp>
       <p:sp>
         <p:nvSpPr>
@@ -7401,7 +7438,7 @@
           </a:bodyPr>
           <a:lstStyle/>
           <a:p>
-            <a:pPr marL="0" indent="0" algn="l">
+            <a:pPr algn="l" indent="0" marL="0">
               <a:lnSpc>
                 <a:spcPts val="2520"/>
               </a:lnSpc>
@@ -7445,7 +7482,7 @@
           </a:bodyPr>
           <a:lstStyle/>
           <a:p>
-            <a:pPr marL="0" indent="0" algn="l">
+            <a:pPr algn="l" indent="0" marL="0">
               <a:lnSpc>
                 <a:spcPts val="1620"/>
               </a:lnSpc>
@@ -7489,7 +7526,7 @@
           </a:bodyPr>
           <a:lstStyle/>
           <a:p>
-            <a:pPr marL="0" indent="0" algn="l">
+            <a:pPr algn="l" indent="0" marL="0">
               <a:lnSpc>
                 <a:spcPts val="3990"/>
               </a:lnSpc>
@@ -7533,7 +7570,7 @@
           </a:bodyPr>
           <a:lstStyle/>
           <a:p>
-            <a:pPr marL="0" indent="0" algn="l">
+            <a:pPr algn="l" indent="0" marL="0">
               <a:lnSpc>
                 <a:spcPts val="1680"/>
               </a:lnSpc>
@@ -7577,7 +7614,7 @@
           </a:bodyPr>
           <a:lstStyle/>
           <a:p>
-            <a:pPr marL="0" indent="0" algn="l">
+            <a:pPr algn="l" indent="0" marL="0">
               <a:lnSpc>
                 <a:spcPts val="3990"/>
               </a:lnSpc>
@@ -7621,7 +7658,7 @@
           </a:bodyPr>
           <a:lstStyle/>
           <a:p>
-            <a:pPr marL="0" indent="0" algn="l">
+            <a:pPr algn="l" indent="0" marL="0">
               <a:lnSpc>
                 <a:spcPts val="1680"/>
               </a:lnSpc>
@@ -7665,7 +7702,7 @@
           </a:bodyPr>
           <a:lstStyle/>
           <a:p>
-            <a:pPr marL="0" indent="0" algn="l">
+            <a:pPr algn="l" indent="0" marL="0">
               <a:lnSpc>
                 <a:spcPts val="1820"/>
               </a:lnSpc>
@@ -7709,7 +7746,7 @@
           </a:bodyPr>
           <a:lstStyle/>
           <a:p>
-            <a:pPr marL="0" indent="0" algn="l">
+            <a:pPr algn="l" indent="0" marL="0">
               <a:lnSpc>
                 <a:spcPts val="1680"/>
               </a:lnSpc>
@@ -7746,7 +7783,6 @@
         <a:solidFill>
           <a:srgbClr val="070A12"/>
         </a:solidFill>
-        <a:effectLst/>
       </p:bgPr>
     </p:bg>
     <p:spTree>
@@ -7793,13 +7829,6 @@
           </a:gradFill>
           <a:ln/>
         </p:spPr>
-        <p:txBody>
-          <a:bodyPr/>
-          <a:lstStyle/>
-          <a:p>
-            <a:endParaRPr lang="en-US"/>
-          </a:p>
-        </p:txBody>
       </p:sp>
       <p:sp>
         <p:nvSpPr>
@@ -7824,14 +7853,14 @@
           </a:bodyPr>
           <a:lstStyle/>
           <a:p>
-            <a:pPr marL="0" indent="0" algn="l">
+            <a:pPr algn="l" indent="0" marL="0">
               <a:lnSpc>
                 <a:spcPts val="1923"/>
               </a:lnSpc>
               <a:buNone/>
             </a:pPr>
             <a:r>
-              <a:rPr lang="en-US" sz="1374" b="1" kern="0" spc="250" dirty="0">
+              <a:rPr lang="en-US" sz="1374" b="1" spc="250" kern="0" dirty="0">
                 <a:solidFill>
                   <a:srgbClr val="D9B650"/>
                 </a:solidFill>
@@ -7848,9 +7877,7 @@
       <p:sp>
         <p:nvSpPr>
           <p:cNvPr id="4" name="Text 2"/>
-          <p:cNvSpPr>
-            <a:spLocks noGrp="1"/>
-          </p:cNvSpPr>
+          <p:cNvSpPr/>
           <p:nvPr>
             <p:ph type="title"/>
           </p:nvPr>
@@ -7872,7 +7899,7 @@
           </a:bodyPr>
           <a:lstStyle/>
           <a:p>
-            <a:pPr marL="0" indent="0" algn="l">
+            <a:pPr algn="l" indent="0" marL="0">
               <a:lnSpc>
                 <a:spcPts val="4023"/>
               </a:lnSpc>
@@ -7923,13 +7950,6 @@
             <a:prstDash val="solid"/>
           </a:ln>
         </p:spPr>
-        <p:txBody>
-          <a:bodyPr/>
-          <a:lstStyle/>
-          <a:p>
-            <a:endParaRPr lang="en-US"/>
-          </a:p>
-        </p:txBody>
       </p:sp>
       <p:graphicFrame>
         <p:nvGraphicFramePr>
@@ -7947,27 +7967,15 @@
         </p:nvGraphicFramePr>
         <p:xfrm>
           <a:off x="1056640" y="2120741"/>
-          <a:ext cx="10088880" cy="2583258"/>
+          <a:ext cx="10088880" cy="2583259"/>
         </p:xfrm>
         <a:graphic>
           <a:graphicData uri="http://schemas.openxmlformats.org/drawingml/2006/table">
             <a:tbl>
               <a:tblPr/>
               <a:tblGrid>
-                <a:gridCol w="4439107">
-                  <a:extLst>
-                    <a:ext uri="{9D8B030D-6E8A-4147-A177-3AD203B41FA5}">
-                      <a16:colId xmlns:a16="http://schemas.microsoft.com/office/drawing/2014/main" val="20000"/>
-                    </a:ext>
-                  </a:extLst>
-                </a:gridCol>
-                <a:gridCol w="5649773">
-                  <a:extLst>
-                    <a:ext uri="{9D8B030D-6E8A-4147-A177-3AD203B41FA5}">
-                      <a16:colId xmlns:a16="http://schemas.microsoft.com/office/drawing/2014/main" val="20001"/>
-                    </a:ext>
-                  </a:extLst>
-                </a:gridCol>
+                <a:gridCol w="4439107"/>
+                <a:gridCol w="5649773"/>
               </a:tblGrid>
               <a:tr h="369014">
                 <a:tc>
@@ -7975,7 +7983,7 @@
                     <a:bodyPr/>
                     <a:lstStyle/>
                     <a:p>
-                      <a:pPr marL="0" indent="0">
+                      <a:pPr indent="0" marL="0">
                         <a:lnSpc>
                           <a:spcPts val="1880"/>
                         </a:lnSpc>
@@ -7999,7 +8007,7 @@
                       </a:endParaRPr>
                     </a:p>
                   </a:txBody>
-                  <a:tcPr marL="59702" marR="59702" marT="59702" marB="59702">
+                  <a:tcPr marL="59702" marR="59702" marT="59702" marB="59702" anchor="t">
                     <a:lnL w="12700" cap="flat" cmpd="sng" algn="ctr">
                       <a:solidFill>
                         <a:srgbClr val="46484D"/>
@@ -8046,7 +8054,7 @@
                     <a:bodyPr/>
                     <a:lstStyle/>
                     <a:p>
-                      <a:pPr marL="0" indent="0">
+                      <a:pPr indent="0" marL="0">
                         <a:lnSpc>
                           <a:spcPts val="1880"/>
                         </a:lnSpc>
@@ -8070,7 +8078,7 @@
                       </a:endParaRPr>
                     </a:p>
                   </a:txBody>
-                  <a:tcPr marL="59702" marR="59702" marT="59702" marB="59702">
+                  <a:tcPr marL="59702" marR="59702" marT="59702" marB="59702" anchor="t">
                     <a:lnL w="12700" cap="flat" cmpd="sng" algn="ctr">
                       <a:solidFill>
                         <a:srgbClr val="54565B"/>
@@ -8112,11 +8120,6 @@
                     </a:solidFill>
                   </a:tcPr>
                 </a:tc>
-                <a:extLst>
-                  <a:ext uri="{0D108BD9-81ED-4DB2-BD59-A6C34878D82A}">
-                    <a16:rowId xmlns:a16="http://schemas.microsoft.com/office/drawing/2014/main" val="10000"/>
-                  </a:ext>
-                </a:extLst>
               </a:tr>
               <a:tr h="369014">
                 <a:tc>
@@ -8124,7 +8127,7 @@
                     <a:bodyPr/>
                     <a:lstStyle/>
                     <a:p>
-                      <a:pPr marL="0" indent="0">
+                      <a:pPr indent="0" marL="0">
                         <a:lnSpc>
                           <a:spcPts val="1880"/>
                         </a:lnSpc>
@@ -8148,7 +8151,7 @@
                       </a:endParaRPr>
                     </a:p>
                   </a:txBody>
-                  <a:tcPr marL="59702" marR="59702" marT="59702" marB="59702">
+                  <a:tcPr marL="59702" marR="59702" marT="59702" marB="59702" anchor="t">
                     <a:lnL w="12700" cap="flat" cmpd="sng" algn="ctr">
                       <a:solidFill>
                         <a:srgbClr val="46484D"/>
@@ -8192,7 +8195,7 @@
                     <a:bodyPr/>
                     <a:lstStyle/>
                     <a:p>
-                      <a:pPr marL="0" indent="0">
+                      <a:pPr indent="0" marL="0">
                         <a:lnSpc>
                           <a:spcPts val="1880"/>
                         </a:lnSpc>
@@ -8216,7 +8219,7 @@
                       </a:endParaRPr>
                     </a:p>
                   </a:txBody>
-                  <a:tcPr marL="59702" marR="59702" marT="59702" marB="59702">
+                  <a:tcPr marL="59702" marR="59702" marT="59702" marB="59702" anchor="t">
                     <a:lnL w="12700" cap="flat" cmpd="sng" algn="ctr">
                       <a:solidFill>
                         <a:srgbClr val="46484D"/>
@@ -8255,11 +8258,6 @@
                     </a:lnB>
                   </a:tcPr>
                 </a:tc>
-                <a:extLst>
-                  <a:ext uri="{0D108BD9-81ED-4DB2-BD59-A6C34878D82A}">
-                    <a16:rowId xmlns:a16="http://schemas.microsoft.com/office/drawing/2014/main" val="10001"/>
-                  </a:ext>
-                </a:extLst>
               </a:tr>
               <a:tr h="369014">
                 <a:tc>
@@ -8267,7 +8265,7 @@
                     <a:bodyPr/>
                     <a:lstStyle/>
                     <a:p>
-                      <a:pPr marL="0" indent="0">
+                      <a:pPr indent="0" marL="0">
                         <a:lnSpc>
                           <a:spcPts val="1880"/>
                         </a:lnSpc>
@@ -8291,7 +8289,7 @@
                       </a:endParaRPr>
                     </a:p>
                   </a:txBody>
-                  <a:tcPr marL="59702" marR="59702" marT="59702" marB="59702">
+                  <a:tcPr marL="59702" marR="59702" marT="59702" marB="59702" anchor="t">
                     <a:lnL w="12700" cap="flat" cmpd="sng" algn="ctr">
                       <a:solidFill>
                         <a:srgbClr val="46484D"/>
@@ -8335,7 +8333,7 @@
                     <a:bodyPr/>
                     <a:lstStyle/>
                     <a:p>
-                      <a:pPr marL="0" indent="0">
+                      <a:pPr indent="0" marL="0">
                         <a:lnSpc>
                           <a:spcPts val="1880"/>
                         </a:lnSpc>
@@ -8359,7 +8357,7 @@
                       </a:endParaRPr>
                     </a:p>
                   </a:txBody>
-                  <a:tcPr marL="59702" marR="59702" marT="59702" marB="59702">
+                  <a:tcPr marL="59702" marR="59702" marT="59702" marB="59702" anchor="t">
                     <a:lnL w="12700" cap="flat" cmpd="sng" algn="ctr">
                       <a:solidFill>
                         <a:srgbClr val="46484D"/>
@@ -8398,11 +8396,6 @@
                     </a:lnB>
                   </a:tcPr>
                 </a:tc>
-                <a:extLst>
-                  <a:ext uri="{0D108BD9-81ED-4DB2-BD59-A6C34878D82A}">
-                    <a16:rowId xmlns:a16="http://schemas.microsoft.com/office/drawing/2014/main" val="10002"/>
-                  </a:ext>
-                </a:extLst>
               </a:tr>
               <a:tr h="369014">
                 <a:tc>
@@ -8410,7 +8403,7 @@
                     <a:bodyPr/>
                     <a:lstStyle/>
                     <a:p>
-                      <a:pPr marL="0" indent="0">
+                      <a:pPr indent="0" marL="0">
                         <a:lnSpc>
                           <a:spcPts val="1880"/>
                         </a:lnSpc>
@@ -8434,7 +8427,7 @@
                       </a:endParaRPr>
                     </a:p>
                   </a:txBody>
-                  <a:tcPr marL="59702" marR="59702" marT="59702" marB="59702">
+                  <a:tcPr marL="59702" marR="59702" marT="59702" marB="59702" anchor="t">
                     <a:lnL w="12700" cap="flat" cmpd="sng" algn="ctr">
                       <a:solidFill>
                         <a:srgbClr val="46484D"/>
@@ -8478,7 +8471,7 @@
                     <a:bodyPr/>
                     <a:lstStyle/>
                     <a:p>
-                      <a:pPr marL="0" indent="0">
+                      <a:pPr indent="0" marL="0">
                         <a:lnSpc>
                           <a:spcPts val="1880"/>
                         </a:lnSpc>
@@ -8502,7 +8495,7 @@
                       </a:endParaRPr>
                     </a:p>
                   </a:txBody>
-                  <a:tcPr marL="59702" marR="59702" marT="59702" marB="59702">
+                  <a:tcPr marL="59702" marR="59702" marT="59702" marB="59702" anchor="t">
                     <a:lnL w="12700" cap="flat" cmpd="sng" algn="ctr">
                       <a:solidFill>
                         <a:srgbClr val="46484D"/>
@@ -8541,11 +8534,6 @@
                     </a:lnB>
                   </a:tcPr>
                 </a:tc>
-                <a:extLst>
-                  <a:ext uri="{0D108BD9-81ED-4DB2-BD59-A6C34878D82A}">
-                    <a16:rowId xmlns:a16="http://schemas.microsoft.com/office/drawing/2014/main" val="10003"/>
-                  </a:ext>
-                </a:extLst>
               </a:tr>
               <a:tr h="369014">
                 <a:tc>
@@ -8553,7 +8541,7 @@
                     <a:bodyPr/>
                     <a:lstStyle/>
                     <a:p>
-                      <a:pPr marL="0" indent="0">
+                      <a:pPr indent="0" marL="0">
                         <a:lnSpc>
                           <a:spcPts val="1880"/>
                         </a:lnSpc>
@@ -8577,7 +8565,7 @@
                       </a:endParaRPr>
                     </a:p>
                   </a:txBody>
-                  <a:tcPr marL="59702" marR="59702" marT="59702" marB="59702">
+                  <a:tcPr marL="59702" marR="59702" marT="59702" marB="59702" anchor="t">
                     <a:lnL w="12700" cap="flat" cmpd="sng" algn="ctr">
                       <a:solidFill>
                         <a:srgbClr val="46484D"/>
@@ -8621,7 +8609,7 @@
                     <a:bodyPr/>
                     <a:lstStyle/>
                     <a:p>
-                      <a:pPr marL="0" indent="0">
+                      <a:pPr indent="0" marL="0">
                         <a:lnSpc>
                           <a:spcPts val="1880"/>
                         </a:lnSpc>
@@ -8645,7 +8633,7 @@
                       </a:endParaRPr>
                     </a:p>
                   </a:txBody>
-                  <a:tcPr marL="59702" marR="59702" marT="59702" marB="59702">
+                  <a:tcPr marL="59702" marR="59702" marT="59702" marB="59702" anchor="t">
                     <a:lnL w="12700" cap="flat" cmpd="sng" algn="ctr">
                       <a:solidFill>
                         <a:srgbClr val="46484D"/>
@@ -8684,11 +8672,6 @@
                     </a:lnB>
                   </a:tcPr>
                 </a:tc>
-                <a:extLst>
-                  <a:ext uri="{0D108BD9-81ED-4DB2-BD59-A6C34878D82A}">
-                    <a16:rowId xmlns:a16="http://schemas.microsoft.com/office/drawing/2014/main" val="10004"/>
-                  </a:ext>
-                </a:extLst>
               </a:tr>
               <a:tr h="369094">
                 <a:tc>
@@ -8696,7 +8679,7 @@
                     <a:bodyPr/>
                     <a:lstStyle/>
                     <a:p>
-                      <a:pPr marL="0" indent="0">
+                      <a:pPr indent="0" marL="0">
                         <a:lnSpc>
                           <a:spcPts val="1880"/>
                         </a:lnSpc>
@@ -8720,7 +8703,7 @@
                       </a:endParaRPr>
                     </a:p>
                   </a:txBody>
-                  <a:tcPr marL="59702" marR="59702" marT="59702" marB="59702">
+                  <a:tcPr marL="59702" marR="59702" marT="59702" marB="59702" anchor="t">
                     <a:lnL w="12700" cap="flat" cmpd="sng" algn="ctr">
                       <a:solidFill>
                         <a:srgbClr val="46484D"/>
@@ -8764,7 +8747,7 @@
                     <a:bodyPr/>
                     <a:lstStyle/>
                     <a:p>
-                      <a:pPr marL="0" indent="0">
+                      <a:pPr indent="0" marL="0">
                         <a:lnSpc>
                           <a:spcPts val="1880"/>
                         </a:lnSpc>
@@ -8788,7 +8771,7 @@
                       </a:endParaRPr>
                     </a:p>
                   </a:txBody>
-                  <a:tcPr marL="59702" marR="59702" marT="59702" marB="59702">
+                  <a:tcPr marL="59702" marR="59702" marT="59702" marB="59702" anchor="t">
                     <a:lnL w="12700" cap="flat" cmpd="sng" algn="ctr">
                       <a:solidFill>
                         <a:srgbClr val="46484D"/>
@@ -8827,11 +8810,6 @@
                     </a:lnB>
                   </a:tcPr>
                 </a:tc>
-                <a:extLst>
-                  <a:ext uri="{0D108BD9-81ED-4DB2-BD59-A6C34878D82A}">
-                    <a16:rowId xmlns:a16="http://schemas.microsoft.com/office/drawing/2014/main" val="10005"/>
-                  </a:ext>
-                </a:extLst>
               </a:tr>
               <a:tr h="369094">
                 <a:tc>
@@ -8839,7 +8817,7 @@
                     <a:bodyPr/>
                     <a:lstStyle/>
                     <a:p>
-                      <a:pPr marL="0" indent="0">
+                      <a:pPr indent="0" marL="0">
                         <a:lnSpc>
                           <a:spcPts val="1880"/>
                         </a:lnSpc>
@@ -8863,7 +8841,7 @@
                       </a:endParaRPr>
                     </a:p>
                   </a:txBody>
-                  <a:tcPr marL="59702" marR="59702" marT="59702" marB="59702">
+                  <a:tcPr marL="59702" marR="59702" marT="59702" marB="59702" anchor="t">
                     <a:lnL w="12700" cap="flat" cmpd="sng" algn="ctr">
                       <a:solidFill>
                         <a:srgbClr val="46484D"/>
@@ -8907,7 +8885,7 @@
                     <a:bodyPr/>
                     <a:lstStyle/>
                     <a:p>
-                      <a:pPr marL="0" indent="0">
+                      <a:pPr indent="0" marL="0">
                         <a:lnSpc>
                           <a:spcPts val="1880"/>
                         </a:lnSpc>
@@ -8931,7 +8909,7 @@
                       </a:endParaRPr>
                     </a:p>
                   </a:txBody>
-                  <a:tcPr marL="59702" marR="59702" marT="59702" marB="59702">
+                  <a:tcPr marL="59702" marR="59702" marT="59702" marB="59702" anchor="t">
                     <a:lnL w="12700" cap="flat" cmpd="sng" algn="ctr">
                       <a:solidFill>
                         <a:srgbClr val="46484D"/>
@@ -8970,11 +8948,6 @@
                     </a:lnB>
                   </a:tcPr>
                 </a:tc>
-                <a:extLst>
-                  <a:ext uri="{0D108BD9-81ED-4DB2-BD59-A6C34878D82A}">
-                    <a16:rowId xmlns:a16="http://schemas.microsoft.com/office/drawing/2014/main" val="10006"/>
-                  </a:ext>
-                </a:extLst>
               </a:tr>
             </a:tbl>
           </a:graphicData>
@@ -9026,7 +8999,7 @@
           </a:bodyPr>
           <a:lstStyle/>
           <a:p>
-            <a:pPr marL="0" indent="0" algn="l">
+            <a:pPr algn="l" indent="0" marL="0">
               <a:lnSpc>
                 <a:spcPts val="2640"/>
               </a:lnSpc>
@@ -9063,7 +9036,6 @@
         <a:solidFill>
           <a:srgbClr val="070A12"/>
         </a:solidFill>
-        <a:effectLst/>
       </p:bgPr>
     </p:bg>
     <p:spTree>
@@ -9110,13 +9082,6 @@
           </a:gradFill>
           <a:ln/>
         </p:spPr>
-        <p:txBody>
-          <a:bodyPr/>
-          <a:lstStyle/>
-          <a:p>
-            <a:endParaRPr lang="en-US"/>
-          </a:p>
-        </p:txBody>
       </p:sp>
       <p:sp>
         <p:nvSpPr>
@@ -9141,14 +9106,14 @@
           </a:bodyPr>
           <a:lstStyle/>
           <a:p>
-            <a:pPr marL="0" indent="0" algn="l">
+            <a:pPr algn="l" indent="0" marL="0">
               <a:lnSpc>
                 <a:spcPts val="1960"/>
               </a:lnSpc>
               <a:buNone/>
             </a:pPr>
             <a:r>
-              <a:rPr lang="en-US" sz="1400" b="1" kern="0" spc="250" dirty="0">
+              <a:rPr lang="en-US" sz="1400" b="1" spc="250" kern="0" dirty="0">
                 <a:solidFill>
                   <a:srgbClr val="8FA8F0"/>
                 </a:solidFill>
@@ -9165,9 +9130,7 @@
       <p:sp>
         <p:nvSpPr>
           <p:cNvPr id="4" name="Text 2"/>
-          <p:cNvSpPr>
-            <a:spLocks noGrp="1"/>
-          </p:cNvSpPr>
+          <p:cNvSpPr/>
           <p:nvPr>
             <p:ph type="title"/>
           </p:nvPr>
@@ -9189,7 +9152,7 @@
           </a:bodyPr>
           <a:lstStyle/>
           <a:p>
-            <a:pPr marL="0" indent="0" algn="l">
+            <a:pPr algn="l" indent="0" marL="0">
               <a:lnSpc>
                 <a:spcPts val="4180"/>
               </a:lnSpc>
@@ -9240,13 +9203,6 @@
             <a:prstDash val="solid"/>
           </a:ln>
         </p:spPr>
-        <p:txBody>
-          <a:bodyPr/>
-          <a:lstStyle/>
-          <a:p>
-            <a:endParaRPr lang="en-US"/>
-          </a:p>
-        </p:txBody>
       </p:sp>
       <p:sp>
         <p:nvSpPr>
@@ -9271,7 +9227,7 @@
           </a:bodyPr>
           <a:lstStyle/>
           <a:p>
-            <a:pPr marL="0" indent="0" algn="l">
+            <a:pPr algn="l" indent="0" marL="0">
               <a:lnSpc>
                 <a:spcPts val="2280"/>
               </a:lnSpc>
@@ -9315,7 +9271,7 @@
           </a:bodyPr>
           <a:lstStyle/>
           <a:p>
-            <a:pPr marL="169418" indent="-169418" algn="l">
+            <a:pPr algn="l" marL="169418" indent="-169418">
               <a:lnSpc>
                 <a:spcPts val="2100"/>
               </a:lnSpc>
@@ -9336,7 +9292,7 @@
             <a:endParaRPr lang="en-US" sz="1400" dirty="0"/>
           </a:p>
           <a:p>
-            <a:pPr marL="169418" indent="-169418" algn="l">
+            <a:pPr algn="l" marL="169418" indent="-169418">
               <a:lnSpc>
                 <a:spcPts val="2100"/>
               </a:lnSpc>
@@ -9357,7 +9313,7 @@
             <a:endParaRPr lang="en-US" sz="1400" dirty="0"/>
           </a:p>
           <a:p>
-            <a:pPr marL="169418" indent="-169418" algn="l">
+            <a:pPr algn="l" marL="169418" indent="-169418">
               <a:lnSpc>
                 <a:spcPts val="2100"/>
               </a:lnSpc>
@@ -9378,7 +9334,7 @@
             <a:endParaRPr lang="en-US" sz="1400" dirty="0"/>
           </a:p>
           <a:p>
-            <a:pPr marL="169418" indent="-169418" algn="l">
+            <a:pPr algn="l" marL="169418" indent="-169418">
               <a:lnSpc>
                 <a:spcPts val="2100"/>
               </a:lnSpc>
@@ -9399,7 +9355,7 @@
             <a:endParaRPr lang="en-US" sz="1400" dirty="0"/>
           </a:p>
           <a:p>
-            <a:pPr marL="169418" indent="-169418" algn="l">
+            <a:pPr algn="l" marL="169418" indent="-169418">
               <a:lnSpc>
                 <a:spcPts val="2100"/>
               </a:lnSpc>
@@ -9420,7 +9376,7 @@
             <a:endParaRPr lang="en-US" sz="1400" dirty="0"/>
           </a:p>
           <a:p>
-            <a:pPr marL="169418" indent="-169418" algn="l">
+            <a:pPr algn="l" marL="169418" indent="-169418">
               <a:lnSpc>
                 <a:spcPts val="2100"/>
               </a:lnSpc>
@@ -9482,13 +9438,6 @@
             <a:prstDash val="solid"/>
           </a:ln>
         </p:spPr>
-        <p:txBody>
-          <a:bodyPr/>
-          <a:lstStyle/>
-          <a:p>
-            <a:endParaRPr lang="en-US"/>
-          </a:p>
-        </p:txBody>
       </p:sp>
       <p:sp>
         <p:nvSpPr>
@@ -9513,7 +9462,7 @@
           </a:bodyPr>
           <a:lstStyle/>
           <a:p>
-            <a:pPr marL="0" indent="0" algn="l">
+            <a:pPr algn="l" indent="0" marL="0">
               <a:lnSpc>
                 <a:spcPts val="2280"/>
               </a:lnSpc>
@@ -9557,7 +9506,7 @@
           </a:bodyPr>
           <a:lstStyle/>
           <a:p>
-            <a:pPr marL="169418" indent="-169418" algn="l">
+            <a:pPr algn="l" marL="169418" indent="-169418">
               <a:lnSpc>
                 <a:spcPts val="2100"/>
               </a:lnSpc>
@@ -9578,7 +9527,7 @@
             <a:endParaRPr lang="en-US" sz="1400" dirty="0"/>
           </a:p>
           <a:p>
-            <a:pPr marL="169418" indent="-169418" algn="l">
+            <a:pPr algn="l" marL="169418" indent="-169418">
               <a:lnSpc>
                 <a:spcPts val="2100"/>
               </a:lnSpc>
@@ -9599,7 +9548,7 @@
             <a:endParaRPr lang="en-US" sz="1400" dirty="0"/>
           </a:p>
           <a:p>
-            <a:pPr marL="169418" indent="-169418" algn="l">
+            <a:pPr algn="l" marL="169418" indent="-169418">
               <a:lnSpc>
                 <a:spcPts val="2100"/>
               </a:lnSpc>
@@ -9620,7 +9569,7 @@
             <a:endParaRPr lang="en-US" sz="1400" dirty="0"/>
           </a:p>
           <a:p>
-            <a:pPr marL="169418" indent="-169418" algn="l">
+            <a:pPr algn="l" marL="169418" indent="-169418">
               <a:lnSpc>
                 <a:spcPts val="2100"/>
               </a:lnSpc>
@@ -9665,7 +9614,7 @@
           </a:bodyPr>
           <a:lstStyle/>
           <a:p>
-            <a:pPr marL="0" indent="0" algn="l">
+            <a:pPr algn="l" indent="0" marL="0">
               <a:lnSpc>
                 <a:spcPts val="1680"/>
               </a:lnSpc>
@@ -9702,7 +9651,6 @@
         <a:solidFill>
           <a:srgbClr val="0B1220"/>
         </a:solidFill>
-        <a:effectLst/>
       </p:bgPr>
     </p:bg>
     <p:spTree>
@@ -9749,13 +9697,6 @@
           </a:gradFill>
           <a:ln/>
         </p:spPr>
-        <p:txBody>
-          <a:bodyPr/>
-          <a:lstStyle/>
-          <a:p>
-            <a:endParaRPr lang="en-US"/>
-          </a:p>
-        </p:txBody>
       </p:sp>
       <p:sp>
         <p:nvSpPr>
@@ -9780,14 +9721,14 @@
           </a:bodyPr>
           <a:lstStyle/>
           <a:p>
-            <a:pPr marL="0" indent="0" algn="l">
+            <a:pPr algn="l" indent="0" marL="0">
               <a:lnSpc>
                 <a:spcPts val="1960"/>
               </a:lnSpc>
               <a:buNone/>
             </a:pPr>
             <a:r>
-              <a:rPr lang="en-US" sz="1400" b="1" kern="0" spc="250" dirty="0">
+              <a:rPr lang="en-US" sz="1400" b="1" spc="250" kern="0" dirty="0">
                 <a:solidFill>
                   <a:srgbClr val="5CCFC0"/>
                 </a:solidFill>
@@ -9804,9 +9745,7 @@
       <p:sp>
         <p:nvSpPr>
           <p:cNvPr id="4" name="Text 2"/>
-          <p:cNvSpPr>
-            <a:spLocks noGrp="1"/>
-          </p:cNvSpPr>
+          <p:cNvSpPr/>
           <p:nvPr>
             <p:ph type="title"/>
           </p:nvPr>
@@ -9828,7 +9767,7 @@
           </a:bodyPr>
           <a:lstStyle/>
           <a:p>
-            <a:pPr marL="0" indent="0" algn="l">
+            <a:pPr algn="l" indent="0" marL="0">
               <a:lnSpc>
                 <a:spcPts val="4180"/>
               </a:lnSpc>
@@ -9879,13 +9818,6 @@
             <a:prstDash val="solid"/>
           </a:ln>
         </p:spPr>
-        <p:txBody>
-          <a:bodyPr/>
-          <a:lstStyle/>
-          <a:p>
-            <a:endParaRPr lang="en-US"/>
-          </a:p>
-        </p:txBody>
       </p:sp>
       <p:sp>
         <p:nvSpPr>
@@ -9910,7 +9842,7 @@
           </a:bodyPr>
           <a:lstStyle/>
           <a:p>
-            <a:pPr marL="0" indent="0" algn="l">
+            <a:pPr algn="l" indent="0" marL="0">
               <a:lnSpc>
                 <a:spcPts val="4200"/>
               </a:lnSpc>
@@ -9954,7 +9886,7 @@
           </a:bodyPr>
           <a:lstStyle/>
           <a:p>
-            <a:pPr marL="0" indent="0" algn="l">
+            <a:pPr algn="l" indent="0" marL="0">
               <a:lnSpc>
                 <a:spcPts val="1960"/>
               </a:lnSpc>
@@ -10005,13 +9937,6 @@
             <a:prstDash val="solid"/>
           </a:ln>
         </p:spPr>
-        <p:txBody>
-          <a:bodyPr/>
-          <a:lstStyle/>
-          <a:p>
-            <a:endParaRPr lang="en-US"/>
-          </a:p>
-        </p:txBody>
       </p:sp>
       <p:sp>
         <p:nvSpPr>
@@ -10036,7 +9961,7 @@
           </a:bodyPr>
           <a:lstStyle/>
           <a:p>
-            <a:pPr marL="0" indent="0" algn="l">
+            <a:pPr algn="l" indent="0" marL="0">
               <a:lnSpc>
                 <a:spcPts val="4200"/>
               </a:lnSpc>
@@ -10080,7 +10005,7 @@
           </a:bodyPr>
           <a:lstStyle/>
           <a:p>
-            <a:pPr marL="0" indent="0" algn="l">
+            <a:pPr algn="l" indent="0" marL="0">
               <a:lnSpc>
                 <a:spcPts val="1960"/>
               </a:lnSpc>
@@ -10131,13 +10056,6 @@
             <a:prstDash val="solid"/>
           </a:ln>
         </p:spPr>
-        <p:txBody>
-          <a:bodyPr/>
-          <a:lstStyle/>
-          <a:p>
-            <a:endParaRPr lang="en-US"/>
-          </a:p>
-        </p:txBody>
       </p:sp>
       <p:sp>
         <p:nvSpPr>
@@ -10162,7 +10080,7 @@
           </a:bodyPr>
           <a:lstStyle/>
           <a:p>
-            <a:pPr marL="0" indent="0" algn="l">
+            <a:pPr algn="l" indent="0" marL="0">
               <a:lnSpc>
                 <a:spcPts val="4200"/>
               </a:lnSpc>
@@ -10206,7 +10124,7 @@
           </a:bodyPr>
           <a:lstStyle/>
           <a:p>
-            <a:pPr marL="0" indent="0" algn="l">
+            <a:pPr algn="l" indent="0" marL="0">
               <a:lnSpc>
                 <a:spcPts val="1960"/>
               </a:lnSpc>
@@ -10257,13 +10175,6 @@
             <a:prstDash val="solid"/>
           </a:ln>
         </p:spPr>
-        <p:txBody>
-          <a:bodyPr/>
-          <a:lstStyle/>
-          <a:p>
-            <a:endParaRPr lang="en-US"/>
-          </a:p>
-        </p:txBody>
       </p:sp>
       <p:graphicFrame>
         <p:nvGraphicFramePr>
@@ -10281,34 +10192,16 @@
         </p:nvGraphicFramePr>
         <p:xfrm>
           <a:off x="6207760" y="2115821"/>
-          <a:ext cx="4963159" cy="2684780"/>
+          <a:ext cx="4963160" cy="2684780"/>
         </p:xfrm>
         <a:graphic>
           <a:graphicData uri="http://schemas.openxmlformats.org/drawingml/2006/table">
             <a:tbl>
               <a:tblPr/>
               <a:tblGrid>
-                <a:gridCol w="2580843">
-                  <a:extLst>
-                    <a:ext uri="{9D8B030D-6E8A-4147-A177-3AD203B41FA5}">
-                      <a16:colId xmlns:a16="http://schemas.microsoft.com/office/drawing/2014/main" val="20000"/>
-                    </a:ext>
-                  </a:extLst>
-                </a:gridCol>
-                <a:gridCol w="1191158">
-                  <a:extLst>
-                    <a:ext uri="{9D8B030D-6E8A-4147-A177-3AD203B41FA5}">
-                      <a16:colId xmlns:a16="http://schemas.microsoft.com/office/drawing/2014/main" val="20001"/>
-                    </a:ext>
-                  </a:extLst>
-                </a:gridCol>
-                <a:gridCol w="1191158">
-                  <a:extLst>
-                    <a:ext uri="{9D8B030D-6E8A-4147-A177-3AD203B41FA5}">
-                      <a16:colId xmlns:a16="http://schemas.microsoft.com/office/drawing/2014/main" val="20002"/>
-                    </a:ext>
-                  </a:extLst>
-                </a:gridCol>
+                <a:gridCol w="2580843"/>
+                <a:gridCol w="1191158"/>
+                <a:gridCol w="1191158"/>
               </a:tblGrid>
               <a:tr h="383540">
                 <a:tc>
@@ -10316,7 +10209,7 @@
                     <a:bodyPr/>
                     <a:lstStyle/>
                     <a:p>
-                      <a:pPr marL="0" indent="0">
+                      <a:pPr indent="0" marL="0">
                         <a:lnSpc>
                           <a:spcPts val="1960"/>
                         </a:lnSpc>
@@ -10340,7 +10233,7 @@
                       </a:endParaRPr>
                     </a:p>
                   </a:txBody>
-                  <a:tcPr marL="62230" marR="62230" marT="62230" marB="62230">
+                  <a:tcPr marL="62230" marR="62230" marT="62230" marB="62230" anchor="t">
                     <a:lnL w="12700" cap="flat" cmpd="sng" algn="ctr">
                       <a:solidFill>
                         <a:srgbClr val="474C56"/>
@@ -10387,7 +10280,7 @@
                     <a:bodyPr/>
                     <a:lstStyle/>
                     <a:p>
-                      <a:pPr marL="0" indent="0" algn="ctr">
+                      <a:pPr algn="ctr" indent="0" marL="0">
                         <a:lnSpc>
                           <a:spcPts val="1960"/>
                         </a:lnSpc>
@@ -10411,7 +10304,7 @@
                       </a:endParaRPr>
                     </a:p>
                   </a:txBody>
-                  <a:tcPr marL="62230" marR="62230" marT="62230" marB="62230">
+                  <a:tcPr marL="62230" marR="62230" marT="62230" marB="62230" anchor="t">
                     <a:lnL w="12700" cap="flat" cmpd="sng" algn="ctr">
                       <a:solidFill>
                         <a:srgbClr val="555A62"/>
@@ -10458,7 +10351,7 @@
                     <a:bodyPr/>
                     <a:lstStyle/>
                     <a:p>
-                      <a:pPr marL="0" indent="0" algn="ctr">
+                      <a:pPr algn="ctr" indent="0" marL="0">
                         <a:lnSpc>
                           <a:spcPts val="1960"/>
                         </a:lnSpc>
@@ -10482,7 +10375,7 @@
                       </a:endParaRPr>
                     </a:p>
                   </a:txBody>
-                  <a:tcPr marL="62230" marR="62230" marT="62230" marB="62230">
+                  <a:tcPr marL="62230" marR="62230" marT="62230" marB="62230" anchor="t">
                     <a:lnL w="12700" cap="flat" cmpd="sng" algn="ctr">
                       <a:solidFill>
                         <a:srgbClr val="555A62"/>
@@ -10524,11 +10417,6 @@
                     </a:solidFill>
                   </a:tcPr>
                 </a:tc>
-                <a:extLst>
-                  <a:ext uri="{0D108BD9-81ED-4DB2-BD59-A6C34878D82A}">
-                    <a16:rowId xmlns:a16="http://schemas.microsoft.com/office/drawing/2014/main" val="10000"/>
-                  </a:ext>
-                </a:extLst>
               </a:tr>
               <a:tr h="383540">
                 <a:tc>
@@ -10536,7 +10424,7 @@
                     <a:bodyPr/>
                     <a:lstStyle/>
                     <a:p>
-                      <a:pPr marL="0" indent="0">
+                      <a:pPr indent="0" marL="0">
                         <a:lnSpc>
                           <a:spcPts val="1960"/>
                         </a:lnSpc>
@@ -10560,7 +10448,7 @@
                       </a:endParaRPr>
                     </a:p>
                   </a:txBody>
-                  <a:tcPr marL="62230" marR="62230" marT="62230" marB="62230">
+                  <a:tcPr marL="62230" marR="62230" marT="62230" marB="62230" anchor="t">
                     <a:lnL w="12700" cap="flat" cmpd="sng" algn="ctr">
                       <a:solidFill>
                         <a:srgbClr val="474C56"/>
@@ -10604,7 +10492,7 @@
                     <a:bodyPr/>
                     <a:lstStyle/>
                     <a:p>
-                      <a:pPr marL="0" indent="0" algn="ctr">
+                      <a:pPr algn="ctr" indent="0" marL="0">
                         <a:lnSpc>
                           <a:spcPts val="1960"/>
                         </a:lnSpc>
@@ -10628,7 +10516,7 @@
                       </a:endParaRPr>
                     </a:p>
                   </a:txBody>
-                  <a:tcPr marL="62230" marR="62230" marT="62230" marB="62230">
+                  <a:tcPr marL="62230" marR="62230" marT="62230" marB="62230" anchor="t">
                     <a:lnL w="12700" cap="flat" cmpd="sng" algn="ctr">
                       <a:solidFill>
                         <a:srgbClr val="474C56"/>
@@ -10672,7 +10560,7 @@
                     <a:bodyPr/>
                     <a:lstStyle/>
                     <a:p>
-                      <a:pPr marL="0" indent="0" algn="ctr">
+                      <a:pPr algn="ctr" indent="0" marL="0">
                         <a:lnSpc>
                           <a:spcPts val="1960"/>
                         </a:lnSpc>
@@ -10696,7 +10584,7 @@
                       </a:endParaRPr>
                     </a:p>
                   </a:txBody>
-                  <a:tcPr marL="62230" marR="62230" marT="62230" marB="62230">
+                  <a:tcPr marL="62230" marR="62230" marT="62230" marB="62230" anchor="t">
                     <a:lnL w="12700" cap="flat" cmpd="sng" algn="ctr">
                       <a:solidFill>
                         <a:srgbClr val="474C56"/>
@@ -10735,11 +10623,6 @@
                     </a:lnB>
                   </a:tcPr>
                 </a:tc>
-                <a:extLst>
-                  <a:ext uri="{0D108BD9-81ED-4DB2-BD59-A6C34878D82A}">
-                    <a16:rowId xmlns:a16="http://schemas.microsoft.com/office/drawing/2014/main" val="10001"/>
-                  </a:ext>
-                </a:extLst>
               </a:tr>
               <a:tr h="383540">
                 <a:tc>
@@ -10747,7 +10630,7 @@
                     <a:bodyPr/>
                     <a:lstStyle/>
                     <a:p>
-                      <a:pPr marL="0" indent="0">
+                      <a:pPr indent="0" marL="0">
                         <a:lnSpc>
                           <a:spcPts val="1960"/>
                         </a:lnSpc>
@@ -10771,7 +10654,7 @@
                       </a:endParaRPr>
                     </a:p>
                   </a:txBody>
-                  <a:tcPr marL="62230" marR="62230" marT="62230" marB="62230">
+                  <a:tcPr marL="62230" marR="62230" marT="62230" marB="62230" anchor="t">
                     <a:lnL w="12700" cap="flat" cmpd="sng" algn="ctr">
                       <a:solidFill>
                         <a:srgbClr val="474C56"/>
@@ -10815,7 +10698,7 @@
                     <a:bodyPr/>
                     <a:lstStyle/>
                     <a:p>
-                      <a:pPr marL="0" indent="0" algn="ctr">
+                      <a:pPr algn="ctr" indent="0" marL="0">
                         <a:lnSpc>
                           <a:spcPts val="1960"/>
                         </a:lnSpc>
@@ -10839,7 +10722,7 @@
                       </a:endParaRPr>
                     </a:p>
                   </a:txBody>
-                  <a:tcPr marL="62230" marR="62230" marT="62230" marB="62230">
+                  <a:tcPr marL="62230" marR="62230" marT="62230" marB="62230" anchor="t">
                     <a:lnL w="12700" cap="flat" cmpd="sng" algn="ctr">
                       <a:solidFill>
                         <a:srgbClr val="474C56"/>
@@ -10883,7 +10766,7 @@
                     <a:bodyPr/>
                     <a:lstStyle/>
                     <a:p>
-                      <a:pPr marL="0" indent="0" algn="ctr">
+                      <a:pPr algn="ctr" indent="0" marL="0">
                         <a:lnSpc>
                           <a:spcPts val="1960"/>
                         </a:lnSpc>
@@ -10907,7 +10790,7 @@
                       </a:endParaRPr>
                     </a:p>
                   </a:txBody>
-                  <a:tcPr marL="62230" marR="62230" marT="62230" marB="62230">
+                  <a:tcPr marL="62230" marR="62230" marT="62230" marB="62230" anchor="t">
                     <a:lnL w="12700" cap="flat" cmpd="sng" algn="ctr">
                       <a:solidFill>
                         <a:srgbClr val="474C56"/>
@@ -10946,11 +10829,6 @@
                     </a:lnB>
                   </a:tcPr>
                 </a:tc>
-                <a:extLst>
-                  <a:ext uri="{0D108BD9-81ED-4DB2-BD59-A6C34878D82A}">
-                    <a16:rowId xmlns:a16="http://schemas.microsoft.com/office/drawing/2014/main" val="10002"/>
-                  </a:ext>
-                </a:extLst>
               </a:tr>
               <a:tr h="383540">
                 <a:tc>
@@ -10958,7 +10836,7 @@
                     <a:bodyPr/>
                     <a:lstStyle/>
                     <a:p>
-                      <a:pPr marL="0" indent="0">
+                      <a:pPr indent="0" marL="0">
                         <a:lnSpc>
                           <a:spcPts val="1960"/>
                         </a:lnSpc>
@@ -10982,7 +10860,7 @@
                       </a:endParaRPr>
                     </a:p>
                   </a:txBody>
-                  <a:tcPr marL="62230" marR="62230" marT="62230" marB="62230">
+                  <a:tcPr marL="62230" marR="62230" marT="62230" marB="62230" anchor="t">
                     <a:lnL w="12700" cap="flat" cmpd="sng" algn="ctr">
                       <a:solidFill>
                         <a:srgbClr val="474C56"/>
@@ -11026,7 +10904,7 @@
                     <a:bodyPr/>
                     <a:lstStyle/>
                     <a:p>
-                      <a:pPr marL="0" indent="0" algn="ctr">
+                      <a:pPr algn="ctr" indent="0" marL="0">
                         <a:lnSpc>
                           <a:spcPts val="1960"/>
                         </a:lnSpc>
@@ -11050,7 +10928,7 @@
                       </a:endParaRPr>
                     </a:p>
                   </a:txBody>
-                  <a:tcPr marL="62230" marR="62230" marT="62230" marB="62230">
+                  <a:tcPr marL="62230" marR="62230" marT="62230" marB="62230" anchor="t">
                     <a:lnL w="12700" cap="flat" cmpd="sng" algn="ctr">
                       <a:solidFill>
                         <a:srgbClr val="474C56"/>
@@ -11094,7 +10972,7 @@
                     <a:bodyPr/>
                     <a:lstStyle/>
                     <a:p>
-                      <a:pPr marL="0" indent="0" algn="ctr">
+                      <a:pPr algn="ctr" indent="0" marL="0">
                         <a:lnSpc>
                           <a:spcPts val="1960"/>
                         </a:lnSpc>
@@ -11118,7 +10996,7 @@
                       </a:endParaRPr>
                     </a:p>
                   </a:txBody>
-                  <a:tcPr marL="62230" marR="62230" marT="62230" marB="62230">
+                  <a:tcPr marL="62230" marR="62230" marT="62230" marB="62230" anchor="t">
                     <a:lnL w="12700" cap="flat" cmpd="sng" algn="ctr">
                       <a:solidFill>
                         <a:srgbClr val="474C56"/>
@@ -11157,11 +11035,6 @@
                     </a:lnB>
                   </a:tcPr>
                 </a:tc>
-                <a:extLst>
-                  <a:ext uri="{0D108BD9-81ED-4DB2-BD59-A6C34878D82A}">
-                    <a16:rowId xmlns:a16="http://schemas.microsoft.com/office/drawing/2014/main" val="10003"/>
-                  </a:ext>
-                </a:extLst>
               </a:tr>
               <a:tr h="383540">
                 <a:tc>
@@ -11169,7 +11042,7 @@
                     <a:bodyPr/>
                     <a:lstStyle/>
                     <a:p>
-                      <a:pPr marL="0" indent="0">
+                      <a:pPr indent="0" marL="0">
                         <a:lnSpc>
                           <a:spcPts val="1960"/>
                         </a:lnSpc>
@@ -11193,7 +11066,7 @@
                       </a:endParaRPr>
                     </a:p>
                   </a:txBody>
-                  <a:tcPr marL="62230" marR="62230" marT="62230" marB="62230">
+                  <a:tcPr marL="62230" marR="62230" marT="62230" marB="62230" anchor="t">
                     <a:lnL w="12700" cap="flat" cmpd="sng" algn="ctr">
                       <a:solidFill>
                         <a:srgbClr val="474C56"/>
@@ -11237,7 +11110,7 @@
                     <a:bodyPr/>
                     <a:lstStyle/>
                     <a:p>
-                      <a:pPr marL="0" indent="0" algn="ctr">
+                      <a:pPr algn="ctr" indent="0" marL="0">
                         <a:lnSpc>
                           <a:spcPts val="1960"/>
                         </a:lnSpc>
@@ -11261,7 +11134,7 @@
                       </a:endParaRPr>
                     </a:p>
                   </a:txBody>
-                  <a:tcPr marL="62230" marR="62230" marT="62230" marB="62230">
+                  <a:tcPr marL="62230" marR="62230" marT="62230" marB="62230" anchor="t">
                     <a:lnL w="12700" cap="flat" cmpd="sng" algn="ctr">
                       <a:solidFill>
                         <a:srgbClr val="474C56"/>
@@ -11305,7 +11178,7 @@
                     <a:bodyPr/>
                     <a:lstStyle/>
                     <a:p>
-                      <a:pPr marL="0" indent="0" algn="ctr">
+                      <a:pPr algn="ctr" indent="0" marL="0">
                         <a:lnSpc>
                           <a:spcPts val="1960"/>
                         </a:lnSpc>
@@ -11329,7 +11202,7 @@
                       </a:endParaRPr>
                     </a:p>
                   </a:txBody>
-                  <a:tcPr marL="62230" marR="62230" marT="62230" marB="62230">
+                  <a:tcPr marL="62230" marR="62230" marT="62230" marB="62230" anchor="t">
                     <a:lnL w="12700" cap="flat" cmpd="sng" algn="ctr">
                       <a:solidFill>
                         <a:srgbClr val="474C56"/>
@@ -11368,11 +11241,6 @@
                     </a:lnB>
                   </a:tcPr>
                 </a:tc>
-                <a:extLst>
-                  <a:ext uri="{0D108BD9-81ED-4DB2-BD59-A6C34878D82A}">
-                    <a16:rowId xmlns:a16="http://schemas.microsoft.com/office/drawing/2014/main" val="10004"/>
-                  </a:ext>
-                </a:extLst>
               </a:tr>
               <a:tr h="383540">
                 <a:tc>
@@ -11380,7 +11248,7 @@
                     <a:bodyPr/>
                     <a:lstStyle/>
                     <a:p>
-                      <a:pPr marL="0" indent="0">
+                      <a:pPr indent="0" marL="0">
                         <a:lnSpc>
                           <a:spcPts val="1960"/>
                         </a:lnSpc>
@@ -11404,7 +11272,7 @@
                       </a:endParaRPr>
                     </a:p>
                   </a:txBody>
-                  <a:tcPr marL="62230" marR="62230" marT="62230" marB="62230">
+                  <a:tcPr marL="62230" marR="62230" marT="62230" marB="62230" anchor="t">
                     <a:lnL w="12700" cap="flat" cmpd="sng" algn="ctr">
                       <a:solidFill>
                         <a:srgbClr val="474C56"/>
@@ -11448,7 +11316,7 @@
                     <a:bodyPr/>
                     <a:lstStyle/>
                     <a:p>
-                      <a:pPr marL="0" indent="0" algn="ctr">
+                      <a:pPr algn="ctr" indent="0" marL="0">
                         <a:lnSpc>
                           <a:spcPts val="1960"/>
                         </a:lnSpc>
@@ -11472,7 +11340,7 @@
                       </a:endParaRPr>
                     </a:p>
                   </a:txBody>
-                  <a:tcPr marL="62230" marR="62230" marT="62230" marB="62230">
+                  <a:tcPr marL="62230" marR="62230" marT="62230" marB="62230" anchor="t">
                     <a:lnL w="12700" cap="flat" cmpd="sng" algn="ctr">
                       <a:solidFill>
                         <a:srgbClr val="474C56"/>
@@ -11516,7 +11384,7 @@
                     <a:bodyPr/>
                     <a:lstStyle/>
                     <a:p>
-                      <a:pPr marL="0" indent="0" algn="ctr">
+                      <a:pPr algn="ctr" indent="0" marL="0">
                         <a:lnSpc>
                           <a:spcPts val="1960"/>
                         </a:lnSpc>
@@ -11540,7 +11408,7 @@
                       </a:endParaRPr>
                     </a:p>
                   </a:txBody>
-                  <a:tcPr marL="62230" marR="62230" marT="62230" marB="62230">
+                  <a:tcPr marL="62230" marR="62230" marT="62230" marB="62230" anchor="t">
                     <a:lnL w="12700" cap="flat" cmpd="sng" algn="ctr">
                       <a:solidFill>
                         <a:srgbClr val="474C56"/>
@@ -11579,11 +11447,6 @@
                     </a:lnB>
                   </a:tcPr>
                 </a:tc>
-                <a:extLst>
-                  <a:ext uri="{0D108BD9-81ED-4DB2-BD59-A6C34878D82A}">
-                    <a16:rowId xmlns:a16="http://schemas.microsoft.com/office/drawing/2014/main" val="10005"/>
-                  </a:ext>
-                </a:extLst>
               </a:tr>
               <a:tr h="383540">
                 <a:tc>
@@ -11591,7 +11454,7 @@
                     <a:bodyPr/>
                     <a:lstStyle/>
                     <a:p>
-                      <a:pPr marL="0" indent="0">
+                      <a:pPr indent="0" marL="0">
                         <a:lnSpc>
                           <a:spcPts val="1960"/>
                         </a:lnSpc>
@@ -11615,7 +11478,7 @@
                       </a:endParaRPr>
                     </a:p>
                   </a:txBody>
-                  <a:tcPr marL="62230" marR="62230" marT="62230" marB="62230">
+                  <a:tcPr marL="62230" marR="62230" marT="62230" marB="62230" anchor="t">
                     <a:lnL w="12700" cap="flat" cmpd="sng" algn="ctr">
                       <a:solidFill>
                         <a:srgbClr val="474C56"/>
@@ -11659,7 +11522,7 @@
                     <a:bodyPr/>
                     <a:lstStyle/>
                     <a:p>
-                      <a:pPr marL="0" indent="0" algn="ctr">
+                      <a:pPr algn="ctr" indent="0" marL="0">
                         <a:lnSpc>
                           <a:spcPts val="1960"/>
                         </a:lnSpc>
@@ -11683,7 +11546,7 @@
                       </a:endParaRPr>
                     </a:p>
                   </a:txBody>
-                  <a:tcPr marL="62230" marR="62230" marT="62230" marB="62230">
+                  <a:tcPr marL="62230" marR="62230" marT="62230" marB="62230" anchor="t">
                     <a:lnL w="12700" cap="flat" cmpd="sng" algn="ctr">
                       <a:solidFill>
                         <a:srgbClr val="474C56"/>
@@ -11727,7 +11590,7 @@
                     <a:bodyPr/>
                     <a:lstStyle/>
                     <a:p>
-                      <a:pPr marL="0" indent="0" algn="ctr">
+                      <a:pPr algn="ctr" indent="0" marL="0">
                         <a:lnSpc>
                           <a:spcPts val="1960"/>
                         </a:lnSpc>
@@ -11751,7 +11614,7 @@
                       </a:endParaRPr>
                     </a:p>
                   </a:txBody>
-                  <a:tcPr marL="62230" marR="62230" marT="62230" marB="62230">
+                  <a:tcPr marL="62230" marR="62230" marT="62230" marB="62230" anchor="t">
                     <a:lnL w="12700" cap="flat" cmpd="sng" algn="ctr">
                       <a:solidFill>
                         <a:srgbClr val="474C56"/>
@@ -11790,11 +11653,6 @@
                     </a:lnB>
                   </a:tcPr>
                 </a:tc>
-                <a:extLst>
-                  <a:ext uri="{0D108BD9-81ED-4DB2-BD59-A6C34878D82A}">
-                    <a16:rowId xmlns:a16="http://schemas.microsoft.com/office/drawing/2014/main" val="10006"/>
-                  </a:ext>
-                </a:extLst>
               </a:tr>
             </a:tbl>
           </a:graphicData>
@@ -11816,7 +11674,6 @@
         <a:solidFill>
           <a:srgbClr val="070A12"/>
         </a:solidFill>
-        <a:effectLst/>
       </p:bgPr>
     </p:bg>
     <p:spTree>
@@ -11863,13 +11720,6 @@
           </a:gradFill>
           <a:ln/>
         </p:spPr>
-        <p:txBody>
-          <a:bodyPr/>
-          <a:lstStyle/>
-          <a:p>
-            <a:endParaRPr lang="en-US"/>
-          </a:p>
-        </p:txBody>
       </p:sp>
       <p:sp>
         <p:nvSpPr>
@@ -11894,14 +11744,14 @@
           </a:bodyPr>
           <a:lstStyle/>
           <a:p>
-            <a:pPr marL="0" indent="0" algn="l">
+            <a:pPr algn="l" indent="0" marL="0">
               <a:lnSpc>
                 <a:spcPts val="1960"/>
               </a:lnSpc>
               <a:buNone/>
             </a:pPr>
             <a:r>
-              <a:rPr lang="en-US" sz="1400" b="1" kern="0" spc="250" dirty="0">
+              <a:rPr lang="en-US" sz="1400" b="1" spc="250" kern="0" dirty="0">
                 <a:solidFill>
                   <a:srgbClr val="D9B650"/>
                 </a:solidFill>
@@ -11918,9 +11768,7 @@
       <p:sp>
         <p:nvSpPr>
           <p:cNvPr id="4" name="Text 2"/>
-          <p:cNvSpPr>
-            <a:spLocks noGrp="1"/>
-          </p:cNvSpPr>
+          <p:cNvSpPr/>
           <p:nvPr>
             <p:ph type="title"/>
           </p:nvPr>
@@ -11942,7 +11790,7 @@
           </a:bodyPr>
           <a:lstStyle/>
           <a:p>
-            <a:pPr marL="0" indent="0" algn="l">
+            <a:pPr algn="l" indent="0" marL="0">
               <a:lnSpc>
                 <a:spcPts val="4180"/>
               </a:lnSpc>
@@ -11993,13 +11841,6 @@
             <a:prstDash val="solid"/>
           </a:ln>
         </p:spPr>
-        <p:txBody>
-          <a:bodyPr/>
-          <a:lstStyle/>
-          <a:p>
-            <a:endParaRPr lang="en-US"/>
-          </a:p>
-        </p:txBody>
       </p:sp>
       <p:sp>
         <p:nvSpPr>
@@ -12024,7 +11865,7 @@
           </a:bodyPr>
           <a:lstStyle/>
           <a:p>
-            <a:pPr marL="0" indent="0" algn="l">
+            <a:pPr algn="l" indent="0" marL="0">
               <a:lnSpc>
                 <a:spcPts val="2280"/>
               </a:lnSpc>
@@ -12068,7 +11909,7 @@
           </a:bodyPr>
           <a:lstStyle/>
           <a:p>
-            <a:pPr marL="0" indent="0" algn="l">
+            <a:pPr algn="l" indent="0" marL="0">
               <a:lnSpc>
                 <a:spcPts val="2030"/>
               </a:lnSpc>
@@ -12119,13 +11960,6 @@
             <a:prstDash val="solid"/>
           </a:ln>
         </p:spPr>
-        <p:txBody>
-          <a:bodyPr/>
-          <a:lstStyle/>
-          <a:p>
-            <a:endParaRPr lang="en-US"/>
-          </a:p>
-        </p:txBody>
       </p:sp>
       <p:sp>
         <p:nvSpPr>
@@ -12150,7 +11984,7 @@
           </a:bodyPr>
           <a:lstStyle/>
           <a:p>
-            <a:pPr marL="0" indent="0" algn="l">
+            <a:pPr algn="l" indent="0" marL="0">
               <a:lnSpc>
                 <a:spcPts val="2280"/>
               </a:lnSpc>
@@ -12194,7 +12028,7 @@
           </a:bodyPr>
           <a:lstStyle/>
           <a:p>
-            <a:pPr marL="0" indent="0" algn="l">
+            <a:pPr algn="l" indent="0" marL="0">
               <a:lnSpc>
                 <a:spcPts val="2030"/>
               </a:lnSpc>
@@ -12245,13 +12079,6 @@
             <a:prstDash val="solid"/>
           </a:ln>
         </p:spPr>
-        <p:txBody>
-          <a:bodyPr/>
-          <a:lstStyle/>
-          <a:p>
-            <a:endParaRPr lang="en-US"/>
-          </a:p>
-        </p:txBody>
       </p:sp>
       <p:sp>
         <p:nvSpPr>
@@ -12276,7 +12103,7 @@
           </a:bodyPr>
           <a:lstStyle/>
           <a:p>
-            <a:pPr marL="0" indent="0" algn="l">
+            <a:pPr algn="l" indent="0" marL="0">
               <a:lnSpc>
                 <a:spcPts val="2280"/>
               </a:lnSpc>
@@ -12320,7 +12147,7 @@
           </a:bodyPr>
           <a:lstStyle/>
           <a:p>
-            <a:pPr marL="0" indent="0" algn="l">
+            <a:pPr algn="l" indent="0" marL="0">
               <a:lnSpc>
                 <a:spcPts val="2030"/>
               </a:lnSpc>
@@ -12364,7 +12191,7 @@
           </a:bodyPr>
           <a:lstStyle/>
           <a:p>
-            <a:pPr marL="0" indent="0" algn="l">
+            <a:pPr algn="l" indent="0" marL="0">
               <a:lnSpc>
                 <a:spcPts val="1680"/>
               </a:lnSpc>
@@ -12379,7 +12206,7 @@
                 <a:ea typeface="DM Sans" pitchFamily="34" charset="-122"/>
                 <a:cs typeface="DM Sans" pitchFamily="34" charset="-120"/>
               </a:rPr>
-              <a:t>The Windows 11 LLM report is also flagged: only 84% of its claims carry a citation.</a:t>
+              <a:t>The validator flags real reports too: Windows 11 is at 72% of claims cited, and Windows 7 was cut off before its risk score.</a:t>
             </a:r>
             <a:endParaRPr lang="en-US" sz="1200" dirty="0"/>
           </a:p>
@@ -12681,319 +12508,4 @@
   <a:objectDefaults/>
   <a:extraClrSchemeLst/>
 </a:theme>
-</file>
-
-<file path=ppt/theme/theme2.xml><?xml version="1.0" encoding="utf-8"?>
-<a:theme xmlns:a="http://schemas.openxmlformats.org/drawingml/2006/main" name="Office Theme">
-  <a:themeElements>
-    <a:clrScheme name="Office">
-      <a:dk1>
-        <a:sysClr val="windowText" lastClr="000000"/>
-      </a:dk1>
-      <a:lt1>
-        <a:sysClr val="window" lastClr="FFFFFF"/>
-      </a:lt1>
-      <a:dk2>
-        <a:srgbClr val="0E2841"/>
-      </a:dk2>
-      <a:lt2>
-        <a:srgbClr val="E8E8E8"/>
-      </a:lt2>
-      <a:accent1>
-        <a:srgbClr val="156082"/>
-      </a:accent1>
-      <a:accent2>
-        <a:srgbClr val="E97132"/>
-      </a:accent2>
-      <a:accent3>
-        <a:srgbClr val="196B24"/>
-      </a:accent3>
-      <a:accent4>
-        <a:srgbClr val="0F9ED5"/>
-      </a:accent4>
-      <a:accent5>
-        <a:srgbClr val="A02B93"/>
-      </a:accent5>
-      <a:accent6>
-        <a:srgbClr val="4EA72E"/>
-      </a:accent6>
-      <a:hlink>
-        <a:srgbClr val="467886"/>
-      </a:hlink>
-      <a:folHlink>
-        <a:srgbClr val="96607D"/>
-      </a:folHlink>
-    </a:clrScheme>
-    <a:fontScheme name="Office">
-      <a:majorFont>
-        <a:latin typeface="Aptos Display" panose="02110004020202020204"/>
-        <a:ea typeface=""/>
-        <a:cs typeface=""/>
-        <a:font script="Jpan" typeface="游ゴシック Light"/>
-        <a:font script="Hang" typeface="맑은 고딕"/>
-        <a:font script="Hans" typeface="等线 Light"/>
-        <a:font script="Hant" typeface="新細明體"/>
-        <a:font script="Arab" typeface="Times New Roman"/>
-        <a:font script="Hebr" typeface="Times New Roman"/>
-        <a:font script="Thai" typeface="Angsana New"/>
-        <a:font script="Ethi" typeface="Nyala"/>
-        <a:font script="Beng" typeface="Vrinda"/>
-        <a:font script="Gujr" typeface="Shruti"/>
-        <a:font script="Khmr" typeface="MoolBoran"/>
-        <a:font script="Knda" typeface="Tunga"/>
-        <a:font script="Guru" typeface="Raavi"/>
-        <a:font script="Cans" typeface="Euphemia"/>
-        <a:font script="Cher" typeface="Plantagenet Cherokee"/>
-        <a:font script="Yiii" typeface="Microsoft Yi Baiti"/>
-        <a:font script="Tibt" typeface="Microsoft Himalaya"/>
-        <a:font script="Thaa" typeface="MV Boli"/>
-        <a:font script="Deva" typeface="Mangal"/>
-        <a:font script="Telu" typeface="Gautami"/>
-        <a:font script="Taml" typeface="Latha"/>
-        <a:font script="Syrc" typeface="Estrangelo Edessa"/>
-        <a:font script="Orya" typeface="Kalinga"/>
-        <a:font script="Mlym" typeface="Kartika"/>
-        <a:font script="Laoo" typeface="DokChampa"/>
-        <a:font script="Sinh" typeface="Iskoola Pota"/>
-        <a:font script="Mong" typeface="Mongolian Baiti"/>
-        <a:font script="Viet" typeface="Times New Roman"/>
-        <a:font script="Uigh" typeface="Microsoft Uighur"/>
-        <a:font script="Geor" typeface="Sylfaen"/>
-        <a:font script="Armn" typeface="Arial"/>
-        <a:font script="Bugi" typeface="Leelawadee UI"/>
-        <a:font script="Bopo" typeface="Microsoft JhengHei"/>
-        <a:font script="Java" typeface="Javanese Text"/>
-        <a:font script="Lisu" typeface="Segoe UI"/>
-        <a:font script="Mymr" typeface="Myanmar Text"/>
-        <a:font script="Nkoo" typeface="Ebrima"/>
-        <a:font script="Olck" typeface="Nirmala UI"/>
-        <a:font script="Osma" typeface="Ebrima"/>
-        <a:font script="Phag" typeface="Phagspa"/>
-        <a:font script="Syrn" typeface="Estrangelo Edessa"/>
-        <a:font script="Syrj" typeface="Estrangelo Edessa"/>
-        <a:font script="Syre" typeface="Estrangelo Edessa"/>
-        <a:font script="Sora" typeface="Nirmala UI"/>
-        <a:font script="Tale" typeface="Microsoft Tai Le"/>
-        <a:font script="Talu" typeface="Microsoft New Tai Lue"/>
-        <a:font script="Tfng" typeface="Ebrima"/>
-      </a:majorFont>
-      <a:minorFont>
-        <a:latin typeface="Aptos" panose="02110004020202020204"/>
-        <a:ea typeface=""/>
-        <a:cs typeface=""/>
-        <a:font script="Jpan" typeface="游ゴシック"/>
-        <a:font script="Hang" typeface="맑은 고딕"/>
-        <a:font script="Hans" typeface="等线"/>
-        <a:font script="Hant" typeface="新細明體"/>
-        <a:font script="Arab" typeface="Arial"/>
-        <a:font script="Hebr" typeface="Arial"/>
-        <a:font script="Thai" typeface="Cordia New"/>
-        <a:font script="Ethi" typeface="Nyala"/>
-        <a:font script="Beng" typeface="Vrinda"/>
-        <a:font script="Gujr" typeface="Shruti"/>
-        <a:font script="Khmr" typeface="DaunPenh"/>
-        <a:font script="Knda" typeface="Tunga"/>
-        <a:font script="Guru" typeface="Raavi"/>
-        <a:font script="Cans" typeface="Euphemia"/>
-        <a:font script="Cher" typeface="Plantagenet Cherokee"/>
-        <a:font script="Yiii" typeface="Microsoft Yi Baiti"/>
-        <a:font script="Tibt" typeface="Microsoft Himalaya"/>
-        <a:font script="Thaa" typeface="MV Boli"/>
-        <a:font script="Deva" typeface="Mangal"/>
-        <a:font script="Telu" typeface="Gautami"/>
-        <a:font script="Taml" typeface="Latha"/>
-        <a:font script="Syrc" typeface="Estrangelo Edessa"/>
-        <a:font script="Orya" typeface="Kalinga"/>
-        <a:font script="Mlym" typeface="Kartika"/>
-        <a:font script="Laoo" typeface="DokChampa"/>
-        <a:font script="Sinh" typeface="Iskoola Pota"/>
-        <a:font script="Mong" typeface="Mongolian Baiti"/>
-        <a:font script="Viet" typeface="Arial"/>
-        <a:font script="Uigh" typeface="Microsoft Uighur"/>
-        <a:font script="Geor" typeface="Sylfaen"/>
-        <a:font script="Armn" typeface="Arial"/>
-        <a:font script="Bugi" typeface="Leelawadee UI"/>
-        <a:font script="Bopo" typeface="Microsoft JhengHei"/>
-        <a:font script="Java" typeface="Javanese Text"/>
-        <a:font script="Lisu" typeface="Segoe UI"/>
-        <a:font script="Mymr" typeface="Myanmar Text"/>
-        <a:font script="Nkoo" typeface="Ebrima"/>
-        <a:font script="Olck" typeface="Nirmala UI"/>
-        <a:font script="Osma" typeface="Ebrima"/>
-        <a:font script="Phag" typeface="Phagspa"/>
-        <a:font script="Syrn" typeface="Estrangelo Edessa"/>
-        <a:font script="Syrj" typeface="Estrangelo Edessa"/>
-        <a:font script="Syre" typeface="Estrangelo Edessa"/>
-        <a:font script="Sora" typeface="Nirmala UI"/>
-        <a:font script="Tale" typeface="Microsoft Tai Le"/>
-        <a:font script="Talu" typeface="Microsoft New Tai Lue"/>
-        <a:font script="Tfng" typeface="Ebrima"/>
-      </a:minorFont>
-    </a:fontScheme>
-    <a:fmtScheme name="Office">
-      <a:fillStyleLst>
-        <a:solidFill>
-          <a:schemeClr val="phClr"/>
-        </a:solidFill>
-        <a:gradFill rotWithShape="1">
-          <a:gsLst>
-            <a:gs pos="0">
-              <a:schemeClr val="phClr">
-                <a:lumMod val="110000"/>
-                <a:satMod val="105000"/>
-                <a:tint val="67000"/>
-              </a:schemeClr>
-            </a:gs>
-            <a:gs pos="50000">
-              <a:schemeClr val="phClr">
-                <a:lumMod val="105000"/>
-                <a:satMod val="103000"/>
-                <a:tint val="73000"/>
-              </a:schemeClr>
-            </a:gs>
-            <a:gs pos="100000">
-              <a:schemeClr val="phClr">
-                <a:lumMod val="105000"/>
-                <a:satMod val="109000"/>
-                <a:tint val="81000"/>
-              </a:schemeClr>
-            </a:gs>
-          </a:gsLst>
-          <a:lin ang="5400000" scaled="0"/>
-        </a:gradFill>
-        <a:gradFill rotWithShape="1">
-          <a:gsLst>
-            <a:gs pos="0">
-              <a:schemeClr val="phClr">
-                <a:satMod val="103000"/>
-                <a:lumMod val="102000"/>
-                <a:tint val="94000"/>
-              </a:schemeClr>
-            </a:gs>
-            <a:gs pos="50000">
-              <a:schemeClr val="phClr">
-                <a:satMod val="110000"/>
-                <a:lumMod val="100000"/>
-                <a:shade val="100000"/>
-              </a:schemeClr>
-            </a:gs>
-            <a:gs pos="100000">
-              <a:schemeClr val="phClr">
-                <a:lumMod val="99000"/>
-                <a:satMod val="120000"/>
-                <a:shade val="78000"/>
-              </a:schemeClr>
-            </a:gs>
-          </a:gsLst>
-          <a:lin ang="5400000" scaled="0"/>
-        </a:gradFill>
-      </a:fillStyleLst>
-      <a:lnStyleLst>
-        <a:ln w="12700" cap="flat" cmpd="sng" algn="ctr">
-          <a:solidFill>
-            <a:schemeClr val="phClr"/>
-          </a:solidFill>
-          <a:prstDash val="solid"/>
-          <a:miter lim="800000"/>
-        </a:ln>
-        <a:ln w="19050" cap="flat" cmpd="sng" algn="ctr">
-          <a:solidFill>
-            <a:schemeClr val="phClr"/>
-          </a:solidFill>
-          <a:prstDash val="solid"/>
-          <a:miter lim="800000"/>
-        </a:ln>
-        <a:ln w="25400" cap="flat" cmpd="sng" algn="ctr">
-          <a:solidFill>
-            <a:schemeClr val="phClr"/>
-          </a:solidFill>
-          <a:prstDash val="solid"/>
-          <a:miter lim="800000"/>
-        </a:ln>
-      </a:lnStyleLst>
-      <a:effectStyleLst>
-        <a:effectStyle>
-          <a:effectLst/>
-        </a:effectStyle>
-        <a:effectStyle>
-          <a:effectLst/>
-        </a:effectStyle>
-        <a:effectStyle>
-          <a:effectLst>
-            <a:outerShdw blurRad="57150" dist="19050" dir="5400000" algn="ctr" rotWithShape="0">
-              <a:srgbClr val="000000">
-                <a:alpha val="63000"/>
-              </a:srgbClr>
-            </a:outerShdw>
-          </a:effectLst>
-        </a:effectStyle>
-      </a:effectStyleLst>
-      <a:bgFillStyleLst>
-        <a:solidFill>
-          <a:schemeClr val="phClr"/>
-        </a:solidFill>
-        <a:solidFill>
-          <a:schemeClr val="phClr">
-            <a:tint val="95000"/>
-            <a:satMod val="170000"/>
-          </a:schemeClr>
-        </a:solidFill>
-        <a:gradFill rotWithShape="1">
-          <a:gsLst>
-            <a:gs pos="0">
-              <a:schemeClr val="phClr">
-                <a:tint val="93000"/>
-                <a:satMod val="150000"/>
-                <a:shade val="98000"/>
-                <a:lumMod val="102000"/>
-              </a:schemeClr>
-            </a:gs>
-            <a:gs pos="50000">
-              <a:schemeClr val="phClr">
-                <a:tint val="98000"/>
-                <a:satMod val="130000"/>
-                <a:shade val="90000"/>
-                <a:lumMod val="103000"/>
-              </a:schemeClr>
-            </a:gs>
-            <a:gs pos="100000">
-              <a:schemeClr val="phClr">
-                <a:shade val="63000"/>
-                <a:satMod val="120000"/>
-              </a:schemeClr>
-            </a:gs>
-          </a:gsLst>
-          <a:lin ang="5400000" scaled="0"/>
-        </a:gradFill>
-      </a:bgFillStyleLst>
-    </a:fmtScheme>
-  </a:themeElements>
-  <a:objectDefaults>
-    <a:lnDef>
-      <a:spPr/>
-      <a:bodyPr/>
-      <a:lstStyle/>
-      <a:style>
-        <a:lnRef idx="2">
-          <a:schemeClr val="accent1"/>
-        </a:lnRef>
-        <a:fillRef idx="0">
-          <a:schemeClr val="accent1"/>
-        </a:fillRef>
-        <a:effectRef idx="1">
-          <a:schemeClr val="accent1"/>
-        </a:effectRef>
-        <a:fontRef idx="minor">
-          <a:schemeClr val="tx1"/>
-        </a:fontRef>
-      </a:style>
-    </a:lnDef>
-  </a:objectDefaults>
-  <a:extraClrSchemeLst/>
-  <a:extLst>
-    <a:ext uri="{05A4C25C-085E-4340-85A3-A5531E510DB2}">
-      <thm15:themeFamily xmlns:thm15="http://schemas.microsoft.com/office/thememl/2012/main" name="Office Theme" id="{2E142A2C-CD16-42D6-873A-C26D2A0506FA}" vid="{1BDDFF52-6CD6-40A5-AB3C-68EB2F1E4D0A}"/>
-    </a:ext>
-  </a:extLst>
-</a:theme>
 </file>
</xml_diff>

<commit_message>
Revised Red Team stats w defense
</commit_message>
<xml_diff>
--- a/TriageGuard Progress Evaluation.pptx
+++ b/TriageGuard Progress Evaluation.pptx
@@ -1215,7 +1215,7 @@
           <a:p>
             <a:r>
               <a:rPr lang="en-US" dirty="0"/>
-              <a:t>Attack success rate is the share of reports that did what the attacker wanted. 4 of 36 without defences, 1 of 36 with them, and none of the successful reports reached a reader without a validation warning. Citation coverage goes from 28 to 78 percent. The one defended success was an attack that failed undefended, which shows how noisy 6 trials are. All 78 reports and the CSV are saved in the repo. If asked: an earlier version of our checker only recognised square-bracket citations and the model sometimes writes fullwidth brackets, which inflated one attack; we fixed it and re-scored.</a:t>
+              <a:t>Attack success rate is the share of reports that did what the attacker wanted. 4 of 36 without defences, 0 of 36 with them. Citation coverage goes from 28 to 78 percent. Zero of 36 at this size does not prove zero risk. All 78 reports and the CSV are saved in the repo. If asked about the scoring: we found and fixed two mistakes in our own checker (the model sometimes writes fullwidth brackets or bold finding ids instead of square brackets) and re-scored all 78 reports offline, which is why earlier drafts showed 7 of 36 and 2 of 36.</a:t>
             </a:r>
             <a:endParaRPr lang="en-US" dirty="0"/>
           </a:p>
@@ -4996,7 +4996,7 @@
                 <a:ea typeface="DM Sans" pitchFamily="34" charset="-122"/>
                 <a:cs typeface="DM Sans" pitchFamily="34" charset="-120"/>
               </a:rPr>
-              <a:t>Dashboard, 27 tests, literature survey</a:t>
+              <a:t>Dashboard, 28 tests, literature survey</a:t>
             </a:r>
             <a:endParaRPr lang="en-US" sz="1450" dirty="0"/>
           </a:p>
@@ -6389,13 +6389,13 @@
           <a:gradFill rotWithShape="1">
             <a:gsLst>
               <a:gs pos="0">
-                <a:srgbClr val="9B8AE8">
-                  <a:alpha val="28000"/>
+                <a:srgbClr val="5CCFC0">
+                  <a:alpha val="8000"/>
                 </a:srgbClr>
               </a:gs>
               <a:gs pos="100000">
-                <a:srgbClr val="F472B6">
-                  <a:alpha val="20000"/>
+                <a:srgbClr val="8FA8F0">
+                  <a:alpha val="8000"/>
                 </a:srgbClr>
               </a:gs>
             </a:gsLst>
@@ -9976,7 +9976,7 @@
                 <a:ea typeface="Space Grotesk" pitchFamily="34" charset="-122"/>
                 <a:cs typeface="Space Grotesk" pitchFamily="34" charset="-120"/>
               </a:rPr>
-              <a:t>4/36 to 1/36</a:t>
+              <a:t>4/36 to 0/36</a:t>
             </a:r>
             <a:endParaRPr lang="en-US" sz="4000" dirty="0"/>
           </a:p>
@@ -11518,7 +11518,7 @@
                           <a:ea typeface="DM Sans" pitchFamily="34" charset="-122"/>
                           <a:cs typeface="DM Sans" pitchFamily="34" charset="-120"/>
                         </a:rPr>
-                        <a:t>1/6</a:t>
+                        <a:t>0/6</a:t>
                       </a:r>
                       <a:endParaRPr lang="en-US" sz="1400" dirty="0">
                         <a:latin typeface="DM Sans" charset="0"/>
@@ -11999,7 +11999,7 @@
                 <a:ea typeface="Space Grotesk" pitchFamily="34" charset="-122"/>
                 <a:cs typeface="Space Grotesk" pitchFamily="34" charset="-120"/>
               </a:rPr>
-              <a:t>Noise at this size</a:t>
+              <a:t>Small samples</a:t>
             </a:r>
             <a:endParaRPr lang="en-US" sz="1900" dirty="0"/>
           </a:p>
@@ -12043,7 +12043,7 @@
                 <a:ea typeface="DM Sans" pitchFamily="34" charset="-122"/>
                 <a:cs typeface="DM Sans" pitchFamily="34" charset="-120"/>
               </a:rPr>
-              <a:t>Only 6 trials per attack. One defended report was fooled while its undefended twin was not.</a:t>
+              <a:t>Only 6 trials per attack. Zero fooled reports out of 36 does not prove zero risk.</a:t>
             </a:r>
             <a:endParaRPr lang="en-US" sz="1400" dirty="0"/>
           </a:p>

</xml_diff>

<commit_message>
Deck: GitHub link, sixth RSA test, planted-data results, contribution slide
</commit_message>
<xml_diff>
--- a/TriageGuard Progress Evaluation.pptx
+++ b/TriageGuard Progress Evaluation.pptx
@@ -15,6 +15,7 @@
     <p:sldId id="263" r:id="rId9"/>
     <p:sldId id="264" r:id="rId10"/>
     <p:sldId id="265" r:id="rId11"/>
+    <p:sldId id="266" r:id="rId17"/>
   </p:sldIdLst>
   <p:notesMasterIdLst>
     <p:notesMasterId r:id="rId12"/>
@@ -2523,7 +2524,7 @@
                 <a:ea typeface="DM Sans" pitchFamily="34" charset="-122"/>
                 <a:cs typeface="DM Sans" pitchFamily="34" charset="-120"/>
               </a:rPr>
-              <a:t>Our own VM and known keys: measure what we find and the false alarms</a:t>
+              <a:t>Synthetic test done. Next: our own VM and known keys, to measure false alarms</a:t>
             </a:r>
             <a:endParaRPr lang="en-US" sz="1400" dirty="0"/>
           </a:p>
@@ -3153,6 +3154,547 @@
           </a:gradFill>
           <a:ln/>
         </p:spPr>
+      </p:sp>
+    </p:spTree>
+  </p:cSld>
+  <p:clrMapOvr>
+    <a:masterClrMapping/>
+  </p:clrMapOvr>
+</p:sld>
+</file>
+
+<file path=ppt/slides/slide11.xml><?xml version="1.0" encoding="utf-8"?>
+<p:sld xmlns:a="http://schemas.openxmlformats.org/drawingml/2006/main" xmlns:p="http://schemas.openxmlformats.org/presentationml/2006/main" xmlns:r="http://schemas.openxmlformats.org/officeDocument/2006/relationships">
+  <p:cSld>
+    <p:spTree>
+      <p:nvGrpSpPr>
+        <p:cNvPr id="1" name=""/>
+        <p:cNvGrpSpPr/>
+        <p:nvPr/>
+      </p:nvGrpSpPr>
+      <p:grpSpPr/>
+      <p:sp>
+        <p:nvSpPr>
+          <p:cNvPr id="2" name="Shape 0"/>
+          <p:cNvSpPr/>
+          <p:nvPr/>
+        </p:nvSpPr>
+        <p:spPr>
+          <a:xfrm>
+            <a:off x="0" y="0"/>
+            <a:ext cx="12192000" cy="6858000"/>
+          </a:xfrm>
+          <a:prstGeom prst="rect">
+            <a:avLst/>
+          </a:prstGeom>
+          <a:gradFill rotWithShape="1">
+            <a:gsLst>
+              <a:gs pos="0">
+                <a:srgbClr val="070A12"/>
+              </a:gs>
+              <a:gs pos="55000">
+                <a:srgbClr val="0B1020"/>
+              </a:gs>
+              <a:gs pos="100000">
+                <a:srgbClr val="101830"/>
+              </a:gs>
+            </a:gsLst>
+            <a:lin ang="2700000" scaled="0"/>
+          </a:gradFill>
+          <a:ln/>
+        </p:spPr>
+      </p:sp>
+      <p:sp>
+        <p:nvSpPr>
+          <p:cNvPr id="3" name="Text 1"/>
+          <p:cNvSpPr/>
+          <p:nvPr/>
+        </p:nvSpPr>
+        <p:spPr>
+          <a:xfrm>
+            <a:off x="812800" y="812800"/>
+            <a:ext cx="10883392" cy="274320"/>
+          </a:xfrm>
+          <a:prstGeom prst="rect">
+            <a:avLst/>
+          </a:prstGeom>
+          <a:noFill/>
+          <a:ln/>
+        </p:spPr>
+        <p:txBody>
+          <a:bodyPr wrap="square" lIns="0" tIns="0" rIns="0" bIns="0" rtlCol="0" anchor="t">
+            <a:normAutofit/>
+          </a:bodyPr>
+          <a:lstStyle/>
+          <a:p>
+            <a:pPr algn="l" indent="0" marL="0">
+              <a:lnSpc>
+                <a:spcPts val="1960"/>
+              </a:lnSpc>
+              <a:buNone/>
+            </a:pPr>
+            <a:r>
+              <a:rPr lang="en-US" sz="1400" b="1" spc="250" kern="0" dirty="0">
+                <a:solidFill>
+                  <a:srgbClr val="D9B650"/>
+                </a:solidFill>
+                <a:latin typeface="DM Sans" pitchFamily="34" charset="0"/>
+                <a:ea typeface="DM Sans" pitchFamily="34" charset="-122"/>
+                <a:cs typeface="DM Sans" pitchFamily="34" charset="-120"/>
+              </a:rPr>
+              <a:t>TEAM</a:t>
+            </a:r>
+            <a:endParaRPr lang="en-US" sz="1400" dirty="0"/>
+          </a:p>
+        </p:txBody>
+      </p:sp>
+      <p:sp>
+        <p:nvSpPr>
+          <p:cNvPr id="4" name="Text 2"/>
+          <p:cNvSpPr/>
+          <p:nvPr>
+            <p:ph type="title"/>
+          </p:nvPr>
+        </p:nvSpPr>
+        <p:spPr>
+          <a:xfrm>
+            <a:off x="812800" y="1163321"/>
+            <a:ext cx="10883392" cy="556260"/>
+          </a:xfrm>
+          <a:prstGeom prst="rect">
+            <a:avLst/>
+          </a:prstGeom>
+          <a:noFill/>
+          <a:ln/>
+        </p:spPr>
+        <p:txBody>
+          <a:bodyPr wrap="square" lIns="0" tIns="0" rIns="0" bIns="0" rtlCol="0" anchor="t">
+            <a:normAutofit/>
+          </a:bodyPr>
+          <a:lstStyle/>
+          <a:p>
+            <a:pPr algn="l" indent="0" marL="0">
+              <a:lnSpc>
+                <a:spcPts val="4180"/>
+              </a:lnSpc>
+              <a:buNone/>
+            </a:pPr>
+            <a:r>
+              <a:rPr lang="en-US" sz="3800" b="1" i="0" dirty="0">
+                <a:solidFill>
+                  <a:srgbClr val="E4E8F2"/>
+                </a:solidFill>
+                <a:latin typeface="Space Grotesk" pitchFamily="34" charset="0"/>
+                <a:ea typeface="Space Grotesk" pitchFamily="34" charset="-122"/>
+                <a:cs typeface="Space Grotesk" pitchFamily="34" charset="-120"/>
+              </a:rPr>
+              <a:t>Who did what</a:t>
+            </a:r>
+            <a:endParaRPr lang="en-US" sz="3800" dirty="0"/>
+          </a:p>
+        </p:txBody>
+      </p:sp>
+      <p:sp>
+        <p:nvSpPr>
+          <p:cNvPr id="5" name="Shape 3"/>
+          <p:cNvSpPr/>
+          <p:nvPr/>
+        </p:nvSpPr>
+        <p:spPr>
+          <a:xfrm>
+            <a:off x="815975" y="1951354"/>
+            <a:ext cx="3397250" cy="2150000"/>
+          </a:xfrm>
+          <a:prstGeom prst="roundRect">
+            <a:avLst>
+              <a:gd name="adj" fmla="val 8532"/>
+            </a:avLst>
+          </a:prstGeom>
+          <a:solidFill>
+            <a:srgbClr val="FFFFFF">
+              <a:alpha val="4000"/>
+            </a:srgbClr>
+          </a:solidFill>
+          <a:ln w="6350">
+            <a:solidFill>
+              <a:srgbClr val="D9B650">
+                <a:alpha val="30000"/>
+              </a:srgbClr>
+            </a:solidFill>
+            <a:prstDash val="solid"/>
+          </a:ln>
+        </p:spPr>
+      </p:sp>
+      <p:sp>
+        <p:nvSpPr>
+          <p:cNvPr id="6" name="Text 4"/>
+          <p:cNvSpPr/>
+          <p:nvPr/>
+        </p:nvSpPr>
+        <p:spPr>
+          <a:xfrm>
+            <a:off x="1033780" y="2169164"/>
+            <a:ext cx="3050489" cy="314960"/>
+          </a:xfrm>
+          <a:prstGeom prst="rect">
+            <a:avLst/>
+          </a:prstGeom>
+          <a:noFill/>
+          <a:ln/>
+        </p:spPr>
+        <p:txBody>
+          <a:bodyPr wrap="square" lIns="0" tIns="0" rIns="0" bIns="0" rtlCol="0" anchor="t">
+            <a:normAutofit/>
+          </a:bodyPr>
+          <a:lstStyle/>
+          <a:p>
+            <a:pPr algn="l" indent="0" marL="0">
+              <a:lnSpc>
+                <a:spcPts val="2280"/>
+              </a:lnSpc>
+              <a:buNone/>
+            </a:pPr>
+            <a:r>
+              <a:rPr lang="en-US" sz="1900" b="1" dirty="0">
+                <a:solidFill>
+                  <a:srgbClr val="D9B650"/>
+                </a:solidFill>
+                <a:latin typeface="Space Grotesk" pitchFamily="34" charset="0"/>
+                <a:ea typeface="Space Grotesk" pitchFamily="34" charset="-122"/>
+                <a:cs typeface="Space Grotesk" pitchFamily="34" charset="-120"/>
+              </a:rPr>
+              <a:t>Sagnik Basu</a:t>
+            </a:r>
+            <a:endParaRPr lang="en-US" sz="1900" dirty="0"/>
+          </a:p>
+        </p:txBody>
+      </p:sp>
+      <p:sp>
+        <p:nvSpPr>
+          <p:cNvPr id="7" name="Text 5"/>
+          <p:cNvSpPr/>
+          <p:nvPr/>
+        </p:nvSpPr>
+        <p:spPr>
+          <a:xfrm>
+            <a:off x="1033780" y="2560321"/>
+            <a:ext cx="3050489" cy="1600000"/>
+          </a:xfrm>
+          <a:prstGeom prst="rect">
+            <a:avLst/>
+          </a:prstGeom>
+          <a:noFill/>
+          <a:ln/>
+        </p:spPr>
+        <p:txBody>
+          <a:bodyPr wrap="square" lIns="0" tIns="0" rIns="0" bIns="0" rtlCol="0" anchor="t">
+            <a:normAutofit/>
+          </a:bodyPr>
+          <a:lstStyle/>
+          <a:p>
+            <a:pPr algn="l" indent="0" marL="0">
+              <a:lnSpc>
+                <a:spcPts val="2030"/>
+              </a:lnSpc>
+              <a:buNone/>
+            </a:pPr>
+            <a:r>
+              <a:rPr lang="en-US" sz="1400" dirty="0">
+                <a:solidFill>
+                  <a:srgbClr val="E4E8F2"/>
+                </a:solidFill>
+                <a:latin typeface="DM Sans" pitchFamily="34" charset="0"/>
+                <a:ea typeface="DM Sans" pitchFamily="34" charset="-122"/>
+                <a:cs typeface="DM Sans" pitchFamily="34" charset="-120"/>
+              </a:rPr>
+              <a:t>Architecture and pipeline wiring, SQLite store, memory stage and real-dump tuning, crypto module, LLM report and its defences, red team, dashboard</a:t>
+            </a:r>
+            <a:endParaRPr lang="en-US" sz="1400" dirty="0"/>
+          </a:p>
+        </p:txBody>
+      </p:sp>
+      <p:sp>
+        <p:nvSpPr>
+          <p:cNvPr id="8" name="Shape 6"/>
+          <p:cNvSpPr/>
+          <p:nvPr/>
+        </p:nvSpPr>
+        <p:spPr>
+          <a:xfrm>
+            <a:off x="4397375" y="1951354"/>
+            <a:ext cx="3397250" cy="2150000"/>
+          </a:xfrm>
+          <a:prstGeom prst="roundRect">
+            <a:avLst>
+              <a:gd name="adj" fmla="val 8532"/>
+            </a:avLst>
+          </a:prstGeom>
+          <a:solidFill>
+            <a:srgbClr val="FFFFFF">
+              <a:alpha val="4000"/>
+            </a:srgbClr>
+          </a:solidFill>
+          <a:ln w="6350">
+            <a:solidFill>
+              <a:srgbClr val="8FA8F0">
+                <a:alpha val="30000"/>
+              </a:srgbClr>
+            </a:solidFill>
+            <a:prstDash val="solid"/>
+          </a:ln>
+        </p:spPr>
+      </p:sp>
+      <p:sp>
+        <p:nvSpPr>
+          <p:cNvPr id="9" name="Text 7"/>
+          <p:cNvSpPr/>
+          <p:nvPr/>
+        </p:nvSpPr>
+        <p:spPr>
+          <a:xfrm>
+            <a:off x="4615180" y="2169164"/>
+            <a:ext cx="3050489" cy="314960"/>
+          </a:xfrm>
+          <a:prstGeom prst="rect">
+            <a:avLst/>
+          </a:prstGeom>
+          <a:noFill/>
+          <a:ln/>
+        </p:spPr>
+        <p:txBody>
+          <a:bodyPr wrap="square" lIns="0" tIns="0" rIns="0" bIns="0" rtlCol="0" anchor="t">
+            <a:normAutofit/>
+          </a:bodyPr>
+          <a:lstStyle/>
+          <a:p>
+            <a:pPr algn="l" indent="0" marL="0">
+              <a:lnSpc>
+                <a:spcPts val="2280"/>
+              </a:lnSpc>
+              <a:buNone/>
+            </a:pPr>
+            <a:r>
+              <a:rPr lang="en-US" sz="1900" b="1" dirty="0">
+                <a:solidFill>
+                  <a:srgbClr val="8FA8F0"/>
+                </a:solidFill>
+                <a:latin typeface="Space Grotesk" pitchFamily="34" charset="0"/>
+                <a:ea typeface="Space Grotesk" pitchFamily="34" charset="-122"/>
+                <a:cs typeface="Space Grotesk" pitchFamily="34" charset="-120"/>
+              </a:rPr>
+              <a:t>Arjun Mittal</a:t>
+            </a:r>
+            <a:endParaRPr lang="en-US" sz="1900" dirty="0"/>
+          </a:p>
+        </p:txBody>
+      </p:sp>
+      <p:sp>
+        <p:nvSpPr>
+          <p:cNvPr id="10" name="Text 8"/>
+          <p:cNvSpPr/>
+          <p:nvPr/>
+        </p:nvSpPr>
+        <p:spPr>
+          <a:xfrm>
+            <a:off x="4615180" y="2560321"/>
+            <a:ext cx="3050489" cy="1600000"/>
+          </a:xfrm>
+          <a:prstGeom prst="rect">
+            <a:avLst/>
+          </a:prstGeom>
+          <a:noFill/>
+          <a:ln/>
+        </p:spPr>
+        <p:txBody>
+          <a:bodyPr wrap="square" lIns="0" tIns="0" rIns="0" bIns="0" rtlCol="0" anchor="t">
+            <a:normAutofit/>
+          </a:bodyPr>
+          <a:lstStyle/>
+          <a:p>
+            <a:pPr algn="l" indent="0" marL="0">
+              <a:lnSpc>
+                <a:spcPts val="2030"/>
+              </a:lnSpc>
+              <a:buNone/>
+            </a:pPr>
+            <a:r>
+              <a:rPr lang="en-US" sz="1400" dirty="0">
+                <a:solidFill>
+                  <a:srgbClr val="E4E8F2"/>
+                </a:solidFill>
+                <a:latin typeface="DM Sans" pitchFamily="34" charset="0"/>
+                <a:ea typeface="DM Sans" pitchFamily="34" charset="-122"/>
+                <a:cs typeface="DM Sans" pitchFamily="34" charset="-120"/>
+              </a:rPr>
+              <a:t>Credential module (JWT, OAuth, OTP), network and TLS module, static analysis and YARA rules, literature survey</a:t>
+            </a:r>
+            <a:endParaRPr lang="en-US" sz="1400" dirty="0"/>
+          </a:p>
+        </p:txBody>
+      </p:sp>
+      <p:sp>
+        <p:nvSpPr>
+          <p:cNvPr id="11" name="Shape 9"/>
+          <p:cNvSpPr/>
+          <p:nvPr/>
+        </p:nvSpPr>
+        <p:spPr>
+          <a:xfrm>
+            <a:off x="7978775" y="1951354"/>
+            <a:ext cx="3397250" cy="2150000"/>
+          </a:xfrm>
+          <a:prstGeom prst="roundRect">
+            <a:avLst>
+              <a:gd name="adj" fmla="val 8532"/>
+            </a:avLst>
+          </a:prstGeom>
+          <a:solidFill>
+            <a:srgbClr val="FFFFFF">
+              <a:alpha val="4000"/>
+            </a:srgbClr>
+          </a:solidFill>
+          <a:ln w="6350">
+            <a:solidFill>
+              <a:srgbClr val="5CCFC0">
+                <a:alpha val="30000"/>
+              </a:srgbClr>
+            </a:solidFill>
+            <a:prstDash val="solid"/>
+          </a:ln>
+        </p:spPr>
+      </p:sp>
+      <p:sp>
+        <p:nvSpPr>
+          <p:cNvPr id="12" name="Text 10"/>
+          <p:cNvSpPr/>
+          <p:nvPr/>
+        </p:nvSpPr>
+        <p:spPr>
+          <a:xfrm>
+            <a:off x="8196580" y="2169164"/>
+            <a:ext cx="3050489" cy="314960"/>
+          </a:xfrm>
+          <a:prstGeom prst="rect">
+            <a:avLst/>
+          </a:prstGeom>
+          <a:noFill/>
+          <a:ln/>
+        </p:spPr>
+        <p:txBody>
+          <a:bodyPr wrap="square" lIns="0" tIns="0" rIns="0" bIns="0" rtlCol="0" anchor="t">
+            <a:normAutofit/>
+          </a:bodyPr>
+          <a:lstStyle/>
+          <a:p>
+            <a:pPr algn="l" indent="0" marL="0">
+              <a:lnSpc>
+                <a:spcPts val="2280"/>
+              </a:lnSpc>
+              <a:buNone/>
+            </a:pPr>
+            <a:r>
+              <a:rPr lang="en-US" sz="1900" b="1" dirty="0">
+                <a:solidFill>
+                  <a:srgbClr val="5CCFC0"/>
+                </a:solidFill>
+                <a:latin typeface="Space Grotesk" pitchFamily="34" charset="0"/>
+                <a:ea typeface="Space Grotesk" pitchFamily="34" charset="-122"/>
+                <a:cs typeface="Space Grotesk" pitchFamily="34" charset="-120"/>
+              </a:rPr>
+              <a:t>Both of us</a:t>
+            </a:r>
+            <a:endParaRPr lang="en-US" sz="1900" dirty="0"/>
+          </a:p>
+        </p:txBody>
+      </p:sp>
+      <p:sp>
+        <p:nvSpPr>
+          <p:cNvPr id="13" name="Text 11"/>
+          <p:cNvSpPr/>
+          <p:nvPr/>
+        </p:nvSpPr>
+        <p:spPr>
+          <a:xfrm>
+            <a:off x="8196580" y="2560321"/>
+            <a:ext cx="3050489" cy="1600000"/>
+          </a:xfrm>
+          <a:prstGeom prst="rect">
+            <a:avLst/>
+          </a:prstGeom>
+          <a:noFill/>
+          <a:ln/>
+        </p:spPr>
+        <p:txBody>
+          <a:bodyPr wrap="square" lIns="0" tIns="0" rIns="0" bIns="0" rtlCol="0" anchor="t">
+            <a:normAutofit/>
+          </a:bodyPr>
+          <a:lstStyle/>
+          <a:p>
+            <a:pPr algn="l" indent="0" marL="0">
+              <a:lnSpc>
+                <a:spcPts val="2030"/>
+              </a:lnSpc>
+              <a:buNone/>
+            </a:pPr>
+            <a:r>
+              <a:rPr lang="en-US" sz="1400" dirty="0">
+                <a:solidFill>
+                  <a:srgbClr val="E4E8F2"/>
+                </a:solidFill>
+                <a:latin typeface="DM Sans" pitchFamily="34" charset="0"/>
+                <a:ea typeface="DM Sans" pitchFamily="34" charset="-122"/>
+                <a:cs typeface="DM Sans" pitchFamily="34" charset="-120"/>
+              </a:rPr>
+              <a:t>Testing and this report. Each of us can explain every module.</a:t>
+            </a:r>
+            <a:endParaRPr lang="en-US" sz="1400" dirty="0"/>
+          </a:p>
+        </p:txBody>
+      </p:sp>
+      <p:sp>
+        <p:nvSpPr>
+          <p:cNvPr id="14" name="Text 12"/>
+          <p:cNvSpPr/>
+          <p:nvPr/>
+        </p:nvSpPr>
+        <p:spPr>
+          <a:xfrm>
+            <a:off x="812800" y="6024879"/>
+            <a:ext cx="10464800" cy="452120"/>
+          </a:xfrm>
+          <a:prstGeom prst="rect">
+            <a:avLst/>
+          </a:prstGeom>
+          <a:noFill/>
+          <a:ln/>
+        </p:spPr>
+        <p:txBody>
+          <a:bodyPr wrap="square" lIns="0" tIns="0" rIns="0" bIns="0" rtlCol="0" anchor="t">
+            <a:normAutofit/>
+          </a:bodyPr>
+          <a:lstStyle/>
+          <a:p>
+            <a:pPr algn="l" indent="0" marL="0">
+              <a:lnSpc>
+                <a:spcPts val="1680"/>
+              </a:lnSpc>
+              <a:buNone/>
+            </a:pPr>
+            <a:r>
+              <a:rPr lang="en-US" sz="1200" dirty="0">
+                <a:solidFill>
+                  <a:srgbClr val="5CCFC0"/>
+                </a:solidFill>
+                <a:latin typeface="DM Sans" pitchFamily="34" charset="0"/>
+                <a:ea typeface="DM Sans" pitchFamily="34" charset="-122"/>
+                <a:cs typeface="DM Sans" pitchFamily="34" charset="-120"/>
+                <a:hlinkClick r:id="rId2"/>
+              </a:rPr>
+              <a:t>Code: github.com/HalcyonVector/Triageguard</a:t>
+            </a:r>
+            <a:endParaRPr lang="en-US" sz="1200" dirty="0"/>
+          </a:p>
+        </p:txBody>
       </p:sp>
     </p:spTree>
   </p:cSld>
@@ -5011,7 +5553,7 @@
         <p:spPr>
           <a:xfrm>
             <a:off x="812800" y="6238241"/>
-            <a:ext cx="9156700" cy="238760"/>
+            <a:ext cx="10883392" cy="238760"/>
           </a:xfrm>
           <a:prstGeom prst="rect">
             <a:avLst/>
@@ -5041,6 +5583,29 @@
                 <a:cs typeface="DM Sans" pitchFamily="34" charset="-120"/>
               </a:rPr>
               <a:t>Public datasets and synthetic keys only, no malware executed.</a:t>
+            </a:r>
+            <a:r>
+              <a:rPr lang="en-US" sz="1200" dirty="0">
+                <a:solidFill>
+                  <a:srgbClr val="8A94B0"/>
+                </a:solidFill>
+                <a:latin typeface="DM Sans" pitchFamily="34" charset="0"/>
+                <a:ea typeface="DM Sans" pitchFamily="34" charset="-122"/>
+                <a:cs typeface="DM Sans" pitchFamily="34" charset="-120"/>
+              </a:rPr>
+              <a:t>  Code: </a:t>
+            </a:r>
+            <a:r>
+              <a:rPr lang="en-US" sz="1200" dirty="0">
+                <a:solidFill>
+                  <a:srgbClr val="5CCFC0"/>
+                </a:solidFill>
+                <a:latin typeface="DM Sans" pitchFamily="34" charset="0"/>
+                <a:ea typeface="DM Sans" pitchFamily="34" charset="-122"/>
+                <a:cs typeface="DM Sans" pitchFamily="34" charset="-120"/>
+                <a:hlinkClick r:id="rId11"/>
+              </a:rPr>
+              <a:t>github.com/HalcyonVector/Triageguard</a:t>
             </a:r>
             <a:endParaRPr lang="en-US" sz="1200" dirty="0"/>
           </a:p>
@@ -6464,7 +7029,7 @@
         <p:spPr>
           <a:xfrm>
             <a:off x="7461219" y="2600961"/>
-            <a:ext cx="3802829" cy="1403350"/>
+            <a:ext cx="3802829" cy="1678940"/>
           </a:xfrm>
           <a:prstGeom prst="rect">
             <a:avLst/>
@@ -6582,6 +7147,27 @@
             </a:r>
             <a:endParaRPr lang="en-US" sz="1400" dirty="0"/>
           </a:p>
+          <a:p>
+            <a:pPr algn="l" marL="169418" indent="-169418">
+              <a:lnSpc>
+                <a:spcPts val="2170"/>
+              </a:lnSpc>
+              <a:buSzPct val="100000"/>
+              <a:buChar char="•"/>
+            </a:pPr>
+            <a:r>
+              <a:rPr lang="en-US" sz="1400" dirty="0">
+                <a:solidFill>
+                  <a:srgbClr val="E4E8F2"/>
+                </a:solidFill>
+                <a:latin typeface="DM Sans" pitchFamily="34" charset="0"/>
+                <a:ea typeface="DM Sans" pitchFamily="34" charset="-122"/>
+                <a:cs typeface="DM Sans" pitchFamily="34" charset="-120"/>
+              </a:rPr>
+              <a:t>Small factors (trial division)</a:t>
+            </a:r>
+            <a:endParaRPr lang="en-US" sz="1400" dirty="0"/>
+          </a:p>
         </p:txBody>
       </p:sp>
       <p:sp>
@@ -6592,7 +7178,7 @@
         </p:nvSpPr>
         <p:spPr>
           <a:xfrm>
-            <a:off x="7376637" y="4105911"/>
+            <a:off x="7376637" y="4381501"/>
             <a:ext cx="3895031" cy="274320"/>
           </a:xfrm>
           <a:prstGeom prst="rect">
@@ -6669,6 +7255,49 @@
               <a:t>Confidence per cipher is 1 minus the product of (1 - weight) over matched signatures. Random data gives zero hits.</a:t>
             </a:r>
             <a:endParaRPr lang="en-US" sz="1200" dirty="0"/>
+          </a:p>
+        </p:txBody>
+      </p:sp>
+      <p:sp>
+        <p:nvSpPr>
+          <p:cNvPr id="12" name="TextBox 11"/>
+          <p:cNvSpPr txBox="1"/>
+          <p:nvPr/>
+        </p:nvSpPr>
+        <p:spPr>
+          <a:xfrm>
+            <a:off x="7376637" y="4761501"/>
+            <a:ext cx="3895031" cy="560000"/>
+          </a:xfrm>
+          <a:prstGeom prst="rect">
+            <a:avLst/>
+          </a:prstGeom>
+          <a:noFill/>
+        </p:spPr>
+        <p:txBody>
+          <a:bodyPr wrap="square" lIns="0" rIns="0" tIns="0" bIns="0">
+            <a:spAutoFit/>
+          </a:bodyPr>
+          <a:lstStyle/>
+          <a:p>
+            <a:r>
+              <a:rPr sz="1400" b="1">
+                <a:solidFill>
+                  <a:srgbClr val="5CCFC0"/>
+                </a:solidFill>
+                <a:latin typeface="DM Sans"/>
+              </a:rPr>
+              <a:t>Planted-data test: </a:t>
+            </a:r>
+            <a:r>
+              <a:rPr sz="1400" b="0">
+                <a:solidFill>
+                  <a:srgbClr val="E4E8F2"/>
+                </a:solidFill>
+                <a:latin typeface="DM Sans"/>
+              </a:rPr>
+              <a:t>5/5 ciphers, 7/7 RSA keys, 4/4 credentials, 0 false hits.</a:t>
+            </a:r>
           </a:p>
         </p:txBody>
       </p:sp>

</xml_diff>